<commit_message>
chore(preview): TSLA outputs regeneres
</commit_message>
<xml_diff>
--- a/preview/TSLA/TSLA_pitchbook.pptx
+++ b/preview/TSLA/TSLA_pitchbook.pptx
@@ -3449,7 +3449,7 @@
                 </a:solidFill>
                 <a:latin typeface="Calibri"/>
               </a:rPr>
-              <a:t>● HOLD  ·  Prix cible base : — $  ·  Upside : —</a:t>
+              <a:t>● HOLD  ·  Prix cible base : 380 $  ·  Upside : +1,3 %</a:t>
             </a:r>
           </a:p>
         </p:txBody>
@@ -4421,7 +4421,7 @@
                           </a:solidFill>
                           <a:latin typeface="Calibri"/>
                         </a:rPr>
-                        <a:t>372,6x</a:t>
+                        <a:t>370,9x</a:t>
                       </a:r>
                     </a:p>
                   </a:txBody>
@@ -4595,7 +4595,7 @@
                           </a:solidFill>
                           <a:latin typeface="Calibri"/>
                         </a:rPr>
-                        <a:t>119,5x</a:t>
+                        <a:t>118,9x</a:t>
                       </a:r>
                     </a:p>
                   </a:txBody>
@@ -5813,7 +5813,7 @@
                           </a:solidFill>
                           <a:latin typeface="Calibri"/>
                         </a:rPr>
-                        <a:t>16,85</a:t>
+                        <a:t>16,78</a:t>
                       </a:r>
                     </a:p>
                   </a:txBody>
@@ -6108,6 +6108,41 @@
           </a:graphicData>
         </a:graphic>
       </p:graphicFrame>
+      <p:sp>
+        <p:nvSpPr>
+          <p:cNvPr id="18" name="TextBox 17"/>
+          <p:cNvSpPr txBox="1"/>
+          <p:nvPr/>
+        </p:nvSpPr>
+        <p:spPr>
+          <a:xfrm>
+            <a:off x="367200" y="3628800"/>
+            <a:ext cx="8413200" cy="824400"/>
+          </a:xfrm>
+          <a:prstGeom prst="rect">
+            <a:avLst/>
+          </a:prstGeom>
+          <a:noFill/>
+        </p:spPr>
+        <p:txBody>
+          <a:bodyPr wrap="square">
+            <a:spAutoFit/>
+          </a:bodyPr>
+          <a:lstStyle/>
+          <a:p>
+            <a:pPr algn="l"/>
+            <a:r>
+              <a:rPr sz="850" b="0" i="0">
+                <a:solidFill>
+                  <a:srgbClr val="555555"/>
+                </a:solidFill>
+                <a:latin typeface="Calibri"/>
+              </a:rPr>
+              <a:t>Les marges brutes passent de 25.6% en 2022 à 18.0% en 2025, reflétant une guerre des prix et une hausse des coûts fixes. L'EBITDA margin chute de 21.7% à 12.4% sur la même période, impactée par les investissements R&amp;D et la baisse des volumes. La durabilité de ces niveaux dépend de la capacité à répercuter les coûts et à améliorer l'efficacité industrielle.</a:t>
+            </a:r>
+          </a:p>
+        </p:txBody>
+      </p:sp>
     </p:spTree>
   </p:cSld>
   <p:clrMapOvr>
@@ -7092,7 +7127,7 @@
                           </a:solidFill>
                           <a:latin typeface="Calibri"/>
                         </a:rPr>
-                        <a:t>14,9 %</a:t>
+                        <a:t>14,8 %</a:t>
                       </a:r>
                     </a:p>
                   </a:txBody>
@@ -7268,7 +7303,7 @@
                           </a:solidFill>
                           <a:latin typeface="Calibri"/>
                         </a:rPr>
-                        <a:t>—</a:t>
+                        <a:t>380 $</a:t>
                       </a:r>
                     </a:p>
                   </a:txBody>
@@ -7356,7 +7391,7 @@
                           </a:solidFill>
                           <a:latin typeface="Calibri"/>
                         </a:rPr>
-                        <a:t>376,71 $</a:t>
+                        <a:t>375,03 $</a:t>
                       </a:r>
                     </a:p>
                   </a:txBody>
@@ -7444,7 +7479,7 @@
                           </a:solidFill>
                           <a:latin typeface="Calibri"/>
                         </a:rPr>
-                        <a:t>—</a:t>
+                        <a:t>+1,3 %</a:t>
                       </a:r>
                     </a:p>
                   </a:txBody>
@@ -7587,7 +7622,7 @@
                           </a:solidFill>
                           <a:latin typeface="Calibri"/>
                         </a:rPr>
-                        <a:t>—</a:t>
+                        <a:t>300 $</a:t>
                       </a:r>
                     </a:p>
                   </a:txBody>
@@ -7610,7 +7645,7 @@
                           </a:solidFill>
                           <a:latin typeface="Calibri"/>
                         </a:rPr>
-                        <a:t>—</a:t>
+                        <a:t>380 $</a:t>
                       </a:r>
                     </a:p>
                   </a:txBody>
@@ -7633,7 +7668,7 @@
                           </a:solidFill>
                           <a:latin typeface="Calibri"/>
                         </a:rPr>
-                        <a:t>—</a:t>
+                        <a:t>450 $</a:t>
                       </a:r>
                     </a:p>
                   </a:txBody>
@@ -7658,7 +7693,7 @@
                           </a:solidFill>
                           <a:latin typeface="Calibri"/>
                         </a:rPr>
-                        <a:t>—</a:t>
+                        <a:t>-20,0 %</a:t>
                       </a:r>
                     </a:p>
                   </a:txBody>
@@ -7681,7 +7716,7 @@
                           </a:solidFill>
                           <a:latin typeface="Calibri"/>
                         </a:rPr>
-                        <a:t>—</a:t>
+                        <a:t>+1,3 %</a:t>
                       </a:r>
                     </a:p>
                   </a:txBody>
@@ -7704,7 +7739,7 @@
                           </a:solidFill>
                           <a:latin typeface="Calibri"/>
                         </a:rPr>
-                        <a:t>—</a:t>
+                        <a:t>+20,0 %</a:t>
                       </a:r>
                     </a:p>
                   </a:txBody>
@@ -8125,7 +8160,7 @@
                           </a:solidFill>
                           <a:latin typeface="Calibri"/>
                         </a:rPr>
-                        <a:t>12,9%</a:t>
+                        <a:t>12,8%</a:t>
                       </a:r>
                     </a:p>
                   </a:txBody>
@@ -8168,7 +8203,7 @@
                           </a:solidFill>
                           <a:latin typeface="Calibri"/>
                         </a:rPr>
-                        <a:t>—</a:t>
+                        <a:t>413</a:t>
                       </a:r>
                     </a:p>
                   </a:txBody>
@@ -8211,7 +8246,7 @@
                           </a:solidFill>
                           <a:latin typeface="Calibri"/>
                         </a:rPr>
-                        <a:t>—</a:t>
+                        <a:t>433</a:t>
                       </a:r>
                     </a:p>
                   </a:txBody>
@@ -8254,7 +8289,7 @@
                           </a:solidFill>
                           <a:latin typeface="Calibri"/>
                         </a:rPr>
-                        <a:t>—</a:t>
+                        <a:t>453</a:t>
                       </a:r>
                     </a:p>
                   </a:txBody>
@@ -8297,7 +8332,7 @@
                           </a:solidFill>
                           <a:latin typeface="Calibri"/>
                         </a:rPr>
-                        <a:t>—</a:t>
+                        <a:t>476</a:t>
                       </a:r>
                     </a:p>
                   </a:txBody>
@@ -8340,7 +8375,7 @@
                           </a:solidFill>
                           <a:latin typeface="Calibri"/>
                         </a:rPr>
-                        <a:t>—</a:t>
+                        <a:t>502</a:t>
                       </a:r>
                     </a:p>
                   </a:txBody>
@@ -8385,7 +8420,7 @@
                           </a:solidFill>
                           <a:latin typeface="Calibri"/>
                         </a:rPr>
-                        <a:t>13,9%</a:t>
+                        <a:t>13,8%</a:t>
                       </a:r>
                     </a:p>
                   </a:txBody>
@@ -8428,7 +8463,7 @@
                           </a:solidFill>
                           <a:latin typeface="Calibri"/>
                         </a:rPr>
-                        <a:t>—</a:t>
+                        <a:t>380</a:t>
                       </a:r>
                     </a:p>
                   </a:txBody>
@@ -8471,7 +8506,7 @@
                           </a:solidFill>
                           <a:latin typeface="Calibri"/>
                         </a:rPr>
-                        <a:t>—</a:t>
+                        <a:t>396</a:t>
                       </a:r>
                     </a:p>
                   </a:txBody>
@@ -8514,7 +8549,7 @@
                           </a:solidFill>
                           <a:latin typeface="Calibri"/>
                         </a:rPr>
-                        <a:t>—</a:t>
+                        <a:t>413</a:t>
                       </a:r>
                     </a:p>
                   </a:txBody>
@@ -8557,7 +8592,7 @@
                           </a:solidFill>
                           <a:latin typeface="Calibri"/>
                         </a:rPr>
-                        <a:t>—</a:t>
+                        <a:t>433</a:t>
                       </a:r>
                     </a:p>
                   </a:txBody>
@@ -8600,7 +8635,7 @@
                           </a:solidFill>
                           <a:latin typeface="Calibri"/>
                         </a:rPr>
-                        <a:t>—</a:t>
+                        <a:t>453</a:t>
                       </a:r>
                     </a:p>
                   </a:txBody>
@@ -8645,7 +8680,7 @@
                           </a:solidFill>
                           <a:latin typeface="Calibri"/>
                         </a:rPr>
-                        <a:t>14,9%</a:t>
+                        <a:t>14,8%</a:t>
                       </a:r>
                     </a:p>
                   </a:txBody>
@@ -8688,7 +8723,7 @@
                           </a:solidFill>
                           <a:latin typeface="Calibri"/>
                         </a:rPr>
-                        <a:t>—</a:t>
+                        <a:t>352</a:t>
                       </a:r>
                     </a:p>
                   </a:txBody>
@@ -8731,7 +8766,7 @@
                           </a:solidFill>
                           <a:latin typeface="Calibri"/>
                         </a:rPr>
-                        <a:t>—</a:t>
+                        <a:t>365</a:t>
                       </a:r>
                     </a:p>
                   </a:txBody>
@@ -8774,7 +8809,7 @@
                           </a:solidFill>
                           <a:latin typeface="Calibri"/>
                         </a:rPr>
-                        <a:t>—</a:t>
+                        <a:t>380</a:t>
                       </a:r>
                     </a:p>
                   </a:txBody>
@@ -8817,7 +8852,7 @@
                           </a:solidFill>
                           <a:latin typeface="Calibri"/>
                         </a:rPr>
-                        <a:t>—</a:t>
+                        <a:t>396</a:t>
                       </a:r>
                     </a:p>
                   </a:txBody>
@@ -8860,7 +8895,7 @@
                           </a:solidFill>
                           <a:latin typeface="Calibri"/>
                         </a:rPr>
-                        <a:t>—</a:t>
+                        <a:t>413</a:t>
                       </a:r>
                     </a:p>
                   </a:txBody>
@@ -8905,7 +8940,7 @@
                           </a:solidFill>
                           <a:latin typeface="Calibri"/>
                         </a:rPr>
-                        <a:t>15,9%</a:t>
+                        <a:t>15,8%</a:t>
                       </a:r>
                     </a:p>
                   </a:txBody>
@@ -8948,7 +8983,7 @@
                           </a:solidFill>
                           <a:latin typeface="Calibri"/>
                         </a:rPr>
-                        <a:t>—</a:t>
+                        <a:t>327</a:t>
                       </a:r>
                     </a:p>
                   </a:txBody>
@@ -8991,7 +9026,7 @@
                           </a:solidFill>
                           <a:latin typeface="Calibri"/>
                         </a:rPr>
-                        <a:t>—</a:t>
+                        <a:t>339</a:t>
                       </a:r>
                     </a:p>
                   </a:txBody>
@@ -9034,7 +9069,7 @@
                           </a:solidFill>
                           <a:latin typeface="Calibri"/>
                         </a:rPr>
-                        <a:t>—</a:t>
+                        <a:t>352</a:t>
                       </a:r>
                     </a:p>
                   </a:txBody>
@@ -9077,7 +9112,7 @@
                           </a:solidFill>
                           <a:latin typeface="Calibri"/>
                         </a:rPr>
-                        <a:t>—</a:t>
+                        <a:t>365</a:t>
                       </a:r>
                     </a:p>
                   </a:txBody>
@@ -9120,7 +9155,7 @@
                           </a:solidFill>
                           <a:latin typeface="Calibri"/>
                         </a:rPr>
-                        <a:t>—</a:t>
+                        <a:t>380</a:t>
                       </a:r>
                     </a:p>
                   </a:txBody>
@@ -9165,7 +9200,7 @@
                           </a:solidFill>
                           <a:latin typeface="Calibri"/>
                         </a:rPr>
-                        <a:t>16,9%</a:t>
+                        <a:t>16,8%</a:t>
                       </a:r>
                     </a:p>
                   </a:txBody>
@@ -9208,7 +9243,7 @@
                           </a:solidFill>
                           <a:latin typeface="Calibri"/>
                         </a:rPr>
-                        <a:t>—</a:t>
+                        <a:t>306</a:t>
                       </a:r>
                     </a:p>
                   </a:txBody>
@@ -9251,7 +9286,7 @@
                           </a:solidFill>
                           <a:latin typeface="Calibri"/>
                         </a:rPr>
-                        <a:t>—</a:t>
+                        <a:t>316</a:t>
                       </a:r>
                     </a:p>
                   </a:txBody>
@@ -9294,7 +9329,7 @@
                           </a:solidFill>
                           <a:latin typeface="Calibri"/>
                         </a:rPr>
-                        <a:t>—</a:t>
+                        <a:t>327</a:t>
                       </a:r>
                     </a:p>
                   </a:txBody>
@@ -9337,7 +9372,7 @@
                           </a:solidFill>
                           <a:latin typeface="Calibri"/>
                         </a:rPr>
-                        <a:t>—</a:t>
+                        <a:t>339</a:t>
                       </a:r>
                     </a:p>
                   </a:txBody>
@@ -9380,7 +9415,7 @@
                           </a:solidFill>
                           <a:latin typeface="Calibri"/>
                         </a:rPr>
-                        <a:t>—</a:t>
+                        <a:t>352</a:t>
                       </a:r>
                     </a:p>
                   </a:txBody>
@@ -9415,6 +9450,41 @@
           </a:graphicData>
         </a:graphic>
       </p:graphicFrame>
+      <p:sp>
+        <p:nvSpPr>
+          <p:cNvPr id="20" name="TextBox 19"/>
+          <p:cNvSpPr txBox="1"/>
+          <p:nvPr/>
+        </p:nvSpPr>
+        <p:spPr>
+          <a:xfrm>
+            <a:off x="367200" y="3916800"/>
+            <a:ext cx="8413200" cy="547200"/>
+          </a:xfrm>
+          <a:prstGeom prst="rect">
+            <a:avLst/>
+          </a:prstGeom>
+          <a:noFill/>
+        </p:spPr>
+        <p:txBody>
+          <a:bodyPr wrap="square">
+            <a:spAutoFit/>
+          </a:bodyPr>
+          <a:lstStyle/>
+          <a:p>
+            <a:pPr algn="l"/>
+            <a:r>
+              <a:rPr sz="850" b="0" i="0">
+                <a:solidFill>
+                  <a:srgbClr val="555555"/>
+                </a:solidFill>
+                <a:latin typeface="Calibri"/>
+              </a:rPr>
+              <a:t>Avec un WACC de 14.8% et un TGR de 2.5%, le prix implicite DCF est de 380$ (base), soit proche du cours actuel. La prime de valorisation actuelle semble justifiée par une croissance future, mais un échec sur la marge ou le volume pourrait entraîner une compression significative.</a:t>
+            </a:r>
+          </a:p>
+        </p:txBody>
+      </p:sp>
     </p:spTree>
   </p:cSld>
   <p:clrMapOvr>
@@ -10024,7 +10094,7 @@
         </p:nvGraphicFramePr>
         <p:xfrm>
           <a:off x="367200" y="914400"/>
-          <a:ext cx="8413200" cy="871200"/>
+          <a:ext cx="8413200" cy="2015999"/>
         </p:xfrm>
         <a:graphic>
           <a:graphicData uri="http://schemas.openxmlformats.org/drawingml/2006/table">
@@ -10042,7 +10112,7 @@
                 <a:gridCol w="1093716"/>
                 <a:gridCol w="1009584"/>
               </a:tblGrid>
-              <a:tr h="290400">
+              <a:tr h="251999">
                 <a:tc>
                   <a:txBody>
                     <a:bodyPr/>
@@ -10228,7 +10298,7 @@
                   </a:tcPr>
                 </a:tc>
               </a:tr>
-              <a:tr h="290400">
+              <a:tr h="251999">
                 <a:tc>
                   <a:txBody>
                     <a:bodyPr/>
@@ -10288,7 +10358,7 @@
                           </a:solidFill>
                           <a:latin typeface="Calibri"/>
                         </a:rPr>
-                        <a:t>1 413,6</a:t>
+                        <a:t>1 407,3</a:t>
                       </a:r>
                     </a:p>
                   </a:txBody>
@@ -10311,7 +10381,7 @@
                           </a:solidFill>
                           <a:latin typeface="Calibri"/>
                         </a:rPr>
-                        <a:t>119,5x</a:t>
+                        <a:t>118,9x</a:t>
                       </a:r>
                     </a:p>
                   </a:txBody>
@@ -10357,7 +10427,7 @@
                           </a:solidFill>
                           <a:latin typeface="Calibri"/>
                         </a:rPr>
-                        <a:t>372,6x</a:t>
+                        <a:t>370,9x</a:t>
                       </a:r>
                     </a:p>
                   </a:txBody>
@@ -10414,7 +10484,7 @@
                   </a:tcPr>
                 </a:tc>
               </a:tr>
-              <a:tr h="290400">
+              <a:tr h="251999">
                 <a:tc>
                   <a:txBody>
                     <a:bodyPr/>
@@ -10422,6 +10492,936 @@
                     <a:p>
                       <a:pPr algn="l"/>
                       <a:r>
+                        <a:rPr sz="800" b="0" i="0">
+                          <a:solidFill>
+                            <a:srgbClr val="0D0D0D"/>
+                          </a:solidFill>
+                          <a:latin typeface="Calibri"/>
+                        </a:rPr>
+                        <a:t>BYD Company Limited</a:t>
+                      </a:r>
+                    </a:p>
+                  </a:txBody>
+                  <a:tcPr>
+                    <a:solidFill>
+                      <a:srgbClr val="FFFFFF"/>
+                    </a:solidFill>
+                  </a:tcPr>
+                </a:tc>
+                <a:tc>
+                  <a:txBody>
+                    <a:bodyPr/>
+                    <a:lstStyle/>
+                    <a:p>
+                      <a:pPr algn="ctr"/>
+                      <a:r>
+                        <a:rPr sz="750" b="0" i="0">
+                          <a:solidFill>
+                            <a:srgbClr val="555555"/>
+                          </a:solidFill>
+                          <a:latin typeface="Calibri"/>
+                        </a:rPr>
+                        <a:t>BYD</a:t>
+                      </a:r>
+                    </a:p>
+                  </a:txBody>
+                  <a:tcPr>
+                    <a:solidFill>
+                      <a:srgbClr val="FFFFFF"/>
+                    </a:solidFill>
+                  </a:tcPr>
+                </a:tc>
+                <a:tc>
+                  <a:txBody>
+                    <a:bodyPr/>
+                    <a:lstStyle/>
+                    <a:p>
+                      <a:pPr algn="ctr"/>
+                      <a:r>
+                        <a:rPr sz="800" b="0" i="0">
+                          <a:solidFill>
+                            <a:srgbClr val="0D0D0D"/>
+                          </a:solidFill>
+                          <a:latin typeface="Calibri"/>
+                        </a:rPr>
+                        <a:t>85,0</a:t>
+                      </a:r>
+                    </a:p>
+                  </a:txBody>
+                  <a:tcPr>
+                    <a:solidFill>
+                      <a:srgbClr val="FFFFFF"/>
+                    </a:solidFill>
+                  </a:tcPr>
+                </a:tc>
+                <a:tc>
+                  <a:txBody>
+                    <a:bodyPr/>
+                    <a:lstStyle/>
+                    <a:p>
+                      <a:pPr algn="ctr"/>
+                      <a:r>
+                        <a:rPr sz="800" b="0" i="0">
+                          <a:solidFill>
+                            <a:srgbClr val="0D0D0D"/>
+                          </a:solidFill>
+                          <a:latin typeface="Calibri"/>
+                        </a:rPr>
+                        <a:t>12,5x</a:t>
+                      </a:r>
+                    </a:p>
+                  </a:txBody>
+                  <a:tcPr>
+                    <a:solidFill>
+                      <a:srgbClr val="FFFFFF"/>
+                    </a:solidFill>
+                  </a:tcPr>
+                </a:tc>
+                <a:tc>
+                  <a:txBody>
+                    <a:bodyPr/>
+                    <a:lstStyle/>
+                    <a:p>
+                      <a:pPr algn="ctr"/>
+                      <a:r>
+                        <a:rPr sz="800" b="0" i="0">
+                          <a:solidFill>
+                            <a:srgbClr val="0D0D0D"/>
+                          </a:solidFill>
+                          <a:latin typeface="Calibri"/>
+                        </a:rPr>
+                        <a:t>2,8x</a:t>
+                      </a:r>
+                    </a:p>
+                  </a:txBody>
+                  <a:tcPr>
+                    <a:solidFill>
+                      <a:srgbClr val="FFFFFF"/>
+                    </a:solidFill>
+                  </a:tcPr>
+                </a:tc>
+                <a:tc>
+                  <a:txBody>
+                    <a:bodyPr/>
+                    <a:lstStyle/>
+                    <a:p>
+                      <a:pPr algn="ctr"/>
+                      <a:r>
+                        <a:rPr sz="800" b="0" i="0">
+                          <a:solidFill>
+                            <a:srgbClr val="0D0D0D"/>
+                          </a:solidFill>
+                          <a:latin typeface="Calibri"/>
+                        </a:rPr>
+                        <a:t>25,0x</a:t>
+                      </a:r>
+                    </a:p>
+                  </a:txBody>
+                  <a:tcPr>
+                    <a:solidFill>
+                      <a:srgbClr val="FFFFFF"/>
+                    </a:solidFill>
+                  </a:tcPr>
+                </a:tc>
+                <a:tc>
+                  <a:txBody>
+                    <a:bodyPr/>
+                    <a:lstStyle/>
+                    <a:p>
+                      <a:pPr algn="ctr"/>
+                      <a:r>
+                        <a:rPr sz="800" b="0" i="0">
+                          <a:solidFill>
+                            <a:srgbClr val="0D0D0D"/>
+                          </a:solidFill>
+                          <a:latin typeface="Calibri"/>
+                        </a:rPr>
+                        <a:t>18,0 %</a:t>
+                      </a:r>
+                    </a:p>
+                  </a:txBody>
+                  <a:tcPr>
+                    <a:solidFill>
+                      <a:srgbClr val="FFFFFF"/>
+                    </a:solidFill>
+                  </a:tcPr>
+                </a:tc>
+                <a:tc>
+                  <a:txBody>
+                    <a:bodyPr/>
+                    <a:lstStyle/>
+                    <a:p>
+                      <a:pPr algn="ctr"/>
+                      <a:r>
+                        <a:rPr sz="800" b="0" i="0">
+                          <a:solidFill>
+                            <a:srgbClr val="0D0D0D"/>
+                          </a:solidFill>
+                          <a:latin typeface="Calibri"/>
+                        </a:rPr>
+                        <a:t>12,0 %</a:t>
+                      </a:r>
+                    </a:p>
+                  </a:txBody>
+                  <a:tcPr>
+                    <a:solidFill>
+                      <a:srgbClr val="FFFFFF"/>
+                    </a:solidFill>
+                  </a:tcPr>
+                </a:tc>
+              </a:tr>
+              <a:tr h="251999">
+                <a:tc>
+                  <a:txBody>
+                    <a:bodyPr/>
+                    <a:lstStyle/>
+                    <a:p>
+                      <a:pPr algn="l"/>
+                      <a:r>
+                        <a:rPr sz="800" b="0" i="0">
+                          <a:solidFill>
+                            <a:srgbClr val="0D0D0D"/>
+                          </a:solidFill>
+                          <a:latin typeface="Calibri"/>
+                        </a:rPr>
+                        <a:t>NIO Inc.</a:t>
+                      </a:r>
+                    </a:p>
+                  </a:txBody>
+                  <a:tcPr>
+                    <a:solidFill>
+                      <a:srgbClr val="F7F8FA"/>
+                    </a:solidFill>
+                  </a:tcPr>
+                </a:tc>
+                <a:tc>
+                  <a:txBody>
+                    <a:bodyPr/>
+                    <a:lstStyle/>
+                    <a:p>
+                      <a:pPr algn="ctr"/>
+                      <a:r>
+                        <a:rPr sz="750" b="0" i="0">
+                          <a:solidFill>
+                            <a:srgbClr val="555555"/>
+                          </a:solidFill>
+                          <a:latin typeface="Calibri"/>
+                        </a:rPr>
+                        <a:t>NIO</a:t>
+                      </a:r>
+                    </a:p>
+                  </a:txBody>
+                  <a:tcPr>
+                    <a:solidFill>
+                      <a:srgbClr val="F7F8FA"/>
+                    </a:solidFill>
+                  </a:tcPr>
+                </a:tc>
+                <a:tc>
+                  <a:txBody>
+                    <a:bodyPr/>
+                    <a:lstStyle/>
+                    <a:p>
+                      <a:pPr algn="ctr"/>
+                      <a:r>
+                        <a:rPr sz="800" b="0" i="0">
+                          <a:solidFill>
+                            <a:srgbClr val="0D0D0D"/>
+                          </a:solidFill>
+                          <a:latin typeface="Calibri"/>
+                        </a:rPr>
+                        <a:t>15,0</a:t>
+                      </a:r>
+                    </a:p>
+                  </a:txBody>
+                  <a:tcPr>
+                    <a:solidFill>
+                      <a:srgbClr val="F7F8FA"/>
+                    </a:solidFill>
+                  </a:tcPr>
+                </a:tc>
+                <a:tc>
+                  <a:txBody>
+                    <a:bodyPr/>
+                    <a:lstStyle/>
+                    <a:p>
+                      <a:pPr algn="ctr"/>
+                      <a:r>
+                        <a:rPr sz="800" b="0" i="0">
+                          <a:solidFill>
+                            <a:srgbClr val="0D0D0D"/>
+                          </a:solidFill>
+                          <a:latin typeface="Calibri"/>
+                        </a:rPr>
+                        <a:t>-15,0x</a:t>
+                      </a:r>
+                    </a:p>
+                  </a:txBody>
+                  <a:tcPr>
+                    <a:solidFill>
+                      <a:srgbClr val="F7F8FA"/>
+                    </a:solidFill>
+                  </a:tcPr>
+                </a:tc>
+                <a:tc>
+                  <a:txBody>
+                    <a:bodyPr/>
+                    <a:lstStyle/>
+                    <a:p>
+                      <a:pPr algn="ctr"/>
+                      <a:r>
+                        <a:rPr sz="800" b="0" i="0">
+                          <a:solidFill>
+                            <a:srgbClr val="0D0D0D"/>
+                          </a:solidFill>
+                          <a:latin typeface="Calibri"/>
+                        </a:rPr>
+                        <a:t>1,5x</a:t>
+                      </a:r>
+                    </a:p>
+                  </a:txBody>
+                  <a:tcPr>
+                    <a:solidFill>
+                      <a:srgbClr val="F7F8FA"/>
+                    </a:solidFill>
+                  </a:tcPr>
+                </a:tc>
+                <a:tc>
+                  <a:txBody>
+                    <a:bodyPr/>
+                    <a:lstStyle/>
+                    <a:p>
+                      <a:pPr algn="ctr"/>
+                      <a:r>
+                        <a:rPr sz="800" b="0" i="0">
+                          <a:solidFill>
+                            <a:srgbClr val="0D0D0D"/>
+                          </a:solidFill>
+                          <a:latin typeface="Calibri"/>
+                        </a:rPr>
+                        <a:t>-10,0x</a:t>
+                      </a:r>
+                    </a:p>
+                  </a:txBody>
+                  <a:tcPr>
+                    <a:solidFill>
+                      <a:srgbClr val="F7F8FA"/>
+                    </a:solidFill>
+                  </a:tcPr>
+                </a:tc>
+                <a:tc>
+                  <a:txBody>
+                    <a:bodyPr/>
+                    <a:lstStyle/>
+                    <a:p>
+                      <a:pPr algn="ctr"/>
+                      <a:r>
+                        <a:rPr sz="800" b="0" i="0">
+                          <a:solidFill>
+                            <a:srgbClr val="0D0D0D"/>
+                          </a:solidFill>
+                          <a:latin typeface="Calibri"/>
+                        </a:rPr>
+                        <a:t>12,0 %</a:t>
+                      </a:r>
+                    </a:p>
+                  </a:txBody>
+                  <a:tcPr>
+                    <a:solidFill>
+                      <a:srgbClr val="F7F8FA"/>
+                    </a:solidFill>
+                  </a:tcPr>
+                </a:tc>
+                <a:tc>
+                  <a:txBody>
+                    <a:bodyPr/>
+                    <a:lstStyle/>
+                    <a:p>
+                      <a:pPr algn="ctr"/>
+                      <a:r>
+                        <a:rPr sz="800" b="0" i="0">
+                          <a:solidFill>
+                            <a:srgbClr val="0D0D0D"/>
+                          </a:solidFill>
+                          <a:latin typeface="Calibri"/>
+                        </a:rPr>
+                        <a:t>-5,0 %</a:t>
+                      </a:r>
+                    </a:p>
+                  </a:txBody>
+                  <a:tcPr>
+                    <a:solidFill>
+                      <a:srgbClr val="F7F8FA"/>
+                    </a:solidFill>
+                  </a:tcPr>
+                </a:tc>
+              </a:tr>
+              <a:tr h="251999">
+                <a:tc>
+                  <a:txBody>
+                    <a:bodyPr/>
+                    <a:lstStyle/>
+                    <a:p>
+                      <a:pPr algn="l"/>
+                      <a:r>
+                        <a:rPr sz="800" b="0" i="0">
+                          <a:solidFill>
+                            <a:srgbClr val="0D0D0D"/>
+                          </a:solidFill>
+                          <a:latin typeface="Calibri"/>
+                        </a:rPr>
+                        <a:t>XPeng Inc.</a:t>
+                      </a:r>
+                    </a:p>
+                  </a:txBody>
+                  <a:tcPr>
+                    <a:solidFill>
+                      <a:srgbClr val="FFFFFF"/>
+                    </a:solidFill>
+                  </a:tcPr>
+                </a:tc>
+                <a:tc>
+                  <a:txBody>
+                    <a:bodyPr/>
+                    <a:lstStyle/>
+                    <a:p>
+                      <a:pPr algn="ctr"/>
+                      <a:r>
+                        <a:rPr sz="750" b="0" i="0">
+                          <a:solidFill>
+                            <a:srgbClr val="555555"/>
+                          </a:solidFill>
+                          <a:latin typeface="Calibri"/>
+                        </a:rPr>
+                        <a:t>XPEV</a:t>
+                      </a:r>
+                    </a:p>
+                  </a:txBody>
+                  <a:tcPr>
+                    <a:solidFill>
+                      <a:srgbClr val="FFFFFF"/>
+                    </a:solidFill>
+                  </a:tcPr>
+                </a:tc>
+                <a:tc>
+                  <a:txBody>
+                    <a:bodyPr/>
+                    <a:lstStyle/>
+                    <a:p>
+                      <a:pPr algn="ctr"/>
+                      <a:r>
+                        <a:rPr sz="800" b="0" i="0">
+                          <a:solidFill>
+                            <a:srgbClr val="0D0D0D"/>
+                          </a:solidFill>
+                          <a:latin typeface="Calibri"/>
+                        </a:rPr>
+                        <a:t>10,0</a:t>
+                      </a:r>
+                    </a:p>
+                  </a:txBody>
+                  <a:tcPr>
+                    <a:solidFill>
+                      <a:srgbClr val="FFFFFF"/>
+                    </a:solidFill>
+                  </a:tcPr>
+                </a:tc>
+                <a:tc>
+                  <a:txBody>
+                    <a:bodyPr/>
+                    <a:lstStyle/>
+                    <a:p>
+                      <a:pPr algn="ctr"/>
+                      <a:r>
+                        <a:rPr sz="800" b="0" i="0">
+                          <a:solidFill>
+                            <a:srgbClr val="0D0D0D"/>
+                          </a:solidFill>
+                          <a:latin typeface="Calibri"/>
+                        </a:rPr>
+                        <a:t>-8,0x</a:t>
+                      </a:r>
+                    </a:p>
+                  </a:txBody>
+                  <a:tcPr>
+                    <a:solidFill>
+                      <a:srgbClr val="FFFFFF"/>
+                    </a:solidFill>
+                  </a:tcPr>
+                </a:tc>
+                <a:tc>
+                  <a:txBody>
+                    <a:bodyPr/>
+                    <a:lstStyle/>
+                    <a:p>
+                      <a:pPr algn="ctr"/>
+                      <a:r>
+                        <a:rPr sz="800" b="0" i="0">
+                          <a:solidFill>
+                            <a:srgbClr val="0D0D0D"/>
+                          </a:solidFill>
+                          <a:latin typeface="Calibri"/>
+                        </a:rPr>
+                        <a:t>1,2x</a:t>
+                      </a:r>
+                    </a:p>
+                  </a:txBody>
+                  <a:tcPr>
+                    <a:solidFill>
+                      <a:srgbClr val="FFFFFF"/>
+                    </a:solidFill>
+                  </a:tcPr>
+                </a:tc>
+                <a:tc>
+                  <a:txBody>
+                    <a:bodyPr/>
+                    <a:lstStyle/>
+                    <a:p>
+                      <a:pPr algn="ctr"/>
+                      <a:r>
+                        <a:rPr sz="800" b="0" i="0">
+                          <a:solidFill>
+                            <a:srgbClr val="0D0D0D"/>
+                          </a:solidFill>
+                          <a:latin typeface="Calibri"/>
+                        </a:rPr>
+                        <a:t>-12,0x</a:t>
+                      </a:r>
+                    </a:p>
+                  </a:txBody>
+                  <a:tcPr>
+                    <a:solidFill>
+                      <a:srgbClr val="FFFFFF"/>
+                    </a:solidFill>
+                  </a:tcPr>
+                </a:tc>
+                <a:tc>
+                  <a:txBody>
+                    <a:bodyPr/>
+                    <a:lstStyle/>
+                    <a:p>
+                      <a:pPr algn="ctr"/>
+                      <a:r>
+                        <a:rPr sz="800" b="0" i="0">
+                          <a:solidFill>
+                            <a:srgbClr val="0D0D0D"/>
+                          </a:solidFill>
+                          <a:latin typeface="Calibri"/>
+                        </a:rPr>
+                        <a:t>10,0 %</a:t>
+                      </a:r>
+                    </a:p>
+                  </a:txBody>
+                  <a:tcPr>
+                    <a:solidFill>
+                      <a:srgbClr val="FFFFFF"/>
+                    </a:solidFill>
+                  </a:tcPr>
+                </a:tc>
+                <a:tc>
+                  <a:txBody>
+                    <a:bodyPr/>
+                    <a:lstStyle/>
+                    <a:p>
+                      <a:pPr algn="ctr"/>
+                      <a:r>
+                        <a:rPr sz="800" b="0" i="0">
+                          <a:solidFill>
+                            <a:srgbClr val="0D0D0D"/>
+                          </a:solidFill>
+                          <a:latin typeface="Calibri"/>
+                        </a:rPr>
+                        <a:t>-8,0 %</a:t>
+                      </a:r>
+                    </a:p>
+                  </a:txBody>
+                  <a:tcPr>
+                    <a:solidFill>
+                      <a:srgbClr val="FFFFFF"/>
+                    </a:solidFill>
+                  </a:tcPr>
+                </a:tc>
+              </a:tr>
+              <a:tr h="251999">
+                <a:tc>
+                  <a:txBody>
+                    <a:bodyPr/>
+                    <a:lstStyle/>
+                    <a:p>
+                      <a:pPr algn="l"/>
+                      <a:r>
+                        <a:rPr sz="800" b="0" i="0">
+                          <a:solidFill>
+                            <a:srgbClr val="0D0D0D"/>
+                          </a:solidFill>
+                          <a:latin typeface="Calibri"/>
+                        </a:rPr>
+                        <a:t>Li Auto Inc.</a:t>
+                      </a:r>
+                    </a:p>
+                  </a:txBody>
+                  <a:tcPr>
+                    <a:solidFill>
+                      <a:srgbClr val="F7F8FA"/>
+                    </a:solidFill>
+                  </a:tcPr>
+                </a:tc>
+                <a:tc>
+                  <a:txBody>
+                    <a:bodyPr/>
+                    <a:lstStyle/>
+                    <a:p>
+                      <a:pPr algn="ctr"/>
+                      <a:r>
+                        <a:rPr sz="750" b="0" i="0">
+                          <a:solidFill>
+                            <a:srgbClr val="555555"/>
+                          </a:solidFill>
+                          <a:latin typeface="Calibri"/>
+                        </a:rPr>
+                        <a:t>LI</a:t>
+                      </a:r>
+                    </a:p>
+                  </a:txBody>
+                  <a:tcPr>
+                    <a:solidFill>
+                      <a:srgbClr val="F7F8FA"/>
+                    </a:solidFill>
+                  </a:tcPr>
+                </a:tc>
+                <a:tc>
+                  <a:txBody>
+                    <a:bodyPr/>
+                    <a:lstStyle/>
+                    <a:p>
+                      <a:pPr algn="ctr"/>
+                      <a:r>
+                        <a:rPr sz="800" b="0" i="0">
+                          <a:solidFill>
+                            <a:srgbClr val="0D0D0D"/>
+                          </a:solidFill>
+                          <a:latin typeface="Calibri"/>
+                        </a:rPr>
+                        <a:t>25,0</a:t>
+                      </a:r>
+                    </a:p>
+                  </a:txBody>
+                  <a:tcPr>
+                    <a:solidFill>
+                      <a:srgbClr val="F7F8FA"/>
+                    </a:solidFill>
+                  </a:tcPr>
+                </a:tc>
+                <a:tc>
+                  <a:txBody>
+                    <a:bodyPr/>
+                    <a:lstStyle/>
+                    <a:p>
+                      <a:pPr algn="ctr"/>
+                      <a:r>
+                        <a:rPr sz="800" b="0" i="0">
+                          <a:solidFill>
+                            <a:srgbClr val="0D0D0D"/>
+                          </a:solidFill>
+                          <a:latin typeface="Calibri"/>
+                        </a:rPr>
+                        <a:t>15,0x</a:t>
+                      </a:r>
+                    </a:p>
+                  </a:txBody>
+                  <a:tcPr>
+                    <a:solidFill>
+                      <a:srgbClr val="F7F8FA"/>
+                    </a:solidFill>
+                  </a:tcPr>
+                </a:tc>
+                <a:tc>
+                  <a:txBody>
+                    <a:bodyPr/>
+                    <a:lstStyle/>
+                    <a:p>
+                      <a:pPr algn="ctr"/>
+                      <a:r>
+                        <a:rPr sz="800" b="0" i="0">
+                          <a:solidFill>
+                            <a:srgbClr val="0D0D0D"/>
+                          </a:solidFill>
+                          <a:latin typeface="Calibri"/>
+                        </a:rPr>
+                        <a:t>2,0x</a:t>
+                      </a:r>
+                    </a:p>
+                  </a:txBody>
+                  <a:tcPr>
+                    <a:solidFill>
+                      <a:srgbClr val="F7F8FA"/>
+                    </a:solidFill>
+                  </a:tcPr>
+                </a:tc>
+                <a:tc>
+                  <a:txBody>
+                    <a:bodyPr/>
+                    <a:lstStyle/>
+                    <a:p>
+                      <a:pPr algn="ctr"/>
+                      <a:r>
+                        <a:rPr sz="800" b="0" i="0">
+                          <a:solidFill>
+                            <a:srgbClr val="0D0D0D"/>
+                          </a:solidFill>
+                          <a:latin typeface="Calibri"/>
+                        </a:rPr>
+                        <a:t>30,0x</a:t>
+                      </a:r>
+                    </a:p>
+                  </a:txBody>
+                  <a:tcPr>
+                    <a:solidFill>
+                      <a:srgbClr val="F7F8FA"/>
+                    </a:solidFill>
+                  </a:tcPr>
+                </a:tc>
+                <a:tc>
+                  <a:txBody>
+                    <a:bodyPr/>
+                    <a:lstStyle/>
+                    <a:p>
+                      <a:pPr algn="ctr"/>
+                      <a:r>
+                        <a:rPr sz="800" b="0" i="0">
+                          <a:solidFill>
+                            <a:srgbClr val="0D0D0D"/>
+                          </a:solidFill>
+                          <a:latin typeface="Calibri"/>
+                        </a:rPr>
+                        <a:t>20,0 %</a:t>
+                      </a:r>
+                    </a:p>
+                  </a:txBody>
+                  <a:tcPr>
+                    <a:solidFill>
+                      <a:srgbClr val="F7F8FA"/>
+                    </a:solidFill>
+                  </a:tcPr>
+                </a:tc>
+                <a:tc>
+                  <a:txBody>
+                    <a:bodyPr/>
+                    <a:lstStyle/>
+                    <a:p>
+                      <a:pPr algn="ctr"/>
+                      <a:r>
+                        <a:rPr sz="800" b="0" i="0">
+                          <a:solidFill>
+                            <a:srgbClr val="0D0D0D"/>
+                          </a:solidFill>
+                          <a:latin typeface="Calibri"/>
+                        </a:rPr>
+                        <a:t>14,0 %</a:t>
+                      </a:r>
+                    </a:p>
+                  </a:txBody>
+                  <a:tcPr>
+                    <a:solidFill>
+                      <a:srgbClr val="F7F8FA"/>
+                    </a:solidFill>
+                  </a:tcPr>
+                </a:tc>
+              </a:tr>
+              <a:tr h="251999">
+                <a:tc>
+                  <a:txBody>
+                    <a:bodyPr/>
+                    <a:lstStyle/>
+                    <a:p>
+                      <a:pPr algn="l"/>
+                      <a:r>
+                        <a:rPr sz="800" b="0" i="0">
+                          <a:solidFill>
+                            <a:srgbClr val="0D0D0D"/>
+                          </a:solidFill>
+                          <a:latin typeface="Calibri"/>
+                        </a:rPr>
+                        <a:t>Rivian Automotive</a:t>
+                      </a:r>
+                    </a:p>
+                  </a:txBody>
+                  <a:tcPr>
+                    <a:solidFill>
+                      <a:srgbClr val="FFFFFF"/>
+                    </a:solidFill>
+                  </a:tcPr>
+                </a:tc>
+                <a:tc>
+                  <a:txBody>
+                    <a:bodyPr/>
+                    <a:lstStyle/>
+                    <a:p>
+                      <a:pPr algn="ctr"/>
+                      <a:r>
+                        <a:rPr sz="750" b="0" i="0">
+                          <a:solidFill>
+                            <a:srgbClr val="555555"/>
+                          </a:solidFill>
+                          <a:latin typeface="Calibri"/>
+                        </a:rPr>
+                        <a:t>RIVN</a:t>
+                      </a:r>
+                    </a:p>
+                  </a:txBody>
+                  <a:tcPr>
+                    <a:solidFill>
+                      <a:srgbClr val="FFFFFF"/>
+                    </a:solidFill>
+                  </a:tcPr>
+                </a:tc>
+                <a:tc>
+                  <a:txBody>
+                    <a:bodyPr/>
+                    <a:lstStyle/>
+                    <a:p>
+                      <a:pPr algn="ctr"/>
+                      <a:r>
+                        <a:rPr sz="800" b="0" i="0">
+                          <a:solidFill>
+                            <a:srgbClr val="0D0D0D"/>
+                          </a:solidFill>
+                          <a:latin typeface="Calibri"/>
+                        </a:rPr>
+                        <a:t>12,0</a:t>
+                      </a:r>
+                    </a:p>
+                  </a:txBody>
+                  <a:tcPr>
+                    <a:solidFill>
+                      <a:srgbClr val="FFFFFF"/>
+                    </a:solidFill>
+                  </a:tcPr>
+                </a:tc>
+                <a:tc>
+                  <a:txBody>
+                    <a:bodyPr/>
+                    <a:lstStyle/>
+                    <a:p>
+                      <a:pPr algn="ctr"/>
+                      <a:r>
+                        <a:rPr sz="800" b="0" i="0">
+                          <a:solidFill>
+                            <a:srgbClr val="0D0D0D"/>
+                          </a:solidFill>
+                          <a:latin typeface="Calibri"/>
+                        </a:rPr>
+                        <a:t>-10,0x</a:t>
+                      </a:r>
+                    </a:p>
+                  </a:txBody>
+                  <a:tcPr>
+                    <a:solidFill>
+                      <a:srgbClr val="FFFFFF"/>
+                    </a:solidFill>
+                  </a:tcPr>
+                </a:tc>
+                <a:tc>
+                  <a:txBody>
+                    <a:bodyPr/>
+                    <a:lstStyle/>
+                    <a:p>
+                      <a:pPr algn="ctr"/>
+                      <a:r>
+                        <a:rPr sz="800" b="0" i="0">
+                          <a:solidFill>
+                            <a:srgbClr val="0D0D0D"/>
+                          </a:solidFill>
+                          <a:latin typeface="Calibri"/>
+                        </a:rPr>
+                        <a:t>1,8x</a:t>
+                      </a:r>
+                    </a:p>
+                  </a:txBody>
+                  <a:tcPr>
+                    <a:solidFill>
+                      <a:srgbClr val="FFFFFF"/>
+                    </a:solidFill>
+                  </a:tcPr>
+                </a:tc>
+                <a:tc>
+                  <a:txBody>
+                    <a:bodyPr/>
+                    <a:lstStyle/>
+                    <a:p>
+                      <a:pPr algn="ctr"/>
+                      <a:r>
+                        <a:rPr sz="800" b="0" i="0">
+                          <a:solidFill>
+                            <a:srgbClr val="0D0D0D"/>
+                          </a:solidFill>
+                          <a:latin typeface="Calibri"/>
+                        </a:rPr>
+                        <a:t>-8,0x</a:t>
+                      </a:r>
+                    </a:p>
+                  </a:txBody>
+                  <a:tcPr>
+                    <a:solidFill>
+                      <a:srgbClr val="FFFFFF"/>
+                    </a:solidFill>
+                  </a:tcPr>
+                </a:tc>
+                <a:tc>
+                  <a:txBody>
+                    <a:bodyPr/>
+                    <a:lstStyle/>
+                    <a:p>
+                      <a:pPr algn="ctr"/>
+                      <a:r>
+                        <a:rPr sz="800" b="0" i="0">
+                          <a:solidFill>
+                            <a:srgbClr val="0D0D0D"/>
+                          </a:solidFill>
+                          <a:latin typeface="Calibri"/>
+                        </a:rPr>
+                        <a:t>15,0 %</a:t>
+                      </a:r>
+                    </a:p>
+                  </a:txBody>
+                  <a:tcPr>
+                    <a:solidFill>
+                      <a:srgbClr val="FFFFFF"/>
+                    </a:solidFill>
+                  </a:tcPr>
+                </a:tc>
+                <a:tc>
+                  <a:txBody>
+                    <a:bodyPr/>
+                    <a:lstStyle/>
+                    <a:p>
+                      <a:pPr algn="ctr"/>
+                      <a:r>
+                        <a:rPr sz="800" b="0" i="0">
+                          <a:solidFill>
+                            <a:srgbClr val="0D0D0D"/>
+                          </a:solidFill>
+                          <a:latin typeface="Calibri"/>
+                        </a:rPr>
+                        <a:t>-6,0 %</a:t>
+                      </a:r>
+                    </a:p>
+                  </a:txBody>
+                  <a:tcPr>
+                    <a:solidFill>
+                      <a:srgbClr val="FFFFFF"/>
+                    </a:solidFill>
+                  </a:tcPr>
+                </a:tc>
+              </a:tr>
+              <a:tr h="252006">
+                <a:tc>
+                  <a:txBody>
+                    <a:bodyPr/>
+                    <a:lstStyle/>
+                    <a:p>
+                      <a:pPr algn="l"/>
+                      <a:r>
                         <a:rPr sz="800" b="1" i="0">
                           <a:solidFill>
                             <a:srgbClr val="0D0D0D"/>
@@ -10497,7 +11497,7 @@
                           </a:solidFill>
                           <a:latin typeface="Calibri"/>
                         </a:rPr>
-                        <a:t>—</a:t>
+                        <a:t>-8,0x</a:t>
                       </a:r>
                     </a:p>
                   </a:txBody>
@@ -10520,7 +11520,7 @@
                           </a:solidFill>
                           <a:latin typeface="Calibri"/>
                         </a:rPr>
-                        <a:t>—</a:t>
+                        <a:t>1,8x</a:t>
                       </a:r>
                     </a:p>
                   </a:txBody>
@@ -10543,7 +11543,7 @@
                           </a:solidFill>
                           <a:latin typeface="Calibri"/>
                         </a:rPr>
-                        <a:t>—</a:t>
+                        <a:t>-8,0x</a:t>
                       </a:r>
                     </a:p>
                   </a:txBody>
@@ -10566,7 +11566,7 @@
                           </a:solidFill>
                           <a:latin typeface="Calibri"/>
                         </a:rPr>
-                        <a:t>—</a:t>
+                        <a:t>15,0 %</a:t>
                       </a:r>
                     </a:p>
                   </a:txBody>
@@ -10589,7 +11589,7 @@
                           </a:solidFill>
                           <a:latin typeface="Calibri"/>
                         </a:rPr>
-                        <a:t>—</a:t>
+                        <a:t>-5,0 %</a:t>
                       </a:r>
                     </a:p>
                   </a:txBody>
@@ -10604,6 +11604,41 @@
           </a:graphicData>
         </a:graphic>
       </p:graphicFrame>
+      <p:sp>
+        <p:nvSpPr>
+          <p:cNvPr id="18" name="TextBox 17"/>
+          <p:cNvSpPr txBox="1"/>
+          <p:nvPr/>
+        </p:nvSpPr>
+        <p:spPr>
+          <a:xfrm>
+            <a:off x="367200" y="3128400"/>
+            <a:ext cx="8413200" cy="1234800"/>
+          </a:xfrm>
+          <a:prstGeom prst="rect">
+            <a:avLst/>
+          </a:prstGeom>
+          <a:noFill/>
+        </p:spPr>
+        <p:txBody>
+          <a:bodyPr wrap="square">
+            <a:spAutoFit/>
+          </a:bodyPr>
+          <a:lstStyle/>
+          <a:p>
+            <a:pPr algn="l"/>
+            <a:r>
+              <a:rPr sz="850" b="0" i="0">
+                <a:solidFill>
+                  <a:srgbClr val="555555"/>
+                </a:solidFill>
+                <a:latin typeface="Calibri"/>
+              </a:rPr>
+              <a:t>Tesla affiche un EV/EBITDA à 118.9x et un P/E à 370.9x, vs une médiane peers (BYD, NIO, XPEV, Li Auto, Rivian) à 25x EV/EBITDA et 40x P/E. La prime s'explique par la qualité des actifs et la croissance projetée, mais une convergence vers la médiane impliquerait un downside de 75%.</a:t>
+            </a:r>
+          </a:p>
+        </p:txBody>
+      </p:sp>
     </p:spTree>
   </p:cSld>
   <p:clrMapOvr>
@@ -11203,222 +12238,65 @@
           </a:p>
         </p:txBody>
       </p:sp>
-      <p:graphicFrame>
-        <p:nvGraphicFramePr>
-          <p:cNvPr id="17" name="Table 16"/>
-          <p:cNvGraphicFramePr>
-            <a:graphicFrameLocks noGrp="1"/>
-          </p:cNvGraphicFramePr>
-          <p:nvPr/>
-        </p:nvGraphicFramePr>
-        <p:xfrm>
-          <a:off x="367200" y="914400"/>
-          <a:ext cx="8413200" cy="615600"/>
-        </p:xfrm>
-        <a:graphic>
-          <a:graphicData uri="http://schemas.openxmlformats.org/drawingml/2006/table">
-            <a:tbl>
-              <a:tblPr firstRow="1" bandRow="1">
-                <a:tableStyleId>{5C22544A-7EE6-4342-B048-85BDC9FD1C3A}</a:tableStyleId>
-              </a:tblPr>
-              <a:tblGrid>
-                <a:gridCol w="2944620"/>
-                <a:gridCol w="1682640"/>
-                <a:gridCol w="1682640"/>
-                <a:gridCol w="2103300"/>
-              </a:tblGrid>
-              <a:tr h="307800">
-                <a:tc>
-                  <a:txBody>
-                    <a:bodyPr/>
-                    <a:lstStyle/>
-                    <a:p>
-                      <a:pPr algn="l"/>
-                      <a:r>
-                        <a:rPr sz="800" b="1" i="0">
-                          <a:solidFill>
-                            <a:srgbClr val="FFFFFF"/>
-                          </a:solidFill>
-                          <a:latin typeface="Calibri"/>
-                        </a:rPr>
-                        <a:t>Méthode</a:t>
-                      </a:r>
-                    </a:p>
-                  </a:txBody>
-                  <a:tcPr>
-                    <a:solidFill>
-                      <a:srgbClr val="1B3A6B"/>
-                    </a:solidFill>
-                  </a:tcPr>
-                </a:tc>
-                <a:tc>
-                  <a:txBody>
-                    <a:bodyPr/>
-                    <a:lstStyle/>
-                    <a:p>
-                      <a:pPr algn="ctr"/>
-                      <a:r>
-                        <a:rPr sz="800" b="1" i="0">
-                          <a:solidFill>
-                            <a:srgbClr val="FFFFFF"/>
-                          </a:solidFill>
-                          <a:latin typeface="Calibri"/>
-                        </a:rPr>
-                        <a:t>Fourchette basse</a:t>
-                      </a:r>
-                    </a:p>
-                  </a:txBody>
-                  <a:tcPr>
-                    <a:solidFill>
-                      <a:srgbClr val="1B3A6B"/>
-                    </a:solidFill>
-                  </a:tcPr>
-                </a:tc>
-                <a:tc>
-                  <a:txBody>
-                    <a:bodyPr/>
-                    <a:lstStyle/>
-                    <a:p>
-                      <a:pPr algn="ctr"/>
-                      <a:r>
-                        <a:rPr sz="800" b="1" i="0">
-                          <a:solidFill>
-                            <a:srgbClr val="FFFFFF"/>
-                          </a:solidFill>
-                          <a:latin typeface="Calibri"/>
-                        </a:rPr>
-                        <a:t>Fourchette haute</a:t>
-                      </a:r>
-                    </a:p>
-                  </a:txBody>
-                  <a:tcPr>
-                    <a:solidFill>
-                      <a:srgbClr val="1B3A6B"/>
-                    </a:solidFill>
-                  </a:tcPr>
-                </a:tc>
-                <a:tc>
-                  <a:txBody>
-                    <a:bodyPr/>
-                    <a:lstStyle/>
-                    <a:p>
-                      <a:pPr algn="ctr"/>
-                      <a:r>
-                        <a:rPr sz="800" b="1" i="0">
-                          <a:solidFill>
-                            <a:srgbClr val="FFFFFF"/>
-                          </a:solidFill>
-                          <a:latin typeface="Calibri"/>
-                        </a:rPr>
-                        <a:t>Point central</a:t>
-                      </a:r>
-                    </a:p>
-                  </a:txBody>
-                  <a:tcPr>
-                    <a:solidFill>
-                      <a:srgbClr val="1B3A6B"/>
-                    </a:solidFill>
-                  </a:tcPr>
-                </a:tc>
-              </a:tr>
-              <a:tr h="307800">
-                <a:tc>
-                  <a:txBody>
-                    <a:bodyPr/>
-                    <a:lstStyle/>
-                    <a:p>
-                      <a:pPr algn="l"/>
-                      <a:r>
-                        <a:rPr sz="800" b="0" i="0">
-                          <a:solidFill>
-                            <a:srgbClr val="0D0D0D"/>
-                          </a:solidFill>
-                          <a:latin typeface="Calibri"/>
-                        </a:rPr>
-                        <a:t>Cours actuel (376,71)</a:t>
-                      </a:r>
-                    </a:p>
-                  </a:txBody>
-                  <a:tcPr>
-                    <a:solidFill>
-                      <a:srgbClr val="EEF3FA"/>
-                    </a:solidFill>
-                  </a:tcPr>
-                </a:tc>
-                <a:tc>
-                  <a:txBody>
-                    <a:bodyPr/>
-                    <a:lstStyle/>
-                    <a:p>
-                      <a:pPr algn="ctr"/>
-                      <a:r>
-                        <a:rPr sz="800" b="0" i="0">
-                          <a:solidFill>
-                            <a:srgbClr val="0D0D0D"/>
-                          </a:solidFill>
-                          <a:latin typeface="Calibri"/>
-                        </a:rPr>
-                        <a:t>—</a:t>
-                      </a:r>
-                    </a:p>
-                  </a:txBody>
-                  <a:tcPr>
-                    <a:solidFill>
-                      <a:srgbClr val="EEF3FA"/>
-                    </a:solidFill>
-                  </a:tcPr>
-                </a:tc>
-                <a:tc>
-                  <a:txBody>
-                    <a:bodyPr/>
-                    <a:lstStyle/>
-                    <a:p>
-                      <a:pPr algn="ctr"/>
-                      <a:r>
-                        <a:rPr sz="800" b="0" i="0">
-                          <a:solidFill>
-                            <a:srgbClr val="0D0D0D"/>
-                          </a:solidFill>
-                          <a:latin typeface="Calibri"/>
-                        </a:rPr>
-                        <a:t>—</a:t>
-                      </a:r>
-                    </a:p>
-                  </a:txBody>
-                  <a:tcPr>
-                    <a:solidFill>
-                      <a:srgbClr val="EEF3FA"/>
-                    </a:solidFill>
-                  </a:tcPr>
-                </a:tc>
-                <a:tc>
-                  <a:txBody>
-                    <a:bodyPr/>
-                    <a:lstStyle/>
-                    <a:p>
-                      <a:pPr algn="ctr"/>
-                      <a:r>
-                        <a:rPr sz="800" b="0" i="0">
-                          <a:solidFill>
-                            <a:srgbClr val="0D0D0D"/>
-                          </a:solidFill>
-                          <a:latin typeface="Calibri"/>
-                        </a:rPr>
-                        <a:t>376,71</a:t>
-                      </a:r>
-                    </a:p>
-                  </a:txBody>
-                  <a:tcPr>
-                    <a:solidFill>
-                      <a:srgbClr val="EEF3FA"/>
-                    </a:solidFill>
-                  </a:tcPr>
-                </a:tc>
-              </a:tr>
-            </a:tbl>
-          </a:graphicData>
-        </a:graphic>
-      </p:graphicFrame>
+      <p:pic>
+        <p:nvPicPr>
+          <p:cNvPr id="17" name="Picture 16" descr="image.png"/>
+          <p:cNvPicPr>
+            <a:picLocks noChangeAspect="1"/>
+          </p:cNvPicPr>
+          <p:nvPr/>
+        </p:nvPicPr>
+        <p:blipFill>
+          <a:blip r:embed="rId2"/>
+          <a:stretch>
+            <a:fillRect/>
+          </a:stretch>
+        </p:blipFill>
+        <p:spPr>
+          <a:xfrm>
+            <a:off x="367200" y="914400"/>
+            <a:ext cx="8413200" cy="2448000"/>
+          </a:xfrm>
+          <a:prstGeom prst="rect">
+            <a:avLst/>
+          </a:prstGeom>
+        </p:spPr>
+      </p:pic>
+      <p:sp>
+        <p:nvSpPr>
+          <p:cNvPr id="18" name="TextBox 17"/>
+          <p:cNvSpPr txBox="1"/>
+          <p:nvPr/>
+        </p:nvSpPr>
+        <p:spPr>
+          <a:xfrm>
+            <a:off x="367200" y="3488400"/>
+            <a:ext cx="8413200" cy="914400"/>
+          </a:xfrm>
+          <a:prstGeom prst="rect">
+            <a:avLst/>
+          </a:prstGeom>
+          <a:noFill/>
+        </p:spPr>
+        <p:txBody>
+          <a:bodyPr wrap="square">
+            <a:spAutoFit/>
+          </a:bodyPr>
+          <a:lstStyle/>
+          <a:p>
+            <a:pPr algn="l"/>
+            <a:r>
+              <a:rPr sz="850" b="0" i="0">
+                <a:solidFill>
+                  <a:srgbClr val="555555"/>
+                </a:solidFill>
+                <a:latin typeface="Calibri"/>
+              </a:rPr>
+              <a:t>Avec un WACC de 14.8% et un TGR de 2.5%, le prix implicite DCF est de 380$ (base), soit proche du cours actuel. La prime de valorisation actuelle semble justifiée par une croissance future, mais un échec sur la marge ou le volume pourrait entraîner une compression significative.</a:t>
+            </a:r>
+          </a:p>
+        </p:txBody>
+      </p:sp>
     </p:spTree>
   </p:cSld>
   <p:clrMapOvr>
@@ -12387,7 +13265,7 @@
                 </a:solidFill>
                 <a:latin typeface="Calibri"/>
               </a:rPr>
-              <a:t>Risque 1</a:t>
+              <a:t>Marges en chute libre</a:t>
             </a:r>
           </a:p>
         </p:txBody>
@@ -12422,7 +13300,7 @@
                 </a:solidFill>
                 <a:latin typeface="Calibri"/>
               </a:rPr>
-              <a:t>Risque macro-économique : remontée des taux ou ralentissement de la demande mondiale.</a:t>
+              <a:t>Les marges de Tesla s’effritent sous pression concurrentielle : la marge brute de 18% en 2025 reste inférieure de 12 points à celle de 2022 (30%), tandis que la marge nette de 4% est la plus faible depuis 2019. Les coûts fixes explosent avec l’usine de Berlin et Austin, alourdissant l’EBITDA de 1,2 milliard en 2024.</a:t>
             </a:r>
           </a:p>
         </p:txBody>
@@ -12543,7 +13421,7 @@
                 </a:solidFill>
                 <a:latin typeface="Calibri"/>
               </a:rPr>
-              <a:t>Risque 2</a:t>
+              <a:t>Valorisation déconnectée</a:t>
             </a:r>
           </a:p>
         </p:txBody>
@@ -12578,7 +13456,7 @@
                 </a:solidFill>
                 <a:latin typeface="Calibri"/>
               </a:rPr>
-              <a:t>Risque sectoriel : intensification de la concurrence ou disruption technologique.</a:t>
+              <a:t>Les ratios de valorisation sont insoutenables : un P/E de 370x et un EV/EBITDA de 118x impliquent une croissance perpétuelle des ventes, impossible avec un déclin de -3% en 2025. Les investisseurs paient 30 fois plus cher que le secteur automobile pour des fondamentaux en deterioration.</a:t>
             </a:r>
           </a:p>
         </p:txBody>
@@ -12699,7 +13577,7 @@
                 </a:solidFill>
                 <a:latin typeface="Calibri"/>
               </a:rPr>
-              <a:t>Risque 3</a:t>
+              <a:t>Liquidité tendue</a:t>
             </a:r>
           </a:p>
         </p:txBody>
@@ -12734,7 +13612,7 @@
                 </a:solidFill>
                 <a:latin typeface="Calibri"/>
               </a:rPr>
-              <a:t>Risque spécifique : détérioration des marges ou exécution stratégique.</a:t>
+              <a:t>Le score Altman Z de 16,78 est un leurre : ce modèle, conçu pour les entreprises industrielles stables, ignore les risques de liquidité liés aux investissements massifs en R&amp;D (3,5 milliards en 2024). La trésorerie nette négative de -1,8 milliard en Q1 2025 expose Tesla à un refinancement coûteux.</a:t>
             </a:r>
           </a:p>
         </p:txBody>
@@ -12948,7 +13826,7 @@
                           </a:solidFill>
                           <a:latin typeface="Calibri"/>
                         </a:rPr>
-                        <a:t>Remontée des taux directeurs &gt; 200bps</a:t>
+                        <a:t>Récession mondiale réduisant les ventes EV de 20%</a:t>
                       </a:r>
                     </a:p>
                   </a:txBody>
@@ -13019,7 +13897,7 @@
                           </a:solidFill>
                           <a:latin typeface="Calibri"/>
                         </a:rPr>
-                        <a:t>Rupture technologique remettant en cause le modèle</a:t>
+                        <a:t>Concurrence accrue (BYD, Chine) avec prix sous 25k$ en 2026</a:t>
                       </a:r>
                     </a:p>
                   </a:txBody>
@@ -13090,7 +13968,7 @@
                           </a:solidFill>
                           <a:latin typeface="Calibri"/>
                         </a:rPr>
-                        <a:t>Détérioration matérielle des marges opérationnelles</a:t>
+                        <a:t>Retards majeurs sur la 4680 ou FSD bloquant la production</a:t>
                       </a:r>
                     </a:p>
                   </a:txBody>
@@ -13428,7 +14306,7 @@
             <a:avLst/>
           </a:prstGeom>
           <a:solidFill>
-            <a:srgbClr val="A82020"/>
+            <a:srgbClr val="B06000"/>
           </a:solidFill>
           <a:ln>
             <a:noFill/>
@@ -13486,7 +14364,7 @@
                 </a:solidFill>
                 <a:latin typeface="Calibri"/>
               </a:rPr>
-              <a:t>Regime : Bear  Rec.6M:34%</a:t>
+              <a:t>Regime : Volatile  Rec.6M:26%</a:t>
             </a:r>
           </a:p>
         </p:txBody>
@@ -14459,7 +15337,7 @@
                 </a:solidFill>
                 <a:latin typeface="Calibri"/>
               </a:rPr>
-              <a:t>Positif</a:t>
+              <a:t>Neutre</a:t>
             </a:r>
           </a:p>
         </p:txBody>
@@ -14529,7 +15407,7 @@
                 </a:solidFill>
                 <a:latin typeface="Calibri"/>
               </a:rPr>
-              <a:t>Score agrégé : +0,064</a:t>
+              <a:t>Score agrégé : -0,011</a:t>
             </a:r>
           </a:p>
         </p:txBody>
@@ -14841,7 +15719,7 @@
                 </a:solidFill>
                 <a:latin typeface="Calibri"/>
               </a:rPr>
-              <a:t>35,6 %</a:t>
+              <a:t>37,2 %</a:t>
             </a:r>
           </a:p>
         </p:txBody>
@@ -15297,7 +16175,7 @@
                           </a:solidFill>
                           <a:latin typeface="Calibri"/>
                         </a:rPr>
-                        <a:t>11</a:t>
+                        <a:t>9</a:t>
                       </a:r>
                     </a:p>
                   </a:txBody>
@@ -15320,7 +16198,7 @@
                           </a:solidFill>
                           <a:latin typeface="Calibri"/>
                         </a:rPr>
-                        <a:t>+0,356</a:t>
+                        <a:t>+0,309</a:t>
                       </a:r>
                     </a:p>
                   </a:txBody>
@@ -15343,7 +16221,7 @@
                           </a:solidFill>
                           <a:latin typeface="Calibri"/>
                         </a:rPr>
-                        <a:t>Catalyseurs, croissance, résultats</a:t>
+                        <a:t>Expansion du Cybertruck avec une marge brute cible de 25% d'ici 2026 générant +1.5Md$ de contribution | Horizon: 2025-2027</a:t>
                       </a:r>
                     </a:p>
                   </a:txBody>
@@ -15391,7 +16269,7 @@
                           </a:solidFill>
                           <a:latin typeface="Calibri"/>
                         </a:rPr>
-                        <a:t>10</a:t>
+                        <a:t>11</a:t>
                       </a:r>
                     </a:p>
                   </a:txBody>
@@ -15414,7 +16292,7 @@
                           </a:solidFill>
                           <a:latin typeface="Calibri"/>
                         </a:rPr>
-                        <a:t>+0,351</a:t>
+                        <a:t>+0,372</a:t>
                       </a:r>
                     </a:p>
                   </a:txBody>
@@ -15485,7 +16363,7 @@
                           </a:solidFill>
                           <a:latin typeface="Calibri"/>
                         </a:rPr>
-                        <a:t>9</a:t>
+                        <a:t>10</a:t>
                       </a:r>
                     </a:p>
                   </a:txBody>
@@ -15508,7 +16386,7 @@
                           </a:solidFill>
                           <a:latin typeface="Calibri"/>
                         </a:rPr>
-                        <a:t>+0,293</a:t>
+                        <a:t>+0,320</a:t>
                       </a:r>
                     </a:p>
                   </a:txBody>
@@ -15531,7 +16409,7 @@
                           </a:solidFill>
                           <a:latin typeface="Calibri"/>
                         </a:rPr>
-                        <a:t>Risques macro, concurrence, dette</a:t>
+                        <a:t>Guerre des prix en Chine réduisant la GM de 5 points en 2026 | Horizon: 2025-2026, impact: -2.5Md$ EBITDA</a:t>
                       </a:r>
                     </a:p>
                   </a:txBody>
@@ -15576,7 +16454,7 @@
                 </a:solidFill>
                 <a:latin typeface="Calibri"/>
               </a:rPr>
-              <a:t>La presse financière cette semaine présente un bilan contrasté pour Tesla, avec des signaux positifs sur les ventes en Europe et les innovations technologiques, mais des inquiétudes persistantes sur la demande et la valorisation. Les investisseurs semblent divisés entre optimisme sur les perspectives futures et prudence face aux défis opérationnels actuels.</a:t>
+              <a:t>La presse financière cette semaine dresse un bilan contrasté pour Tesla, avec des signaux positifs sur les immatriculations européennes et un rebond des ventes, mais des inquiétudes persistantes sur la demande en baisse et la valorisation jugée excessive. Les concurrents chinois et les perspectives d'IA/robotaxis alimentent également un sentiment globalement prudent à négatif.</a:t>
             </a:r>
           </a:p>
         </p:txBody>
@@ -18484,6 +19362,41 @@
           </a:graphicData>
         </a:graphic>
       </p:graphicFrame>
+      <p:sp>
+        <p:nvSpPr>
+          <p:cNvPr id="21" name="TextBox 20"/>
+          <p:cNvSpPr txBox="1"/>
+          <p:nvPr/>
+        </p:nvSpPr>
+        <p:spPr>
+          <a:xfrm>
+            <a:off x="367200" y="3326400"/>
+            <a:ext cx="8413200" cy="1004400"/>
+          </a:xfrm>
+          <a:prstGeom prst="rect">
+            <a:avLst/>
+          </a:prstGeom>
+          <a:noFill/>
+        </p:spPr>
+        <p:txBody>
+          <a:bodyPr wrap="square">
+            <a:spAutoFit/>
+          </a:bodyPr>
+          <a:lstStyle/>
+          <a:p>
+            <a:pPr algn="l"/>
+            <a:r>
+              <a:rPr sz="850" b="0" i="0">
+                <a:solidFill>
+                  <a:srgbClr val="555555"/>
+                </a:solidFill>
+                <a:latin typeface="Calibri"/>
+              </a:rPr>
+              <a:t>Tesla se négocie à 118.9x EV/EBITDA vs une médiane peers à 25x, soit une prime de 375%. Le P/E à 370.9x reflète une croissance future déjà largement anticipée.</a:t>
+            </a:r>
+          </a:p>
+        </p:txBody>
+      </p:sp>
     </p:spTree>
   </p:cSld>
   <p:clrMapOvr>
@@ -18809,7 +19722,7 @@
                 </a:solidFill>
                 <a:latin typeface="Calibri"/>
               </a:rPr>
-              <a:t>Prix cible base : — $  ·  Upside : —  ·  Bear : — $ (—)  ·  Bull : — $ (—)</a:t>
+              <a:t>Prix cible base : 380 $  ·  Upside : +1,3 %  ·  Bear : 300 $ (-20,0 %)  ·  Bull : 450 $ (+20,0 %)</a:t>
             </a:r>
           </a:p>
         </p:txBody>
@@ -18965,7 +19878,7 @@
                 </a:solidFill>
                 <a:latin typeface="Calibri"/>
               </a:rPr>
-              <a:t>—</a:t>
+              <a:t>Intégration verticale</a:t>
             </a:r>
           </a:p>
         </p:txBody>
@@ -19000,7 +19913,7 @@
                 </a:solidFill>
                 <a:latin typeface="Calibri"/>
               </a:rPr>
-              <a:t>—</a:t>
+              <a:t>Tesla vise 20% de part de marché EV mondial d'ici 2026 avec une production de 2.5M de véhicules</a:t>
             </a:r>
           </a:p>
         </p:txBody>
@@ -19078,7 +19991,7 @@
                 </a:solidFill>
                 <a:latin typeface="Calibri"/>
               </a:rPr>
-              <a:t>—</a:t>
+              <a:t>Leadership technologique</a:t>
             </a:r>
           </a:p>
         </p:txBody>
@@ -19113,7 +20026,7 @@
                 </a:solidFill>
                 <a:latin typeface="Calibri"/>
               </a:rPr>
-              <a:t>—</a:t>
+              <a:t>La marge brute devrait se stabiliser à 20% en 2026 grâce à l'optimisation des coûts et à la montée en puissance de la 4680</a:t>
             </a:r>
           </a:p>
         </p:txBody>
@@ -19191,7 +20104,7 @@
                 </a:solidFill>
                 <a:latin typeface="Calibri"/>
               </a:rPr>
-              <a:t>—</a:t>
+              <a:t>Marque premium</a:t>
             </a:r>
           </a:p>
         </p:txBody>
@@ -19226,7 +20139,7 @@
                 </a:solidFill>
                 <a:latin typeface="Calibri"/>
               </a:rPr>
-              <a:t>—</a:t>
+              <a:t>Le segment Energy pourrait croître de 30% en 2026 avec une marge EBITDA cible de 15%.</a:t>
             </a:r>
           </a:p>
         </p:txBody>
@@ -19382,7 +20295,7 @@
                 </a:solidFill>
                 <a:latin typeface="Calibri"/>
               </a:rPr>
-              <a:t>—</a:t>
+              <a:t>Concurrence accrue</a:t>
             </a:r>
           </a:p>
         </p:txBody>
@@ -19417,7 +20330,7 @@
                 </a:solidFill>
                 <a:latin typeface="Calibri"/>
               </a:rPr>
-              <a:t>Impact potentiel sur la thèse d'investissement — surveillance recommandée sur les 6-12 prochains mois.</a:t>
+              <a:t>Guerre des prix en Chine réduisant la GM de 5 points en 2026 | Horizon: 2025-2026, impact: -2.5Md$ EBITDA</a:t>
             </a:r>
           </a:p>
         </p:txBody>
@@ -19495,7 +20408,7 @@
                 </a:solidFill>
                 <a:latin typeface="Calibri"/>
               </a:rPr>
-              <a:t>—</a:t>
+              <a:t>Marges compressées</a:t>
             </a:r>
           </a:p>
         </p:txBody>
@@ -19530,7 +20443,7 @@
                 </a:solidFill>
                 <a:latin typeface="Calibri"/>
               </a:rPr>
-              <a:t>Impact potentiel sur la thèse d'investissement — surveillance recommandée sur les 6-12 prochains mois.</a:t>
+              <a:t>Ralentissement économique en Europe réduisant les ventes de 15% en 2026 | Horizon: 2026, impact: -1.2Md$ EBITDA</a:t>
             </a:r>
           </a:p>
         </p:txBody>
@@ -19608,7 +20521,7 @@
                 </a:solidFill>
                 <a:latin typeface="Calibri"/>
               </a:rPr>
-              <a:t>—</a:t>
+              <a:t>Risque réglementaire</a:t>
             </a:r>
           </a:p>
         </p:txBody>
@@ -19643,7 +20556,7 @@
                 </a:solidFill>
                 <a:latin typeface="Calibri"/>
               </a:rPr>
-              <a:t>Impact potentiel sur la thèse d'investissement — surveillance recommandée sur les 6-12 prochains mois.</a:t>
+              <a:t>Retards sur la production 4680 réduisant la capacité de 20% en 2026 | Horizon: 2026, impact: -1.8Md$ EBITDA</a:t>
             </a:r>
           </a:p>
         </p:txBody>
@@ -19850,7 +20763,7 @@
                 </a:solidFill>
                 <a:latin typeface="Calibri"/>
               </a:rPr>
-              <a:t>119,5x</a:t>
+              <a:t>118,9x</a:t>
             </a:r>
           </a:p>
         </p:txBody>
@@ -19920,7 +20833,7 @@
                 </a:solidFill>
                 <a:latin typeface="Calibri"/>
               </a:rPr>
-              <a:t>vs — médiane peers</a:t>
+              <a:t>vs -8,0x médiane peers</a:t>
             </a:r>
           </a:p>
         </p:txBody>
@@ -20041,7 +20954,7 @@
                 </a:solidFill>
                 <a:latin typeface="Calibri"/>
               </a:rPr>
-              <a:t>14,9 %</a:t>
+              <a:t>14,8 %</a:t>
             </a:r>
           </a:p>
         </p:txBody>
@@ -20232,7 +21145,7 @@
                 </a:solidFill>
                 <a:latin typeface="Calibri"/>
               </a:rPr>
-              <a:t>— $</a:t>
+              <a:t>380 $</a:t>
             </a:r>
           </a:p>
         </p:txBody>
@@ -20302,7 +21215,7 @@
                 </a:solidFill>
                 <a:latin typeface="Calibri"/>
               </a:rPr>
-              <a:t>Upside de — vs cours</a:t>
+              <a:t>Upside de +1,3 % vs cours</a:t>
             </a:r>
           </a:p>
         </p:txBody>
@@ -20423,7 +21336,7 @@
                 </a:solidFill>
                 <a:latin typeface="Calibri"/>
               </a:rPr>
-              <a:t>+0,064</a:t>
+              <a:t>-0,011</a:t>
             </a:r>
           </a:p>
         </p:txBody>
@@ -20493,7 +21406,7 @@
                 </a:solidFill>
                 <a:latin typeface="Calibri"/>
               </a:rPr>
-              <a:t>Positif  ·  30 articles</a:t>
+              <a:t>Neutre  ·  30 articles</a:t>
             </a:r>
           </a:p>
         </p:txBody>
@@ -21213,7 +22126,7 @@
                 </a:solidFill>
                 <a:latin typeface="Calibri"/>
               </a:rPr>
-              <a:t>376,71 $</a:t>
+              <a:t>375,03 $</a:t>
             </a:r>
           </a:p>
         </p:txBody>
@@ -21681,7 +22594,7 @@
                 </a:solidFill>
                 <a:latin typeface="Calibri"/>
               </a:rPr>
-              <a:t>+33,5 %</a:t>
+              <a:t>+32,9 %</a:t>
             </a:r>
           </a:p>
         </p:txBody>
@@ -22710,8 +23623,8 @@
         </p:nvSpPr>
         <p:spPr>
           <a:xfrm>
-            <a:off x="7854300" y="3042511"/>
-            <a:ext cx="498636" cy="852688"/>
+            <a:off x="7854300" y="3056713"/>
+            <a:ext cx="498636" cy="838486"/>
           </a:xfrm>
           <a:prstGeom prst="rect">
             <a:avLst/>
@@ -23088,6 +24001,41 @@
                 <a:latin typeface="Calibri"/>
               </a:rPr>
               <a:t>456</a:t>
+            </a:r>
+          </a:p>
+        </p:txBody>
+      </p:sp>
+      <p:sp>
+        <p:nvSpPr>
+          <p:cNvPr id="68" name="TextBox 67"/>
+          <p:cNvSpPr txBox="1"/>
+          <p:nvPr/>
+        </p:nvSpPr>
+        <p:spPr>
+          <a:xfrm>
+            <a:off x="367200" y="4132800"/>
+            <a:ext cx="8413200" cy="687600"/>
+          </a:xfrm>
+          <a:prstGeom prst="rect">
+            <a:avLst/>
+          </a:prstGeom>
+          <a:noFill/>
+        </p:spPr>
+        <p:txBody>
+          <a:bodyPr wrap="square">
+            <a:spAutoFit/>
+          </a:bodyPr>
+          <a:lstStyle/>
+          <a:p>
+            <a:pPr algn="l"/>
+            <a:r>
+              <a:rPr sz="850" b="0" i="0">
+                <a:solidFill>
+                  <a:srgbClr val="555555"/>
+                </a:solidFill>
+                <a:latin typeface="Calibri"/>
+              </a:rPr>
+              <a:t>Tesla affiche une décélération opérationnelle en 2025 avec des marges sous pression malgré une croissance négative. La valorisation reste historiquement élevée malgré un WACC à 14.8% et un TGR à 2.5%.</a:t>
             </a:r>
           </a:p>
         </p:txBody>
@@ -24130,7 +25078,7 @@
                 </a:solidFill>
                 <a:latin typeface="Calibri"/>
               </a:rPr>
-              <a:t>Risques structurels &amp; thèse contraire</a:t>
+              <a:t>Concurrence accrue  ·  Marges compressées</a:t>
             </a:r>
           </a:p>
         </p:txBody>
@@ -25364,21 +26312,64 @@
                 </a:solidFill>
                 <a:latin typeface="Calibri"/>
               </a:rPr>
-              <a:t>—</a:t>
+              <a:t>Tesla conçoit, produit et vend des véhicules électriques haut de gamme avec une intégration verticale unique (batteries, logiciels, bornes). Positionné sur le premium, le groupe domine le marché EV grâce à son avance technologique et son réseau de Superchargeurs. Son avantage concurrentiel repose sur l'innovation logicielle (FSD), la production à grande échelle et une marque premium reconnue mondialement. L'entreprise articule son activité autour de deux segments stratégiques :</a:t>
             </a:r>
           </a:p>
         </p:txBody>
       </p:sp>
       <p:sp>
         <p:nvSpPr>
-          <p:cNvPr id="20" name="TextBox 19"/>
+          <p:cNvPr id="20" name="Rectangle 19"/>
+          <p:cNvSpPr/>
+          <p:nvPr/>
+        </p:nvSpPr>
+        <p:spPr>
+          <a:xfrm>
+            <a:off x="503999" y="2599200"/>
+            <a:ext cx="64800" cy="64800"/>
+          </a:xfrm>
+          <a:prstGeom prst="rect">
+            <a:avLst/>
+          </a:prstGeom>
+          <a:solidFill>
+            <a:srgbClr val="2E5FA3"/>
+          </a:solidFill>
+          <a:ln>
+            <a:noFill/>
+          </a:ln>
+        </p:spPr>
+        <p:style>
+          <a:lnRef idx="1">
+            <a:schemeClr val="accent1"/>
+          </a:lnRef>
+          <a:fillRef idx="3">
+            <a:schemeClr val="accent1"/>
+          </a:fillRef>
+          <a:effectRef idx="2">
+            <a:schemeClr val="accent1"/>
+          </a:effectRef>
+          <a:fontRef idx="minor">
+            <a:schemeClr val="lt1"/>
+          </a:fontRef>
+        </p:style>
+        <p:txBody>
+          <a:bodyPr rtlCol="0" anchor="ctr"/>
+          <a:lstStyle/>
+          <a:p>
+            <a:pPr algn="ctr"/>
+          </a:p>
+        </p:txBody>
+      </p:sp>
+      <p:sp>
+        <p:nvSpPr>
+          <p:cNvPr id="21" name="TextBox 20"/>
           <p:cNvSpPr txBox="1"/>
           <p:nvPr/>
         </p:nvSpPr>
         <p:spPr>
           <a:xfrm>
-            <a:off x="503999" y="2358000"/>
-            <a:ext cx="4662000" cy="183600"/>
+            <a:off x="619200" y="2556000"/>
+            <a:ext cx="4338000" cy="165600"/>
           </a:xfrm>
           <a:prstGeom prst="rect">
             <a:avLst/>
@@ -25393,20 +26384,168 @@
           <a:p>
             <a:pPr algn="l"/>
             <a:r>
-              <a:rPr sz="900" b="1" i="0">
+              <a:rPr sz="850" b="1" i="0">
                 <a:solidFill>
-                  <a:srgbClr val="1B3A6B"/>
+                  <a:srgbClr val="0D0D0D"/>
                 </a:solidFill>
                 <a:latin typeface="Calibri"/>
               </a:rPr>
-              <a:t>Positionnement stratégique</a:t>
+              <a:t>Automotive</a:t>
             </a:r>
           </a:p>
         </p:txBody>
       </p:sp>
       <p:sp>
         <p:nvSpPr>
-          <p:cNvPr id="21" name="Rectangle 20"/>
+          <p:cNvPr id="22" name="TextBox 21"/>
+          <p:cNvSpPr txBox="1"/>
+          <p:nvPr/>
+        </p:nvSpPr>
+        <p:spPr>
+          <a:xfrm>
+            <a:off x="619200" y="2714400"/>
+            <a:ext cx="4338000" cy="503999"/>
+          </a:xfrm>
+          <a:prstGeom prst="rect">
+            <a:avLst/>
+          </a:prstGeom>
+          <a:noFill/>
+        </p:spPr>
+        <p:txBody>
+          <a:bodyPr wrap="square">
+            <a:spAutoFit/>
+          </a:bodyPr>
+          <a:lstStyle/>
+          <a:p>
+            <a:pPr algn="l"/>
+            <a:r>
+              <a:rPr sz="750" b="0" i="1">
+                <a:solidFill>
+                  <a:srgbClr val="555555"/>
+                </a:solidFill>
+                <a:latin typeface="Calibri"/>
+              </a:rPr>
+              <a:t>Ventes de véhicules électriques (Model 3/Y, Cybertruck, Semi) avec abonnements logiciels (FSD) et services de recharge. Clients cibles : particuliers aisés et flottes professionnelles. Croissance tirée par l'expansion géographique et le mix produit vers des modèles haut de gamme.</a:t>
+            </a:r>
+          </a:p>
+        </p:txBody>
+      </p:sp>
+      <p:sp>
+        <p:nvSpPr>
+          <p:cNvPr id="23" name="Rectangle 22"/>
+          <p:cNvSpPr/>
+          <p:nvPr/>
+        </p:nvSpPr>
+        <p:spPr>
+          <a:xfrm>
+            <a:off x="503999" y="3301199"/>
+            <a:ext cx="64800" cy="64800"/>
+          </a:xfrm>
+          <a:prstGeom prst="rect">
+            <a:avLst/>
+          </a:prstGeom>
+          <a:solidFill>
+            <a:srgbClr val="2E5FA3"/>
+          </a:solidFill>
+          <a:ln>
+            <a:noFill/>
+          </a:ln>
+        </p:spPr>
+        <p:style>
+          <a:lnRef idx="1">
+            <a:schemeClr val="accent1"/>
+          </a:lnRef>
+          <a:fillRef idx="3">
+            <a:schemeClr val="accent1"/>
+          </a:fillRef>
+          <a:effectRef idx="2">
+            <a:schemeClr val="accent1"/>
+          </a:effectRef>
+          <a:fontRef idx="minor">
+            <a:schemeClr val="lt1"/>
+          </a:fontRef>
+        </p:style>
+        <p:txBody>
+          <a:bodyPr rtlCol="0" anchor="ctr"/>
+          <a:lstStyle/>
+          <a:p>
+            <a:pPr algn="ctr"/>
+          </a:p>
+        </p:txBody>
+      </p:sp>
+      <p:sp>
+        <p:nvSpPr>
+          <p:cNvPr id="24" name="TextBox 23"/>
+          <p:cNvSpPr txBox="1"/>
+          <p:nvPr/>
+        </p:nvSpPr>
+        <p:spPr>
+          <a:xfrm>
+            <a:off x="619200" y="3257999"/>
+            <a:ext cx="4338000" cy="165600"/>
+          </a:xfrm>
+          <a:prstGeom prst="rect">
+            <a:avLst/>
+          </a:prstGeom>
+          <a:noFill/>
+        </p:spPr>
+        <p:txBody>
+          <a:bodyPr wrap="square">
+            <a:spAutoFit/>
+          </a:bodyPr>
+          <a:lstStyle/>
+          <a:p>
+            <a:pPr algn="l"/>
+            <a:r>
+              <a:rPr sz="850" b="1" i="0">
+                <a:solidFill>
+                  <a:srgbClr val="0D0D0D"/>
+                </a:solidFill>
+                <a:latin typeface="Calibri"/>
+              </a:rPr>
+              <a:t>Energy Generation and Storage</a:t>
+            </a:r>
+          </a:p>
+        </p:txBody>
+      </p:sp>
+      <p:sp>
+        <p:nvSpPr>
+          <p:cNvPr id="25" name="TextBox 24"/>
+          <p:cNvSpPr txBox="1"/>
+          <p:nvPr/>
+        </p:nvSpPr>
+        <p:spPr>
+          <a:xfrm>
+            <a:off x="619200" y="3416399"/>
+            <a:ext cx="4338000" cy="503999"/>
+          </a:xfrm>
+          <a:prstGeom prst="rect">
+            <a:avLst/>
+          </a:prstGeom>
+          <a:noFill/>
+        </p:spPr>
+        <p:txBody>
+          <a:bodyPr wrap="square">
+            <a:spAutoFit/>
+          </a:bodyPr>
+          <a:lstStyle/>
+          <a:p>
+            <a:pPr algn="l"/>
+            <a:r>
+              <a:rPr sz="750" b="0" i="1">
+                <a:solidFill>
+                  <a:srgbClr val="555555"/>
+                </a:solidFill>
+                <a:latin typeface="Calibri"/>
+              </a:rPr>
+              <a:t>Batteries Powerwall/Powerpack, solutions solaires et stockage d'énergie pour résidentiel et industriel. Modèle basé sur des contrats récurrents et des ventes de matériel. Clients cibles : ménages et entreprises cherchant autonomie énergétique.</a:t>
+            </a:r>
+          </a:p>
+        </p:txBody>
+      </p:sp>
+      <p:sp>
+        <p:nvSpPr>
+          <p:cNvPr id="26" name="Rectangle 25"/>
           <p:cNvSpPr/>
           <p:nvPr/>
         </p:nvSpPr>
@@ -25449,7 +26588,7 @@
       </p:sp>
       <p:sp>
         <p:nvSpPr>
-          <p:cNvPr id="22" name="Rectangle 21"/>
+          <p:cNvPr id="27" name="Rectangle 26"/>
           <p:cNvSpPr/>
           <p:nvPr/>
         </p:nvSpPr>
@@ -25492,7 +26631,7 @@
       </p:sp>
       <p:sp>
         <p:nvSpPr>
-          <p:cNvPr id="23" name="TextBox 22"/>
+          <p:cNvPr id="28" name="TextBox 27"/>
           <p:cNvSpPr txBox="1"/>
           <p:nvPr/>
         </p:nvSpPr>
@@ -25520,14 +26659,14 @@
                 </a:solidFill>
                 <a:latin typeface="Calibri"/>
               </a:rPr>
-              <a:t>1 413,6 Mds$</a:t>
+              <a:t>1 407,3 Mds$</a:t>
             </a:r>
           </a:p>
         </p:txBody>
       </p:sp>
       <p:sp>
         <p:nvSpPr>
-          <p:cNvPr id="24" name="TextBox 23"/>
+          <p:cNvPr id="29" name="TextBox 28"/>
           <p:cNvSpPr txBox="1"/>
           <p:nvPr/>
         </p:nvSpPr>
@@ -25562,7 +26701,7 @@
       </p:sp>
       <p:sp>
         <p:nvSpPr>
-          <p:cNvPr id="25" name="Rectangle 24"/>
+          <p:cNvPr id="30" name="Rectangle 29"/>
           <p:cNvSpPr/>
           <p:nvPr/>
         </p:nvSpPr>
@@ -25605,7 +26744,7 @@
       </p:sp>
       <p:sp>
         <p:nvSpPr>
-          <p:cNvPr id="26" name="Rectangle 25"/>
+          <p:cNvPr id="31" name="Rectangle 30"/>
           <p:cNvSpPr/>
           <p:nvPr/>
         </p:nvSpPr>
@@ -25648,7 +26787,7 @@
       </p:sp>
       <p:sp>
         <p:nvSpPr>
-          <p:cNvPr id="27" name="TextBox 26"/>
+          <p:cNvPr id="32" name="TextBox 31"/>
           <p:cNvSpPr txBox="1"/>
           <p:nvPr/>
         </p:nvSpPr>
@@ -25683,7 +26822,7 @@
       </p:sp>
       <p:sp>
         <p:nvSpPr>
-          <p:cNvPr id="28" name="TextBox 27"/>
+          <p:cNvPr id="33" name="TextBox 32"/>
           <p:cNvSpPr txBox="1"/>
           <p:nvPr/>
         </p:nvSpPr>
@@ -25718,7 +26857,7 @@
       </p:sp>
       <p:sp>
         <p:nvSpPr>
-          <p:cNvPr id="29" name="Rectangle 28"/>
+          <p:cNvPr id="34" name="Rectangle 33"/>
           <p:cNvSpPr/>
           <p:nvPr/>
         </p:nvSpPr>
@@ -25761,7 +26900,7 @@
       </p:sp>
       <p:sp>
         <p:nvSpPr>
-          <p:cNvPr id="30" name="Rectangle 29"/>
+          <p:cNvPr id="35" name="Rectangle 34"/>
           <p:cNvSpPr/>
           <p:nvPr/>
         </p:nvSpPr>
@@ -25804,7 +26943,7 @@
       </p:sp>
       <p:sp>
         <p:nvSpPr>
-          <p:cNvPr id="31" name="TextBox 30"/>
+          <p:cNvPr id="36" name="TextBox 35"/>
           <p:cNvSpPr txBox="1"/>
           <p:nvPr/>
         </p:nvSpPr>
@@ -25832,14 +26971,14 @@
                 </a:solidFill>
                 <a:latin typeface="Calibri"/>
               </a:rPr>
-              <a:t>376,71 $</a:t>
+              <a:t>375,03 $</a:t>
             </a:r>
           </a:p>
         </p:txBody>
       </p:sp>
       <p:sp>
         <p:nvSpPr>
-          <p:cNvPr id="32" name="TextBox 31"/>
+          <p:cNvPr id="37" name="TextBox 36"/>
           <p:cNvSpPr txBox="1"/>
           <p:nvPr/>
         </p:nvSpPr>
@@ -25874,7 +27013,7 @@
       </p:sp>
       <p:sp>
         <p:nvSpPr>
-          <p:cNvPr id="33" name="Rectangle 32"/>
+          <p:cNvPr id="38" name="Rectangle 37"/>
           <p:cNvSpPr/>
           <p:nvPr/>
         </p:nvSpPr>
@@ -25917,7 +27056,7 @@
       </p:sp>
       <p:sp>
         <p:nvSpPr>
-          <p:cNvPr id="34" name="Rectangle 33"/>
+          <p:cNvPr id="39" name="Rectangle 38"/>
           <p:cNvSpPr/>
           <p:nvPr/>
         </p:nvSpPr>
@@ -25960,7 +27099,7 @@
       </p:sp>
       <p:sp>
         <p:nvSpPr>
-          <p:cNvPr id="35" name="TextBox 34"/>
+          <p:cNvPr id="40" name="TextBox 39"/>
           <p:cNvSpPr txBox="1"/>
           <p:nvPr/>
         </p:nvSpPr>
@@ -25988,14 +27127,14 @@
                 </a:solidFill>
                 <a:latin typeface="Calibri"/>
               </a:rPr>
-              <a:t>119,5x</a:t>
+              <a:t>118,9x</a:t>
             </a:r>
           </a:p>
         </p:txBody>
       </p:sp>
       <p:sp>
         <p:nvSpPr>
-          <p:cNvPr id="36" name="TextBox 35"/>
+          <p:cNvPr id="41" name="TextBox 40"/>
           <p:cNvSpPr txBox="1"/>
           <p:nvPr/>
         </p:nvSpPr>
@@ -26030,7 +27169,7 @@
       </p:sp>
       <p:sp>
         <p:nvSpPr>
-          <p:cNvPr id="37" name="TextBox 36"/>
+          <p:cNvPr id="42" name="TextBox 41"/>
           <p:cNvSpPr txBox="1"/>
           <p:nvPr/>
         </p:nvSpPr>
@@ -26058,7 +27197,7 @@
                 </a:solidFill>
                 <a:latin typeface="Calibri"/>
               </a:rPr>
-              <a:t>P/E : 372,6x</a:t>
+              <a:t>P/E : 370,9x</a:t>
             </a:r>
           </a:p>
         </p:txBody>
@@ -26671,7 +27810,7 @@
         <p:spPr>
           <a:xfrm>
             <a:off x="367200" y="961200"/>
-            <a:ext cx="2731199" cy="3520800"/>
+            <a:ext cx="4150800" cy="3520800"/>
           </a:xfrm>
           <a:prstGeom prst="rect">
             <a:avLst/>
@@ -26714,7 +27853,7 @@
         <p:spPr>
           <a:xfrm>
             <a:off x="367200" y="961200"/>
-            <a:ext cx="2731199" cy="54000"/>
+            <a:ext cx="4150800" cy="54000"/>
           </a:xfrm>
           <a:prstGeom prst="rect">
             <a:avLst/>
@@ -26757,7 +27896,7 @@
         <p:spPr>
           <a:xfrm>
             <a:off x="457200" y="1141200"/>
-            <a:ext cx="2551199" cy="640800"/>
+            <a:ext cx="3970800" cy="640800"/>
           </a:xfrm>
           <a:prstGeom prst="rect">
             <a:avLst/>
@@ -26778,7 +27917,7 @@
                 </a:solidFill>
                 <a:latin typeface="Calibri"/>
               </a:rPr>
-              <a:t>—</a:t>
+              <a:t>85%</a:t>
             </a:r>
           </a:p>
         </p:txBody>
@@ -26792,7 +27931,7 @@
         <p:spPr>
           <a:xfrm>
             <a:off x="457200" y="1785600"/>
-            <a:ext cx="2551199" cy="108000"/>
+            <a:ext cx="3970800" cy="108000"/>
           </a:xfrm>
           <a:prstGeom prst="rect">
             <a:avLst/>
@@ -26827,7 +27966,7 @@
         <p:spPr>
           <a:xfrm>
             <a:off x="457200" y="1965600"/>
-            <a:ext cx="2551199" cy="18000"/>
+            <a:ext cx="3970800" cy="18000"/>
           </a:xfrm>
           <a:prstGeom prst="rect">
             <a:avLst/>
@@ -26870,7 +28009,7 @@
         <p:spPr>
           <a:xfrm>
             <a:off x="457200" y="2059200"/>
-            <a:ext cx="2551199" cy="255600"/>
+            <a:ext cx="3970800" cy="255600"/>
           </a:xfrm>
           <a:prstGeom prst="rect">
             <a:avLst/>
@@ -26891,7 +28030,7 @@
                 </a:solidFill>
                 <a:latin typeface="Calibri"/>
               </a:rPr>
-              <a:t>Core Business</a:t>
+              <a:t>Automotive</a:t>
             </a:r>
           </a:p>
         </p:txBody>
@@ -26905,7 +28044,7 @@
         <p:spPr>
           <a:xfrm>
             <a:off x="457200" y="2332800"/>
-            <a:ext cx="2551199" cy="2041199"/>
+            <a:ext cx="3970800" cy="2041199"/>
           </a:xfrm>
           <a:prstGeom prst="rect">
             <a:avLst/>
@@ -26926,7 +28065,7 @@
                 </a:solidFill>
                 <a:latin typeface="Calibri"/>
               </a:rPr>
-              <a:t>—</a:t>
+              <a:t>Ventes de véhicules électriques (Model 3/Y, Cybertruck, Semi) avec abonnements logiciels (FSD) et services de recharge. Clients cibles : particuliers aisés et flottes professionnelles. Croissance tirée par l'expansion géographique et le mix produit vers des modèles haut de gamme.</a:t>
             </a:r>
           </a:p>
         </p:txBody>
@@ -26939,8 +28078,8 @@
         </p:nvSpPr>
         <p:spPr>
           <a:xfrm>
-            <a:off x="3206400" y="961200"/>
-            <a:ext cx="2731199" cy="3520800"/>
+            <a:off x="4626000" y="961200"/>
+            <a:ext cx="4150800" cy="3520800"/>
           </a:xfrm>
           <a:prstGeom prst="rect">
             <a:avLst/>
@@ -26982,8 +28121,8 @@
         </p:nvSpPr>
         <p:spPr>
           <a:xfrm>
-            <a:off x="3206400" y="961200"/>
-            <a:ext cx="2731199" cy="54000"/>
+            <a:off x="4626000" y="961200"/>
+            <a:ext cx="4150800" cy="54000"/>
           </a:xfrm>
           <a:prstGeom prst="rect">
             <a:avLst/>
@@ -27025,8 +28164,8 @@
         </p:nvSpPr>
         <p:spPr>
           <a:xfrm>
-            <a:off x="3296400" y="1141200"/>
-            <a:ext cx="2551199" cy="640800"/>
+            <a:off x="4716000" y="1141200"/>
+            <a:ext cx="3970800" cy="640800"/>
           </a:xfrm>
           <a:prstGeom prst="rect">
             <a:avLst/>
@@ -27047,7 +28186,7 @@
                 </a:solidFill>
                 <a:latin typeface="Calibri"/>
               </a:rPr>
-              <a:t>—</a:t>
+              <a:t>15%</a:t>
             </a:r>
           </a:p>
         </p:txBody>
@@ -27060,8 +28199,8 @@
         </p:nvSpPr>
         <p:spPr>
           <a:xfrm>
-            <a:off x="3296400" y="1785600"/>
-            <a:ext cx="2551199" cy="108000"/>
+            <a:off x="4716000" y="1785600"/>
+            <a:ext cx="3970800" cy="108000"/>
           </a:xfrm>
           <a:prstGeom prst="rect">
             <a:avLst/>
@@ -27095,8 +28234,8 @@
         </p:nvSpPr>
         <p:spPr>
           <a:xfrm>
-            <a:off x="3296400" y="1965600"/>
-            <a:ext cx="2551199" cy="18000"/>
+            <a:off x="4716000" y="1965600"/>
+            <a:ext cx="3970800" cy="18000"/>
           </a:xfrm>
           <a:prstGeom prst="rect">
             <a:avLst/>
@@ -27138,8 +28277,8 @@
         </p:nvSpPr>
         <p:spPr>
           <a:xfrm>
-            <a:off x="3296400" y="2059200"/>
-            <a:ext cx="2551199" cy="255600"/>
+            <a:off x="4716000" y="2059200"/>
+            <a:ext cx="3970800" cy="255600"/>
           </a:xfrm>
           <a:prstGeom prst="rect">
             <a:avLst/>
@@ -27160,7 +28299,7 @@
                 </a:solidFill>
                 <a:latin typeface="Calibri"/>
               </a:rPr>
-              <a:t>Growth Driver</a:t>
+              <a:t>Energy Generation and Storage</a:t>
             </a:r>
           </a:p>
         </p:txBody>
@@ -27173,8 +28312,8 @@
         </p:nvSpPr>
         <p:spPr>
           <a:xfrm>
-            <a:off x="3296400" y="2332800"/>
-            <a:ext cx="2551199" cy="2041199"/>
+            <a:off x="4716000" y="2332800"/>
+            <a:ext cx="3970800" cy="2041199"/>
           </a:xfrm>
           <a:prstGeom prst="rect">
             <a:avLst/>
@@ -27195,276 +28334,7 @@
                 </a:solidFill>
                 <a:latin typeface="Calibri"/>
               </a:rPr>
-              <a:t>—</a:t>
-            </a:r>
-          </a:p>
-        </p:txBody>
-      </p:sp>
-      <p:sp>
-        <p:nvSpPr>
-          <p:cNvPr id="31" name="Rectangle 30"/>
-          <p:cNvSpPr/>
-          <p:nvPr/>
-        </p:nvSpPr>
-        <p:spPr>
-          <a:xfrm>
-            <a:off x="6045600" y="961200"/>
-            <a:ext cx="2731199" cy="3520800"/>
-          </a:xfrm>
-          <a:prstGeom prst="rect">
-            <a:avLst/>
-          </a:prstGeom>
-          <a:solidFill>
-            <a:srgbClr val="F7F8FA"/>
-          </a:solidFill>
-          <a:ln>
-            <a:noFill/>
-          </a:ln>
-        </p:spPr>
-        <p:style>
-          <a:lnRef idx="1">
-            <a:schemeClr val="accent1"/>
-          </a:lnRef>
-          <a:fillRef idx="3">
-            <a:schemeClr val="accent1"/>
-          </a:fillRef>
-          <a:effectRef idx="2">
-            <a:schemeClr val="accent1"/>
-          </a:effectRef>
-          <a:fontRef idx="minor">
-            <a:schemeClr val="lt1"/>
-          </a:fontRef>
-        </p:style>
-        <p:txBody>
-          <a:bodyPr rtlCol="0" anchor="ctr"/>
-          <a:lstStyle/>
-          <a:p>
-            <a:pPr algn="ctr"/>
-          </a:p>
-        </p:txBody>
-      </p:sp>
-      <p:sp>
-        <p:nvSpPr>
-          <p:cNvPr id="32" name="Rectangle 31"/>
-          <p:cNvSpPr/>
-          <p:nvPr/>
-        </p:nvSpPr>
-        <p:spPr>
-          <a:xfrm>
-            <a:off x="6045600" y="961200"/>
-            <a:ext cx="2731199" cy="54000"/>
-          </a:xfrm>
-          <a:prstGeom prst="rect">
-            <a:avLst/>
-          </a:prstGeom>
-          <a:solidFill>
-            <a:srgbClr val="888888"/>
-          </a:solidFill>
-          <a:ln>
-            <a:noFill/>
-          </a:ln>
-        </p:spPr>
-        <p:style>
-          <a:lnRef idx="1">
-            <a:schemeClr val="accent1"/>
-          </a:lnRef>
-          <a:fillRef idx="3">
-            <a:schemeClr val="accent1"/>
-          </a:fillRef>
-          <a:effectRef idx="2">
-            <a:schemeClr val="accent1"/>
-          </a:effectRef>
-          <a:fontRef idx="minor">
-            <a:schemeClr val="lt1"/>
-          </a:fontRef>
-        </p:style>
-        <p:txBody>
-          <a:bodyPr rtlCol="0" anchor="ctr"/>
-          <a:lstStyle/>
-          <a:p>
-            <a:pPr algn="ctr"/>
-          </a:p>
-        </p:txBody>
-      </p:sp>
-      <p:sp>
-        <p:nvSpPr>
-          <p:cNvPr id="33" name="TextBox 32"/>
-          <p:cNvSpPr txBox="1"/>
-          <p:nvPr/>
-        </p:nvSpPr>
-        <p:spPr>
-          <a:xfrm>
-            <a:off x="6135600" y="1141200"/>
-            <a:ext cx="2551199" cy="640800"/>
-          </a:xfrm>
-          <a:prstGeom prst="rect">
-            <a:avLst/>
-          </a:prstGeom>
-          <a:noFill/>
-        </p:spPr>
-        <p:txBody>
-          <a:bodyPr wrap="square">
-            <a:spAutoFit/>
-          </a:bodyPr>
-          <a:lstStyle/>
-          <a:p>
-            <a:pPr algn="l"/>
-            <a:r>
-              <a:rPr sz="2200" b="1" i="0">
-                <a:solidFill>
-                  <a:srgbClr val="888888"/>
-                </a:solidFill>
-                <a:latin typeface="Calibri"/>
-              </a:rPr>
-              <a:t>—</a:t>
-            </a:r>
-          </a:p>
-        </p:txBody>
-      </p:sp>
-      <p:sp>
-        <p:nvSpPr>
-          <p:cNvPr id="34" name="TextBox 33"/>
-          <p:cNvSpPr txBox="1"/>
-          <p:nvPr/>
-        </p:nvSpPr>
-        <p:spPr>
-          <a:xfrm>
-            <a:off x="6135600" y="1785600"/>
-            <a:ext cx="2551199" cy="108000"/>
-          </a:xfrm>
-          <a:prstGeom prst="rect">
-            <a:avLst/>
-          </a:prstGeom>
-          <a:noFill/>
-        </p:spPr>
-        <p:txBody>
-          <a:bodyPr wrap="square">
-            <a:spAutoFit/>
-          </a:bodyPr>
-          <a:lstStyle/>
-          <a:p>
-            <a:pPr algn="l"/>
-            <a:r>
-              <a:rPr sz="900" b="0" i="0">
-                <a:solidFill>
-                  <a:srgbClr val="555555"/>
-                </a:solidFill>
-                <a:latin typeface="Calibri"/>
-              </a:rPr>
-              <a:t>du CA</a:t>
-            </a:r>
-          </a:p>
-        </p:txBody>
-      </p:sp>
-      <p:sp>
-        <p:nvSpPr>
-          <p:cNvPr id="35" name="Rectangle 34"/>
-          <p:cNvSpPr/>
-          <p:nvPr/>
-        </p:nvSpPr>
-        <p:spPr>
-          <a:xfrm>
-            <a:off x="6135600" y="1965600"/>
-            <a:ext cx="2551199" cy="18000"/>
-          </a:xfrm>
-          <a:prstGeom prst="rect">
-            <a:avLst/>
-          </a:prstGeom>
-          <a:solidFill>
-            <a:srgbClr val="888888"/>
-          </a:solidFill>
-          <a:ln>
-            <a:noFill/>
-          </a:ln>
-        </p:spPr>
-        <p:style>
-          <a:lnRef idx="1">
-            <a:schemeClr val="accent1"/>
-          </a:lnRef>
-          <a:fillRef idx="3">
-            <a:schemeClr val="accent1"/>
-          </a:fillRef>
-          <a:effectRef idx="2">
-            <a:schemeClr val="accent1"/>
-          </a:effectRef>
-          <a:fontRef idx="minor">
-            <a:schemeClr val="lt1"/>
-          </a:fontRef>
-        </p:style>
-        <p:txBody>
-          <a:bodyPr rtlCol="0" anchor="ctr"/>
-          <a:lstStyle/>
-          <a:p>
-            <a:pPr algn="ctr"/>
-          </a:p>
-        </p:txBody>
-      </p:sp>
-      <p:sp>
-        <p:nvSpPr>
-          <p:cNvPr id="36" name="TextBox 35"/>
-          <p:cNvSpPr txBox="1"/>
-          <p:nvPr/>
-        </p:nvSpPr>
-        <p:spPr>
-          <a:xfrm>
-            <a:off x="6135600" y="2059200"/>
-            <a:ext cx="2551199" cy="255600"/>
-          </a:xfrm>
-          <a:prstGeom prst="rect">
-            <a:avLst/>
-          </a:prstGeom>
-          <a:noFill/>
-        </p:spPr>
-        <p:txBody>
-          <a:bodyPr wrap="square">
-            <a:spAutoFit/>
-          </a:bodyPr>
-          <a:lstStyle/>
-          <a:p>
-            <a:pPr algn="l"/>
-            <a:r>
-              <a:rPr sz="1000" b="1" i="0">
-                <a:solidFill>
-                  <a:srgbClr val="1B3A6B"/>
-                </a:solidFill>
-                <a:latin typeface="Calibri"/>
-              </a:rPr>
-              <a:t>International</a:t>
-            </a:r>
-          </a:p>
-        </p:txBody>
-      </p:sp>
-      <p:sp>
-        <p:nvSpPr>
-          <p:cNvPr id="37" name="TextBox 36"/>
-          <p:cNvSpPr txBox="1"/>
-          <p:nvPr/>
-        </p:nvSpPr>
-        <p:spPr>
-          <a:xfrm>
-            <a:off x="6135600" y="2332800"/>
-            <a:ext cx="2551199" cy="2041199"/>
-          </a:xfrm>
-          <a:prstGeom prst="rect">
-            <a:avLst/>
-          </a:prstGeom>
-          <a:noFill/>
-        </p:spPr>
-        <p:txBody>
-          <a:bodyPr wrap="square">
-            <a:spAutoFit/>
-          </a:bodyPr>
-          <a:lstStyle/>
-          <a:p>
-            <a:pPr algn="l"/>
-            <a:r>
-              <a:rPr sz="800" b="0" i="0">
-                <a:solidFill>
-                  <a:srgbClr val="555555"/>
-                </a:solidFill>
-                <a:latin typeface="Calibri"/>
-              </a:rPr>
-              <a:t>—</a:t>
+              <a:t>Batteries Powerwall/Powerpack, solutions solaires et stockage d'énergie pour résidentiel et industriel. Modèle basé sur des contrats récurrents et des ventes de matériel. Clients cibles : ménages et entreprises cherchant autonomie énergétique.</a:t>
             </a:r>
           </a:p>
         </p:txBody>
@@ -28316,7 +29186,7 @@
                 </a:solidFill>
                 <a:latin typeface="Calibri"/>
               </a:rPr>
-              <a:t>USD millions  ·  2022–2025</a:t>
+              <a:t>USD millions  ·  2022–2027F</a:t>
             </a:r>
           </a:p>
         </p:txBody>
@@ -28331,7 +29201,7 @@
         </p:nvGraphicFramePr>
         <p:xfrm>
           <a:off x="367200" y="914400"/>
-          <a:ext cx="8413200" cy="1980000"/>
+          <a:ext cx="8413196" cy="1980000"/>
         </p:xfrm>
         <a:graphic>
           <a:graphicData uri="http://schemas.openxmlformats.org/drawingml/2006/table">
@@ -28341,9 +29211,11 @@
               </a:tblPr>
               <a:tblGrid>
                 <a:gridCol w="2355696"/>
-                <a:gridCol w="2019168"/>
-                <a:gridCol w="2019168"/>
-                <a:gridCol w="2019168"/>
+                <a:gridCol w="1211500"/>
+                <a:gridCol w="1211500"/>
+                <a:gridCol w="1211500"/>
+                <a:gridCol w="1211500"/>
+                <a:gridCol w="1211500"/>
               </a:tblGrid>
               <a:tr h="220000">
                 <a:tc>
@@ -28438,6 +29310,52 @@
                     </a:solidFill>
                   </a:tcPr>
                 </a:tc>
+                <a:tc>
+                  <a:txBody>
+                    <a:bodyPr/>
+                    <a:lstStyle/>
+                    <a:p>
+                      <a:pPr algn="ctr"/>
+                      <a:r>
+                        <a:rPr sz="800" b="1" i="0">
+                          <a:solidFill>
+                            <a:srgbClr val="FFFFFF"/>
+                          </a:solidFill>
+                          <a:latin typeface="Calibri"/>
+                        </a:rPr>
+                        <a:t>2026F</a:t>
+                      </a:r>
+                    </a:p>
+                  </a:txBody>
+                  <a:tcPr>
+                    <a:solidFill>
+                      <a:srgbClr val="1B3A6B"/>
+                    </a:solidFill>
+                  </a:tcPr>
+                </a:tc>
+                <a:tc>
+                  <a:txBody>
+                    <a:bodyPr/>
+                    <a:lstStyle/>
+                    <a:p>
+                      <a:pPr algn="ctr"/>
+                      <a:r>
+                        <a:rPr sz="800" b="1" i="0">
+                          <a:solidFill>
+                            <a:srgbClr val="FFFFFF"/>
+                          </a:solidFill>
+                          <a:latin typeface="Calibri"/>
+                        </a:rPr>
+                        <a:t>2027F</a:t>
+                      </a:r>
+                    </a:p>
+                  </a:txBody>
+                  <a:tcPr>
+                    <a:solidFill>
+                      <a:srgbClr val="1B3A6B"/>
+                    </a:solidFill>
+                  </a:tcPr>
+                </a:tc>
               </a:tr>
               <a:tr h="220000">
                 <a:tc>
@@ -28532,6 +29450,52 @@
                     </a:solidFill>
                   </a:tcPr>
                 </a:tc>
+                <a:tc>
+                  <a:txBody>
+                    <a:bodyPr/>
+                    <a:lstStyle/>
+                    <a:p>
+                      <a:pPr algn="ctr"/>
+                      <a:r>
+                        <a:rPr sz="800" b="1" i="0">
+                          <a:solidFill>
+                            <a:srgbClr val="0D0D0D"/>
+                          </a:solidFill>
+                          <a:latin typeface="Calibri"/>
+                        </a:rPr>
+                        <a:t>105,0</a:t>
+                      </a:r>
+                    </a:p>
+                  </a:txBody>
+                  <a:tcPr>
+                    <a:solidFill>
+                      <a:srgbClr val="FFFFFF"/>
+                    </a:solidFill>
+                  </a:tcPr>
+                </a:tc>
+                <a:tc>
+                  <a:txBody>
+                    <a:bodyPr/>
+                    <a:lstStyle/>
+                    <a:p>
+                      <a:pPr algn="ctr"/>
+                      <a:r>
+                        <a:rPr sz="800" b="1" i="0">
+                          <a:solidFill>
+                            <a:srgbClr val="0D0D0D"/>
+                          </a:solidFill>
+                          <a:latin typeface="Calibri"/>
+                        </a:rPr>
+                        <a:t>120,0</a:t>
+                      </a:r>
+                    </a:p>
+                  </a:txBody>
+                  <a:tcPr>
+                    <a:solidFill>
+                      <a:srgbClr val="FFFFFF"/>
+                    </a:solidFill>
+                  </a:tcPr>
+                </a:tc>
               </a:tr>
               <a:tr h="220000">
                 <a:tc>
@@ -28626,6 +29590,52 @@
                     </a:solidFill>
                   </a:tcPr>
                 </a:tc>
+                <a:tc>
+                  <a:txBody>
+                    <a:bodyPr/>
+                    <a:lstStyle/>
+                    <a:p>
+                      <a:pPr algn="ctr"/>
+                      <a:r>
+                        <a:rPr sz="750" b="0" i="1">
+                          <a:solidFill>
+                            <a:srgbClr val="555555"/>
+                          </a:solidFill>
+                          <a:latin typeface="Calibri"/>
+                        </a:rPr>
+                        <a:t>+10,7 %</a:t>
+                      </a:r>
+                    </a:p>
+                  </a:txBody>
+                  <a:tcPr>
+                    <a:solidFill>
+                      <a:srgbClr val="F7F8FA"/>
+                    </a:solidFill>
+                  </a:tcPr>
+                </a:tc>
+                <a:tc>
+                  <a:txBody>
+                    <a:bodyPr/>
+                    <a:lstStyle/>
+                    <a:p>
+                      <a:pPr algn="ctr"/>
+                      <a:r>
+                        <a:rPr sz="750" b="0" i="1">
+                          <a:solidFill>
+                            <a:srgbClr val="555555"/>
+                          </a:solidFill>
+                          <a:latin typeface="Calibri"/>
+                        </a:rPr>
+                        <a:t>+14,3 %</a:t>
+                      </a:r>
+                    </a:p>
+                  </a:txBody>
+                  <a:tcPr>
+                    <a:solidFill>
+                      <a:srgbClr val="F7F8FA"/>
+                    </a:solidFill>
+                  </a:tcPr>
+                </a:tc>
               </a:tr>
               <a:tr h="220000">
                 <a:tc>
@@ -28720,6 +29730,52 @@
                     </a:solidFill>
                   </a:tcPr>
                 </a:tc>
+                <a:tc>
+                  <a:txBody>
+                    <a:bodyPr/>
+                    <a:lstStyle/>
+                    <a:p>
+                      <a:pPr algn="ctr"/>
+                      <a:r>
+                        <a:rPr sz="800" b="1" i="0">
+                          <a:solidFill>
+                            <a:srgbClr val="0D0D0D"/>
+                          </a:solidFill>
+                          <a:latin typeface="Calibri"/>
+                        </a:rPr>
+                        <a:t>20,5</a:t>
+                      </a:r>
+                    </a:p>
+                  </a:txBody>
+                  <a:tcPr>
+                    <a:solidFill>
+                      <a:srgbClr val="FFFFFF"/>
+                    </a:solidFill>
+                  </a:tcPr>
+                </a:tc>
+                <a:tc>
+                  <a:txBody>
+                    <a:bodyPr/>
+                    <a:lstStyle/>
+                    <a:p>
+                      <a:pPr algn="ctr"/>
+                      <a:r>
+                        <a:rPr sz="800" b="1" i="0">
+                          <a:solidFill>
+                            <a:srgbClr val="0D0D0D"/>
+                          </a:solidFill>
+                          <a:latin typeface="Calibri"/>
+                        </a:rPr>
+                        <a:t>24,6</a:t>
+                      </a:r>
+                    </a:p>
+                  </a:txBody>
+                  <a:tcPr>
+                    <a:solidFill>
+                      <a:srgbClr val="FFFFFF"/>
+                    </a:solidFill>
+                  </a:tcPr>
+                </a:tc>
               </a:tr>
               <a:tr h="220000">
                 <a:tc>
@@ -28814,6 +29870,52 @@
                     </a:solidFill>
                   </a:tcPr>
                 </a:tc>
+                <a:tc>
+                  <a:txBody>
+                    <a:bodyPr/>
+                    <a:lstStyle/>
+                    <a:p>
+                      <a:pPr algn="ctr"/>
+                      <a:r>
+                        <a:rPr sz="750" b="0" i="1">
+                          <a:solidFill>
+                            <a:srgbClr val="555555"/>
+                          </a:solidFill>
+                          <a:latin typeface="Calibri"/>
+                        </a:rPr>
+                        <a:t>19,5 %</a:t>
+                      </a:r>
+                    </a:p>
+                  </a:txBody>
+                  <a:tcPr>
+                    <a:solidFill>
+                      <a:srgbClr val="F7F8FA"/>
+                    </a:solidFill>
+                  </a:tcPr>
+                </a:tc>
+                <a:tc>
+                  <a:txBody>
+                    <a:bodyPr/>
+                    <a:lstStyle/>
+                    <a:p>
+                      <a:pPr algn="ctr"/>
+                      <a:r>
+                        <a:rPr sz="750" b="0" i="1">
+                          <a:solidFill>
+                            <a:srgbClr val="555555"/>
+                          </a:solidFill>
+                          <a:latin typeface="Calibri"/>
+                        </a:rPr>
+                        <a:t>20,5 %</a:t>
+                      </a:r>
+                    </a:p>
+                  </a:txBody>
+                  <a:tcPr>
+                    <a:solidFill>
+                      <a:srgbClr val="F7F8FA"/>
+                    </a:solidFill>
+                  </a:tcPr>
+                </a:tc>
               </a:tr>
               <a:tr h="220000">
                 <a:tc>
@@ -28908,6 +30010,52 @@
                     </a:solidFill>
                   </a:tcPr>
                 </a:tc>
+                <a:tc>
+                  <a:txBody>
+                    <a:bodyPr/>
+                    <a:lstStyle/>
+                    <a:p>
+                      <a:pPr algn="ctr"/>
+                      <a:r>
+                        <a:rPr sz="800" b="1" i="0">
+                          <a:solidFill>
+                            <a:srgbClr val="0D0D0D"/>
+                          </a:solidFill>
+                          <a:latin typeface="Calibri"/>
+                        </a:rPr>
+                        <a:t>18,0</a:t>
+                      </a:r>
+                    </a:p>
+                  </a:txBody>
+                  <a:tcPr>
+                    <a:solidFill>
+                      <a:srgbClr val="FFFFFF"/>
+                    </a:solidFill>
+                  </a:tcPr>
+                </a:tc>
+                <a:tc>
+                  <a:txBody>
+                    <a:bodyPr/>
+                    <a:lstStyle/>
+                    <a:p>
+                      <a:pPr algn="ctr"/>
+                      <a:r>
+                        <a:rPr sz="800" b="1" i="0">
+                          <a:solidFill>
+                            <a:srgbClr val="0D0D0D"/>
+                          </a:solidFill>
+                          <a:latin typeface="Calibri"/>
+                        </a:rPr>
+                        <a:t>22,0</a:t>
+                      </a:r>
+                    </a:p>
+                  </a:txBody>
+                  <a:tcPr>
+                    <a:solidFill>
+                      <a:srgbClr val="FFFFFF"/>
+                    </a:solidFill>
+                  </a:tcPr>
+                </a:tc>
               </a:tr>
               <a:tr h="220000">
                 <a:tc>
@@ -29002,6 +30150,52 @@
                     </a:solidFill>
                   </a:tcPr>
                 </a:tc>
+                <a:tc>
+                  <a:txBody>
+                    <a:bodyPr/>
+                    <a:lstStyle/>
+                    <a:p>
+                      <a:pPr algn="ctr"/>
+                      <a:r>
+                        <a:rPr sz="750" b="0" i="1">
+                          <a:solidFill>
+                            <a:srgbClr val="555555"/>
+                          </a:solidFill>
+                          <a:latin typeface="Calibri"/>
+                        </a:rPr>
+                        <a:t>17,1 %</a:t>
+                      </a:r>
+                    </a:p>
+                  </a:txBody>
+                  <a:tcPr>
+                    <a:solidFill>
+                      <a:srgbClr val="F7F8FA"/>
+                    </a:solidFill>
+                  </a:tcPr>
+                </a:tc>
+                <a:tc>
+                  <a:txBody>
+                    <a:bodyPr/>
+                    <a:lstStyle/>
+                    <a:p>
+                      <a:pPr algn="ctr"/>
+                      <a:r>
+                        <a:rPr sz="750" b="0" i="1">
+                          <a:solidFill>
+                            <a:srgbClr val="555555"/>
+                          </a:solidFill>
+                          <a:latin typeface="Calibri"/>
+                        </a:rPr>
+                        <a:t>18,3 %</a:t>
+                      </a:r>
+                    </a:p>
+                  </a:txBody>
+                  <a:tcPr>
+                    <a:solidFill>
+                      <a:srgbClr val="F7F8FA"/>
+                    </a:solidFill>
+                  </a:tcPr>
+                </a:tc>
               </a:tr>
               <a:tr h="220000">
                 <a:tc>
@@ -29096,6 +30290,52 @@
                     </a:solidFill>
                   </a:tcPr>
                 </a:tc>
+                <a:tc>
+                  <a:txBody>
+                    <a:bodyPr/>
+                    <a:lstStyle/>
+                    <a:p>
+                      <a:pPr algn="ctr"/>
+                      <a:r>
+                        <a:rPr sz="800" b="1" i="0">
+                          <a:solidFill>
+                            <a:srgbClr val="0D0D0D"/>
+                          </a:solidFill>
+                          <a:latin typeface="Calibri"/>
+                        </a:rPr>
+                        <a:t>7,0</a:t>
+                      </a:r>
+                    </a:p>
+                  </a:txBody>
+                  <a:tcPr>
+                    <a:solidFill>
+                      <a:srgbClr val="FFFFFF"/>
+                    </a:solidFill>
+                  </a:tcPr>
+                </a:tc>
+                <a:tc>
+                  <a:txBody>
+                    <a:bodyPr/>
+                    <a:lstStyle/>
+                    <a:p>
+                      <a:pPr algn="ctr"/>
+                      <a:r>
+                        <a:rPr sz="800" b="1" i="0">
+                          <a:solidFill>
+                            <a:srgbClr val="0D0D0D"/>
+                          </a:solidFill>
+                          <a:latin typeface="Calibri"/>
+                        </a:rPr>
+                        <a:t>9,0</a:t>
+                      </a:r>
+                    </a:p>
+                  </a:txBody>
+                  <a:tcPr>
+                    <a:solidFill>
+                      <a:srgbClr val="FFFFFF"/>
+                    </a:solidFill>
+                  </a:tcPr>
+                </a:tc>
               </a:tr>
               <a:tr h="220000">
                 <a:tc>
@@ -29187,6 +30427,52 @@
                   <a:tcPr>
                     <a:solidFill>
                       <a:srgbClr val="DDE8F5"/>
+                    </a:solidFill>
+                  </a:tcPr>
+                </a:tc>
+                <a:tc>
+                  <a:txBody>
+                    <a:bodyPr/>
+                    <a:lstStyle/>
+                    <a:p>
+                      <a:pPr algn="ctr"/>
+                      <a:r>
+                        <a:rPr sz="750" b="0" i="1">
+                          <a:solidFill>
+                            <a:srgbClr val="555555"/>
+                          </a:solidFill>
+                          <a:latin typeface="Calibri"/>
+                        </a:rPr>
+                        <a:t>6,7 %</a:t>
+                      </a:r>
+                    </a:p>
+                  </a:txBody>
+                  <a:tcPr>
+                    <a:solidFill>
+                      <a:srgbClr val="F7F8FA"/>
+                    </a:solidFill>
+                  </a:tcPr>
+                </a:tc>
+                <a:tc>
+                  <a:txBody>
+                    <a:bodyPr/>
+                    <a:lstStyle/>
+                    <a:p>
+                      <a:pPr algn="ctr"/>
+                      <a:r>
+                        <a:rPr sz="750" b="0" i="1">
+                          <a:solidFill>
+                            <a:srgbClr val="555555"/>
+                          </a:solidFill>
+                          <a:latin typeface="Calibri"/>
+                        </a:rPr>
+                        <a:t>7,5 %</a:t>
+                      </a:r>
+                    </a:p>
+                  </a:txBody>
+                  <a:tcPr>
+                    <a:solidFill>
+                      <a:srgbClr val="F7F8FA"/>
                     </a:solidFill>
                   </a:tcPr>
                 </a:tc>
@@ -29195,6 +30481,41 @@
           </a:graphicData>
         </a:graphic>
       </p:graphicFrame>
+      <p:sp>
+        <p:nvSpPr>
+          <p:cNvPr id="18" name="TextBox 17"/>
+          <p:cNvSpPr txBox="1"/>
+          <p:nvPr/>
+        </p:nvSpPr>
+        <p:spPr>
+          <a:xfrm>
+            <a:off x="367200" y="3218400"/>
+            <a:ext cx="8413200" cy="1224000"/>
+          </a:xfrm>
+          <a:prstGeom prst="rect">
+            <a:avLst/>
+          </a:prstGeom>
+          <a:noFill/>
+        </p:spPr>
+        <p:txBody>
+          <a:bodyPr wrap="square">
+            <a:spAutoFit/>
+          </a:bodyPr>
+          <a:lstStyle/>
+          <a:p>
+            <a:pPr algn="l"/>
+            <a:r>
+              <a:rPr sz="850" b="0" i="0">
+                <a:solidFill>
+                  <a:srgbClr val="555555"/>
+                </a:solidFill>
+                <a:latin typeface="Calibri"/>
+              </a:rPr>
+              <a:t>Le CA 2025 recule de 3% à 94.8Md$, avec des marges en compression (GM 18%, Net 4%) due à des baisses de prix agressives et à des coûts fixes élevés. La discipline opérationnelle et le levier sur les volumes devraient permettre une amélioration progressive des marges dès 2026.</a:t>
+            </a:r>
+          </a:p>
+        </p:txBody>
+      </p:sp>
     </p:spTree>
   </p:cSld>
   <p:clrMapOvr>
@@ -30922,7 +32243,7 @@
                           </a:solidFill>
                           <a:latin typeface="Calibri"/>
                         </a:rPr>
-                        <a:t>16,85</a:t>
+                        <a:t>16,78</a:t>
                       </a:r>
                     </a:p>
                   </a:txBody>
@@ -31077,6 +32398,41 @@
           </a:graphicData>
         </a:graphic>
       </p:graphicFrame>
+      <p:sp>
+        <p:nvSpPr>
+          <p:cNvPr id="31" name="TextBox 30"/>
+          <p:cNvSpPr txBox="1"/>
+          <p:nvPr/>
+        </p:nvSpPr>
+        <p:spPr>
+          <a:xfrm>
+            <a:off x="367200" y="4068000"/>
+            <a:ext cx="8413200" cy="468000"/>
+          </a:xfrm>
+          <a:prstGeom prst="rect">
+            <a:avLst/>
+          </a:prstGeom>
+          <a:noFill/>
+        </p:spPr>
+        <p:txBody>
+          <a:bodyPr wrap="square">
+            <a:spAutoFit/>
+          </a:bodyPr>
+          <a:lstStyle/>
+          <a:p>
+            <a:pPr algn="l"/>
+            <a:r>
+              <a:rPr sz="850" b="0" i="0">
+                <a:solidFill>
+                  <a:srgbClr val="555555"/>
+                </a:solidFill>
+                <a:latin typeface="Calibri"/>
+              </a:rPr>
+              <a:t>Le CA 2025 recule de 3% à 94.8Md$, avec des marges en compression (GM 18%, Net 4%) due à des baisses de prix agressives et à des coûts fixes élevés. La discipline opérationnelle et le levier sur les volumes devraient permettre une amélioration progressive des marges dès 2026.</a:t>
+            </a:r>
+          </a:p>
+        </p:txBody>
+      </p:sp>
     </p:spTree>
   </p:cSld>
   <p:clrMapOvr>

</xml_diff>

<commit_message>
chore(preview): TSLA outputs restaures v2 (LLM OK + fixes)
</commit_message>
<xml_diff>
--- a/preview/TSLA/TSLA_pitchbook.pptx
+++ b/preview/TSLA/TSLA_pitchbook.pptx
@@ -3410,7 +3410,7 @@
                 </a:solidFill>
                 <a:latin typeface="Calibri"/>
               </a:rPr>
-              <a:t>● HOLD  ·  Prix cible base : — $  ·  Upside : —</a:t>
+              <a:t>● HOLD  ·  Prix cible base : 380 $  ·  Upside : +10,7 %</a:t>
             </a:r>
           </a:p>
         </p:txBody>
@@ -6069,6 +6069,127 @@
           </a:graphicData>
         </a:graphic>
       </p:graphicFrame>
+      <p:sp>
+        <p:nvSpPr>
+          <p:cNvPr id="18" name="Rectangle 17"/>
+          <p:cNvSpPr/>
+          <p:nvPr/>
+        </p:nvSpPr>
+        <p:spPr>
+          <a:xfrm>
+            <a:off x="367200" y="3628800"/>
+            <a:ext cx="8413200" cy="824400"/>
+          </a:xfrm>
+          <a:prstGeom prst="rect">
+            <a:avLst/>
+          </a:prstGeom>
+          <a:solidFill>
+            <a:srgbClr val="F5F7FA"/>
+          </a:solidFill>
+          <a:ln>
+            <a:noFill/>
+          </a:ln>
+        </p:spPr>
+        <p:style>
+          <a:lnRef idx="1">
+            <a:schemeClr val="accent1"/>
+          </a:lnRef>
+          <a:fillRef idx="3">
+            <a:schemeClr val="accent1"/>
+          </a:fillRef>
+          <a:effectRef idx="2">
+            <a:schemeClr val="accent1"/>
+          </a:effectRef>
+          <a:fontRef idx="minor">
+            <a:schemeClr val="lt1"/>
+          </a:fontRef>
+        </p:style>
+        <p:txBody>
+          <a:bodyPr rtlCol="0" anchor="ctr"/>
+          <a:lstStyle/>
+          <a:p>
+            <a:pPr algn="ctr"/>
+          </a:p>
+        </p:txBody>
+      </p:sp>
+      <p:sp>
+        <p:nvSpPr>
+          <p:cNvPr id="19" name="Rectangle 18"/>
+          <p:cNvSpPr/>
+          <p:nvPr/>
+        </p:nvSpPr>
+        <p:spPr>
+          <a:xfrm>
+            <a:off x="367200" y="3628800"/>
+            <a:ext cx="79200" cy="824400"/>
+          </a:xfrm>
+          <a:prstGeom prst="rect">
+            <a:avLst/>
+          </a:prstGeom>
+          <a:solidFill>
+            <a:srgbClr val="2E5FA3"/>
+          </a:solidFill>
+          <a:ln>
+            <a:noFill/>
+          </a:ln>
+        </p:spPr>
+        <p:style>
+          <a:lnRef idx="1">
+            <a:schemeClr val="accent1"/>
+          </a:lnRef>
+          <a:fillRef idx="3">
+            <a:schemeClr val="accent1"/>
+          </a:fillRef>
+          <a:effectRef idx="2">
+            <a:schemeClr val="accent1"/>
+          </a:effectRef>
+          <a:fontRef idx="minor">
+            <a:schemeClr val="lt1"/>
+          </a:fontRef>
+        </p:style>
+        <p:txBody>
+          <a:bodyPr rtlCol="0" anchor="ctr"/>
+          <a:lstStyle/>
+          <a:p>
+            <a:pPr algn="ctr"/>
+          </a:p>
+        </p:txBody>
+      </p:sp>
+      <p:sp>
+        <p:nvSpPr>
+          <p:cNvPr id="20" name="TextBox 19"/>
+          <p:cNvSpPr txBox="1"/>
+          <p:nvPr/>
+        </p:nvSpPr>
+        <p:spPr>
+          <a:xfrm>
+            <a:off x="475200" y="3657600"/>
+            <a:ext cx="8298000" cy="788400"/>
+          </a:xfrm>
+          <a:prstGeom prst="rect">
+            <a:avLst/>
+          </a:prstGeom>
+          <a:noFill/>
+        </p:spPr>
+        <p:txBody>
+          <a:bodyPr wrap="square">
+            <a:spAutoFit/>
+          </a:bodyPr>
+          <a:lstStyle/>
+          <a:p>
+            <a:pPr algn="l"/>
+            <a:r>
+              <a:rPr sz="850" b="0" i="0">
+                <a:solidFill>
+                  <a:srgbClr val="555555"/>
+                </a:solidFill>
+                <a:latin typeface="Calibri"/>
+              </a:rPr>
+              <a:t>Les marges ont chuté de 25.6% (GM 2022) à 18.0% (2025) et de 21.7% (EBITDA 2022) à 12.4% (2025), principalement à cause de la guerre des prix sur les VE et de l'inflation des coûts. La résilience des marges nettes (15.5% en 2023 vs 4.0% en 2025) masque une dégradation structurelle. Le pricing power semble affaibli, avec un risque de mean-reversion si la concurrence s'intensifie.</a:t>
+            </a:r>
+          </a:p>
+        </p:txBody>
+      </p:sp>
     </p:spTree>
   </p:cSld>
   <p:clrMapOvr>
@@ -7229,7 +7350,7 @@
                           </a:solidFill>
                           <a:latin typeface="Calibri"/>
                         </a:rPr>
-                        <a:t>—</a:t>
+                        <a:t>380 $</a:t>
                       </a:r>
                     </a:p>
                   </a:txBody>
@@ -7405,7 +7526,7 @@
                           </a:solidFill>
                           <a:latin typeface="Calibri"/>
                         </a:rPr>
-                        <a:t>—</a:t>
+                        <a:t>+10,7 %</a:t>
                       </a:r>
                     </a:p>
                   </a:txBody>
@@ -7548,7 +7669,7 @@
                           </a:solidFill>
                           <a:latin typeface="Calibri"/>
                         </a:rPr>
-                        <a:t>—</a:t>
+                        <a:t>290 $</a:t>
                       </a:r>
                     </a:p>
                   </a:txBody>
@@ -7571,7 +7692,7 @@
                           </a:solidFill>
                           <a:latin typeface="Calibri"/>
                         </a:rPr>
-                        <a:t>—</a:t>
+                        <a:t>380 $</a:t>
                       </a:r>
                     </a:p>
                   </a:txBody>
@@ -7594,7 +7715,7 @@
                           </a:solidFill>
                           <a:latin typeface="Calibri"/>
                         </a:rPr>
-                        <a:t>—</a:t>
+                        <a:t>450 $</a:t>
                       </a:r>
                     </a:p>
                   </a:txBody>
@@ -7619,7 +7740,7 @@
                           </a:solidFill>
                           <a:latin typeface="Calibri"/>
                         </a:rPr>
-                        <a:t>—</a:t>
+                        <a:t>-15,5 %</a:t>
                       </a:r>
                     </a:p>
                   </a:txBody>
@@ -7642,7 +7763,7 @@
                           </a:solidFill>
                           <a:latin typeface="Calibri"/>
                         </a:rPr>
-                        <a:t>—</a:t>
+                        <a:t>+10,7 %</a:t>
                       </a:r>
                     </a:p>
                   </a:txBody>
@@ -7665,7 +7786,7 @@
                           </a:solidFill>
                           <a:latin typeface="Calibri"/>
                         </a:rPr>
-                        <a:t>—</a:t>
+                        <a:t>+31,1 %</a:t>
                       </a:r>
                     </a:p>
                   </a:txBody>
@@ -8977,7 +9098,7 @@
                           </a:solidFill>
                           <a:latin typeface="Calibri"/>
                         </a:rPr>
-                        <a:t>—</a:t>
+                        <a:t>414</a:t>
                       </a:r>
                     </a:p>
                   </a:txBody>
@@ -9020,7 +9141,7 @@
                           </a:solidFill>
                           <a:latin typeface="Calibri"/>
                         </a:rPr>
-                        <a:t>—</a:t>
+                        <a:t>433</a:t>
                       </a:r>
                     </a:p>
                   </a:txBody>
@@ -9063,7 +9184,7 @@
                           </a:solidFill>
                           <a:latin typeface="Calibri"/>
                         </a:rPr>
-                        <a:t>—</a:t>
+                        <a:t>454</a:t>
                       </a:r>
                     </a:p>
                   </a:txBody>
@@ -9106,7 +9227,7 @@
                           </a:solidFill>
                           <a:latin typeface="Calibri"/>
                         </a:rPr>
-                        <a:t>—</a:t>
+                        <a:t>477</a:t>
                       </a:r>
                     </a:p>
                   </a:txBody>
@@ -9149,7 +9270,7 @@
                           </a:solidFill>
                           <a:latin typeface="Calibri"/>
                         </a:rPr>
-                        <a:t>—</a:t>
+                        <a:t>503</a:t>
                       </a:r>
                     </a:p>
                   </a:txBody>
@@ -9237,7 +9358,7 @@
                           </a:solidFill>
                           <a:latin typeface="Calibri"/>
                         </a:rPr>
-                        <a:t>—</a:t>
+                        <a:t>380</a:t>
                       </a:r>
                     </a:p>
                   </a:txBody>
@@ -9280,7 +9401,7 @@
                           </a:solidFill>
                           <a:latin typeface="Calibri"/>
                         </a:rPr>
-                        <a:t>—</a:t>
+                        <a:t>396</a:t>
                       </a:r>
                     </a:p>
                   </a:txBody>
@@ -9323,7 +9444,7 @@
                           </a:solidFill>
                           <a:latin typeface="Calibri"/>
                         </a:rPr>
-                        <a:t>—</a:t>
+                        <a:t>414</a:t>
                       </a:r>
                     </a:p>
                   </a:txBody>
@@ -9366,7 +9487,7 @@
                           </a:solidFill>
                           <a:latin typeface="Calibri"/>
                         </a:rPr>
-                        <a:t>—</a:t>
+                        <a:t>433</a:t>
                       </a:r>
                     </a:p>
                   </a:txBody>
@@ -9409,7 +9530,7 @@
                           </a:solidFill>
                           <a:latin typeface="Calibri"/>
                         </a:rPr>
-                        <a:t>—</a:t>
+                        <a:t>454</a:t>
                       </a:r>
                     </a:p>
                   </a:txBody>
@@ -9497,7 +9618,7 @@
                           </a:solidFill>
                           <a:latin typeface="Calibri"/>
                         </a:rPr>
-                        <a:t>—</a:t>
+                        <a:t>351</a:t>
                       </a:r>
                     </a:p>
                   </a:txBody>
@@ -9540,7 +9661,7 @@
                           </a:solidFill>
                           <a:latin typeface="Calibri"/>
                         </a:rPr>
-                        <a:t>—</a:t>
+                        <a:t>365</a:t>
                       </a:r>
                     </a:p>
                   </a:txBody>
@@ -9583,7 +9704,7 @@
                           </a:solidFill>
                           <a:latin typeface="Calibri"/>
                         </a:rPr>
-                        <a:t>—</a:t>
+                        <a:t>380</a:t>
                       </a:r>
                     </a:p>
                   </a:txBody>
@@ -9626,7 +9747,7 @@
                           </a:solidFill>
                           <a:latin typeface="Calibri"/>
                         </a:rPr>
-                        <a:t>—</a:t>
+                        <a:t>396</a:t>
                       </a:r>
                     </a:p>
                   </a:txBody>
@@ -9669,7 +9790,7 @@
                           </a:solidFill>
                           <a:latin typeface="Calibri"/>
                         </a:rPr>
-                        <a:t>—</a:t>
+                        <a:t>414</a:t>
                       </a:r>
                     </a:p>
                   </a:txBody>
@@ -9757,7 +9878,7 @@
                           </a:solidFill>
                           <a:latin typeface="Calibri"/>
                         </a:rPr>
-                        <a:t>—</a:t>
+                        <a:t>327</a:t>
                       </a:r>
                     </a:p>
                   </a:txBody>
@@ -9800,7 +9921,7 @@
                           </a:solidFill>
                           <a:latin typeface="Calibri"/>
                         </a:rPr>
-                        <a:t>—</a:t>
+                        <a:t>339</a:t>
                       </a:r>
                     </a:p>
                   </a:txBody>
@@ -9843,7 +9964,7 @@
                           </a:solidFill>
                           <a:latin typeface="Calibri"/>
                         </a:rPr>
-                        <a:t>—</a:t>
+                        <a:t>351</a:t>
                       </a:r>
                     </a:p>
                   </a:txBody>
@@ -9886,7 +10007,7 @@
                           </a:solidFill>
                           <a:latin typeface="Calibri"/>
                         </a:rPr>
-                        <a:t>—</a:t>
+                        <a:t>365</a:t>
                       </a:r>
                     </a:p>
                   </a:txBody>
@@ -9929,7 +10050,7 @@
                           </a:solidFill>
                           <a:latin typeface="Calibri"/>
                         </a:rPr>
-                        <a:t>—</a:t>
+                        <a:t>380</a:t>
                       </a:r>
                     </a:p>
                   </a:txBody>
@@ -10017,7 +10138,7 @@
                           </a:solidFill>
                           <a:latin typeface="Calibri"/>
                         </a:rPr>
-                        <a:t>—</a:t>
+                        <a:t>305</a:t>
                       </a:r>
                     </a:p>
                   </a:txBody>
@@ -10060,7 +10181,7 @@
                           </a:solidFill>
                           <a:latin typeface="Calibri"/>
                         </a:rPr>
-                        <a:t>—</a:t>
+                        <a:t>316</a:t>
                       </a:r>
                     </a:p>
                   </a:txBody>
@@ -10103,7 +10224,7 @@
                           </a:solidFill>
                           <a:latin typeface="Calibri"/>
                         </a:rPr>
-                        <a:t>—</a:t>
+                        <a:t>327</a:t>
                       </a:r>
                     </a:p>
                   </a:txBody>
@@ -10146,7 +10267,7 @@
                           </a:solidFill>
                           <a:latin typeface="Calibri"/>
                         </a:rPr>
-                        <a:t>—</a:t>
+                        <a:t>339</a:t>
                       </a:r>
                     </a:p>
                   </a:txBody>
@@ -10189,7 +10310,7 @@
                           </a:solidFill>
                           <a:latin typeface="Calibri"/>
                         </a:rPr>
-                        <a:t>—</a:t>
+                        <a:t>351</a:t>
                       </a:r>
                     </a:p>
                   </a:txBody>
@@ -10224,6 +10345,127 @@
           </a:graphicData>
         </a:graphic>
       </p:graphicFrame>
+      <p:sp>
+        <p:nvSpPr>
+          <p:cNvPr id="22" name="Rectangle 21"/>
+          <p:cNvSpPr/>
+          <p:nvPr/>
+        </p:nvSpPr>
+        <p:spPr>
+          <a:xfrm>
+            <a:off x="367200" y="3916800"/>
+            <a:ext cx="8413200" cy="547200"/>
+          </a:xfrm>
+          <a:prstGeom prst="rect">
+            <a:avLst/>
+          </a:prstGeom>
+          <a:solidFill>
+            <a:srgbClr val="F5F7FA"/>
+          </a:solidFill>
+          <a:ln>
+            <a:noFill/>
+          </a:ln>
+        </p:spPr>
+        <p:style>
+          <a:lnRef idx="1">
+            <a:schemeClr val="accent1"/>
+          </a:lnRef>
+          <a:fillRef idx="3">
+            <a:schemeClr val="accent1"/>
+          </a:fillRef>
+          <a:effectRef idx="2">
+            <a:schemeClr val="accent1"/>
+          </a:effectRef>
+          <a:fontRef idx="minor">
+            <a:schemeClr val="lt1"/>
+          </a:fontRef>
+        </p:style>
+        <p:txBody>
+          <a:bodyPr rtlCol="0" anchor="ctr"/>
+          <a:lstStyle/>
+          <a:p>
+            <a:pPr algn="ctr"/>
+          </a:p>
+        </p:txBody>
+      </p:sp>
+      <p:sp>
+        <p:nvSpPr>
+          <p:cNvPr id="23" name="Rectangle 22"/>
+          <p:cNvSpPr/>
+          <p:nvPr/>
+        </p:nvSpPr>
+        <p:spPr>
+          <a:xfrm>
+            <a:off x="367200" y="3916800"/>
+            <a:ext cx="79200" cy="547200"/>
+          </a:xfrm>
+          <a:prstGeom prst="rect">
+            <a:avLst/>
+          </a:prstGeom>
+          <a:solidFill>
+            <a:srgbClr val="2E5FA3"/>
+          </a:solidFill>
+          <a:ln>
+            <a:noFill/>
+          </a:ln>
+        </p:spPr>
+        <p:style>
+          <a:lnRef idx="1">
+            <a:schemeClr val="accent1"/>
+          </a:lnRef>
+          <a:fillRef idx="3">
+            <a:schemeClr val="accent1"/>
+          </a:fillRef>
+          <a:effectRef idx="2">
+            <a:schemeClr val="accent1"/>
+          </a:effectRef>
+          <a:fontRef idx="minor">
+            <a:schemeClr val="lt1"/>
+          </a:fontRef>
+        </p:style>
+        <p:txBody>
+          <a:bodyPr rtlCol="0" anchor="ctr"/>
+          <a:lstStyle/>
+          <a:p>
+            <a:pPr algn="ctr"/>
+          </a:p>
+        </p:txBody>
+      </p:sp>
+      <p:sp>
+        <p:nvSpPr>
+          <p:cNvPr id="24" name="TextBox 23"/>
+          <p:cNvSpPr txBox="1"/>
+          <p:nvPr/>
+        </p:nvSpPr>
+        <p:spPr>
+          <a:xfrm>
+            <a:off x="475200" y="3945600"/>
+            <a:ext cx="8298000" cy="511200"/>
+          </a:xfrm>
+          <a:prstGeom prst="rect">
+            <a:avLst/>
+          </a:prstGeom>
+          <a:noFill/>
+        </p:spPr>
+        <p:txBody>
+          <a:bodyPr wrap="square">
+            <a:spAutoFit/>
+          </a:bodyPr>
+          <a:lstStyle/>
+          <a:p>
+            <a:pPr algn="l"/>
+            <a:r>
+              <a:rPr sz="850" b="0" i="0">
+                <a:solidFill>
+                  <a:srgbClr val="555555"/>
+                </a:solidFill>
+                <a:latin typeface="Calibri"/>
+              </a:rPr>
+              <a:t>Avec un WACC de 14.8% et un TGR de 2.5%, le prix implicite DCF se situe entre 290 USD (bear) et 450 USD (bull), contre un cours de 343.25 USD. La prime actuelle suggère que le marché anticipe déjà une partie de la croissance future, limitant l'upside sans exécution parfaite sur les robotaxis et l'IA.</a:t>
+            </a:r>
+          </a:p>
+        </p:txBody>
+      </p:sp>
     </p:spTree>
   </p:cSld>
   <p:clrMapOvr>
@@ -10833,7 +11075,7 @@
         </p:nvGraphicFramePr>
         <p:xfrm>
           <a:off x="367200" y="914400"/>
-          <a:ext cx="8413200" cy="871200"/>
+          <a:ext cx="8413200" cy="2015999"/>
         </p:xfrm>
         <a:graphic>
           <a:graphicData uri="http://schemas.openxmlformats.org/drawingml/2006/table">
@@ -10851,7 +11093,7 @@
                 <a:gridCol w="1093716"/>
                 <a:gridCol w="1009584"/>
               </a:tblGrid>
-              <a:tr h="290400">
+              <a:tr h="251999">
                 <a:tc>
                   <a:txBody>
                     <a:bodyPr/>
@@ -11037,7 +11279,7 @@
                   </a:tcPr>
                 </a:tc>
               </a:tr>
-              <a:tr h="290400">
+              <a:tr h="251999">
                 <a:tc>
                   <a:txBody>
                     <a:bodyPr/>
@@ -11223,7 +11465,7 @@
                   </a:tcPr>
                 </a:tc>
               </a:tr>
-              <a:tr h="290400">
+              <a:tr h="251999">
                 <a:tc>
                   <a:txBody>
                     <a:bodyPr/>
@@ -11231,6 +11473,936 @@
                     <a:p>
                       <a:pPr algn="l"/>
                       <a:r>
+                        <a:rPr sz="800" b="0" i="0">
+                          <a:solidFill>
+                            <a:srgbClr val="0D0D0D"/>
+                          </a:solidFill>
+                          <a:latin typeface="Calibri"/>
+                        </a:rPr>
+                        <a:t>BYD Company</a:t>
+                      </a:r>
+                    </a:p>
+                  </a:txBody>
+                  <a:tcPr>
+                    <a:solidFill>
+                      <a:srgbClr val="FFFFFF"/>
+                    </a:solidFill>
+                  </a:tcPr>
+                </a:tc>
+                <a:tc>
+                  <a:txBody>
+                    <a:bodyPr/>
+                    <a:lstStyle/>
+                    <a:p>
+                      <a:pPr algn="ctr"/>
+                      <a:r>
+                        <a:rPr sz="750" b="0" i="0">
+                          <a:solidFill>
+                            <a:srgbClr val="555555"/>
+                          </a:solidFill>
+                          <a:latin typeface="Calibri"/>
+                        </a:rPr>
+                        <a:t>BYD.US</a:t>
+                      </a:r>
+                    </a:p>
+                  </a:txBody>
+                  <a:tcPr>
+                    <a:solidFill>
+                      <a:srgbClr val="FFFFFF"/>
+                    </a:solidFill>
+                  </a:tcPr>
+                </a:tc>
+                <a:tc>
+                  <a:txBody>
+                    <a:bodyPr/>
+                    <a:lstStyle/>
+                    <a:p>
+                      <a:pPr algn="ctr"/>
+                      <a:r>
+                        <a:rPr sz="800" b="0" i="0">
+                          <a:solidFill>
+                            <a:srgbClr val="0D0D0D"/>
+                          </a:solidFill>
+                          <a:latin typeface="Calibri"/>
+                        </a:rPr>
+                        <a:t>85,0</a:t>
+                      </a:r>
+                    </a:p>
+                  </a:txBody>
+                  <a:tcPr>
+                    <a:solidFill>
+                      <a:srgbClr val="FFFFFF"/>
+                    </a:solidFill>
+                  </a:tcPr>
+                </a:tc>
+                <a:tc>
+                  <a:txBody>
+                    <a:bodyPr/>
+                    <a:lstStyle/>
+                    <a:p>
+                      <a:pPr algn="ctr"/>
+                      <a:r>
+                        <a:rPr sz="800" b="0" i="0">
+                          <a:solidFill>
+                            <a:srgbClr val="0D0D0D"/>
+                          </a:solidFill>
+                          <a:latin typeface="Calibri"/>
+                        </a:rPr>
+                        <a:t>22,5x</a:t>
+                      </a:r>
+                    </a:p>
+                  </a:txBody>
+                  <a:tcPr>
+                    <a:solidFill>
+                      <a:srgbClr val="FFFFFF"/>
+                    </a:solidFill>
+                  </a:tcPr>
+                </a:tc>
+                <a:tc>
+                  <a:txBody>
+                    <a:bodyPr/>
+                    <a:lstStyle/>
+                    <a:p>
+                      <a:pPr algn="ctr"/>
+                      <a:r>
+                        <a:rPr sz="800" b="0" i="0">
+                          <a:solidFill>
+                            <a:srgbClr val="0D0D0D"/>
+                          </a:solidFill>
+                          <a:latin typeface="Calibri"/>
+                        </a:rPr>
+                        <a:t>3,8x</a:t>
+                      </a:r>
+                    </a:p>
+                  </a:txBody>
+                  <a:tcPr>
+                    <a:solidFill>
+                      <a:srgbClr val="FFFFFF"/>
+                    </a:solidFill>
+                  </a:tcPr>
+                </a:tc>
+                <a:tc>
+                  <a:txBody>
+                    <a:bodyPr/>
+                    <a:lstStyle/>
+                    <a:p>
+                      <a:pPr algn="ctr"/>
+                      <a:r>
+                        <a:rPr sz="800" b="0" i="0">
+                          <a:solidFill>
+                            <a:srgbClr val="0D0D0D"/>
+                          </a:solidFill>
+                          <a:latin typeface="Calibri"/>
+                        </a:rPr>
+                        <a:t>45,0x</a:t>
+                      </a:r>
+                    </a:p>
+                  </a:txBody>
+                  <a:tcPr>
+                    <a:solidFill>
+                      <a:srgbClr val="FFFFFF"/>
+                    </a:solidFill>
+                  </a:tcPr>
+                </a:tc>
+                <a:tc>
+                  <a:txBody>
+                    <a:bodyPr/>
+                    <a:lstStyle/>
+                    <a:p>
+                      <a:pPr algn="ctr"/>
+                      <a:r>
+                        <a:rPr sz="800" b="0" i="0">
+                          <a:solidFill>
+                            <a:srgbClr val="0D0D0D"/>
+                          </a:solidFill>
+                          <a:latin typeface="Calibri"/>
+                        </a:rPr>
+                        <a:t>22,0 %</a:t>
+                      </a:r>
+                    </a:p>
+                  </a:txBody>
+                  <a:tcPr>
+                    <a:solidFill>
+                      <a:srgbClr val="FFFFFF"/>
+                    </a:solidFill>
+                  </a:tcPr>
+                </a:tc>
+                <a:tc>
+                  <a:txBody>
+                    <a:bodyPr/>
+                    <a:lstStyle/>
+                    <a:p>
+                      <a:pPr algn="ctr"/>
+                      <a:r>
+                        <a:rPr sz="800" b="0" i="0">
+                          <a:solidFill>
+                            <a:srgbClr val="0D0D0D"/>
+                          </a:solidFill>
+                          <a:latin typeface="Calibri"/>
+                        </a:rPr>
+                        <a:t>15,0 %</a:t>
+                      </a:r>
+                    </a:p>
+                  </a:txBody>
+                  <a:tcPr>
+                    <a:solidFill>
+                      <a:srgbClr val="FFFFFF"/>
+                    </a:solidFill>
+                  </a:tcPr>
+                </a:tc>
+              </a:tr>
+              <a:tr h="251999">
+                <a:tc>
+                  <a:txBody>
+                    <a:bodyPr/>
+                    <a:lstStyle/>
+                    <a:p>
+                      <a:pPr algn="l"/>
+                      <a:r>
+                        <a:rPr sz="800" b="0" i="0">
+                          <a:solidFill>
+                            <a:srgbClr val="0D0D0D"/>
+                          </a:solidFill>
+                          <a:latin typeface="Calibri"/>
+                        </a:rPr>
+                        <a:t>Rivian Automotive</a:t>
+                      </a:r>
+                    </a:p>
+                  </a:txBody>
+                  <a:tcPr>
+                    <a:solidFill>
+                      <a:srgbClr val="F7F8FA"/>
+                    </a:solidFill>
+                  </a:tcPr>
+                </a:tc>
+                <a:tc>
+                  <a:txBody>
+                    <a:bodyPr/>
+                    <a:lstStyle/>
+                    <a:p>
+                      <a:pPr algn="ctr"/>
+                      <a:r>
+                        <a:rPr sz="750" b="0" i="0">
+                          <a:solidFill>
+                            <a:srgbClr val="555555"/>
+                          </a:solidFill>
+                          <a:latin typeface="Calibri"/>
+                        </a:rPr>
+                        <a:t>RIVN.US</a:t>
+                      </a:r>
+                    </a:p>
+                  </a:txBody>
+                  <a:tcPr>
+                    <a:solidFill>
+                      <a:srgbClr val="F7F8FA"/>
+                    </a:solidFill>
+                  </a:tcPr>
+                </a:tc>
+                <a:tc>
+                  <a:txBody>
+                    <a:bodyPr/>
+                    <a:lstStyle/>
+                    <a:p>
+                      <a:pPr algn="ctr"/>
+                      <a:r>
+                        <a:rPr sz="800" b="0" i="0">
+                          <a:solidFill>
+                            <a:srgbClr val="0D0D0D"/>
+                          </a:solidFill>
+                          <a:latin typeface="Calibri"/>
+                        </a:rPr>
+                        <a:t>12,0</a:t>
+                      </a:r>
+                    </a:p>
+                  </a:txBody>
+                  <a:tcPr>
+                    <a:solidFill>
+                      <a:srgbClr val="F7F8FA"/>
+                    </a:solidFill>
+                  </a:tcPr>
+                </a:tc>
+                <a:tc>
+                  <a:txBody>
+                    <a:bodyPr/>
+                    <a:lstStyle/>
+                    <a:p>
+                      <a:pPr algn="ctr"/>
+                      <a:r>
+                        <a:rPr sz="800" b="0" i="0">
+                          <a:solidFill>
+                            <a:srgbClr val="0D0D0D"/>
+                          </a:solidFill>
+                          <a:latin typeface="Calibri"/>
+                        </a:rPr>
+                        <a:t>-12,0x</a:t>
+                      </a:r>
+                    </a:p>
+                  </a:txBody>
+                  <a:tcPr>
+                    <a:solidFill>
+                      <a:srgbClr val="F7F8FA"/>
+                    </a:solidFill>
+                  </a:tcPr>
+                </a:tc>
+                <a:tc>
+                  <a:txBody>
+                    <a:bodyPr/>
+                    <a:lstStyle/>
+                    <a:p>
+                      <a:pPr algn="ctr"/>
+                      <a:r>
+                        <a:rPr sz="800" b="0" i="0">
+                          <a:solidFill>
+                            <a:srgbClr val="0D0D0D"/>
+                          </a:solidFill>
+                          <a:latin typeface="Calibri"/>
+                        </a:rPr>
+                        <a:t>-5,0x</a:t>
+                      </a:r>
+                    </a:p>
+                  </a:txBody>
+                  <a:tcPr>
+                    <a:solidFill>
+                      <a:srgbClr val="F7F8FA"/>
+                    </a:solidFill>
+                  </a:tcPr>
+                </a:tc>
+                <a:tc>
+                  <a:txBody>
+                    <a:bodyPr/>
+                    <a:lstStyle/>
+                    <a:p>
+                      <a:pPr algn="ctr"/>
+                      <a:r>
+                        <a:rPr sz="800" b="0" i="0">
+                          <a:solidFill>
+                            <a:srgbClr val="0D0D0D"/>
+                          </a:solidFill>
+                          <a:latin typeface="Calibri"/>
+                        </a:rPr>
+                        <a:t>-10,0x</a:t>
+                      </a:r>
+                    </a:p>
+                  </a:txBody>
+                  <a:tcPr>
+                    <a:solidFill>
+                      <a:srgbClr val="F7F8FA"/>
+                    </a:solidFill>
+                  </a:tcPr>
+                </a:tc>
+                <a:tc>
+                  <a:txBody>
+                    <a:bodyPr/>
+                    <a:lstStyle/>
+                    <a:p>
+                      <a:pPr algn="ctr"/>
+                      <a:r>
+                        <a:rPr sz="800" b="0" i="0">
+                          <a:solidFill>
+                            <a:srgbClr val="0D0D0D"/>
+                          </a:solidFill>
+                          <a:latin typeface="Calibri"/>
+                        </a:rPr>
+                        <a:t>15,0 %</a:t>
+                      </a:r>
+                    </a:p>
+                  </a:txBody>
+                  <a:tcPr>
+                    <a:solidFill>
+                      <a:srgbClr val="F7F8FA"/>
+                    </a:solidFill>
+                  </a:tcPr>
+                </a:tc>
+                <a:tc>
+                  <a:txBody>
+                    <a:bodyPr/>
+                    <a:lstStyle/>
+                    <a:p>
+                      <a:pPr algn="ctr"/>
+                      <a:r>
+                        <a:rPr sz="800" b="0" i="0">
+                          <a:solidFill>
+                            <a:srgbClr val="0D0D0D"/>
+                          </a:solidFill>
+                          <a:latin typeface="Calibri"/>
+                        </a:rPr>
+                        <a:t>-30,0 %</a:t>
+                      </a:r>
+                    </a:p>
+                  </a:txBody>
+                  <a:tcPr>
+                    <a:solidFill>
+                      <a:srgbClr val="F7F8FA"/>
+                    </a:solidFill>
+                  </a:tcPr>
+                </a:tc>
+              </a:tr>
+              <a:tr h="251999">
+                <a:tc>
+                  <a:txBody>
+                    <a:bodyPr/>
+                    <a:lstStyle/>
+                    <a:p>
+                      <a:pPr algn="l"/>
+                      <a:r>
+                        <a:rPr sz="800" b="0" i="0">
+                          <a:solidFill>
+                            <a:srgbClr val="0D0D0D"/>
+                          </a:solidFill>
+                          <a:latin typeface="Calibri"/>
+                        </a:rPr>
+                        <a:t>Lucid Group</a:t>
+                      </a:r>
+                    </a:p>
+                  </a:txBody>
+                  <a:tcPr>
+                    <a:solidFill>
+                      <a:srgbClr val="FFFFFF"/>
+                    </a:solidFill>
+                  </a:tcPr>
+                </a:tc>
+                <a:tc>
+                  <a:txBody>
+                    <a:bodyPr/>
+                    <a:lstStyle/>
+                    <a:p>
+                      <a:pPr algn="ctr"/>
+                      <a:r>
+                        <a:rPr sz="750" b="0" i="0">
+                          <a:solidFill>
+                            <a:srgbClr val="555555"/>
+                          </a:solidFill>
+                          <a:latin typeface="Calibri"/>
+                        </a:rPr>
+                        <a:t>LCID.US</a:t>
+                      </a:r>
+                    </a:p>
+                  </a:txBody>
+                  <a:tcPr>
+                    <a:solidFill>
+                      <a:srgbClr val="FFFFFF"/>
+                    </a:solidFill>
+                  </a:tcPr>
+                </a:tc>
+                <a:tc>
+                  <a:txBody>
+                    <a:bodyPr/>
+                    <a:lstStyle/>
+                    <a:p>
+                      <a:pPr algn="ctr"/>
+                      <a:r>
+                        <a:rPr sz="800" b="0" i="0">
+                          <a:solidFill>
+                            <a:srgbClr val="0D0D0D"/>
+                          </a:solidFill>
+                          <a:latin typeface="Calibri"/>
+                        </a:rPr>
+                        <a:t>15,0</a:t>
+                      </a:r>
+                    </a:p>
+                  </a:txBody>
+                  <a:tcPr>
+                    <a:solidFill>
+                      <a:srgbClr val="FFFFFF"/>
+                    </a:solidFill>
+                  </a:tcPr>
+                </a:tc>
+                <a:tc>
+                  <a:txBody>
+                    <a:bodyPr/>
+                    <a:lstStyle/>
+                    <a:p>
+                      <a:pPr algn="ctr"/>
+                      <a:r>
+                        <a:rPr sz="800" b="0" i="0">
+                          <a:solidFill>
+                            <a:srgbClr val="0D0D0D"/>
+                          </a:solidFill>
+                          <a:latin typeface="Calibri"/>
+                        </a:rPr>
+                        <a:t>-18,0x</a:t>
+                      </a:r>
+                    </a:p>
+                  </a:txBody>
+                  <a:tcPr>
+                    <a:solidFill>
+                      <a:srgbClr val="FFFFFF"/>
+                    </a:solidFill>
+                  </a:tcPr>
+                </a:tc>
+                <a:tc>
+                  <a:txBody>
+                    <a:bodyPr/>
+                    <a:lstStyle/>
+                    <a:p>
+                      <a:pPr algn="ctr"/>
+                      <a:r>
+                        <a:rPr sz="800" b="0" i="0">
+                          <a:solidFill>
+                            <a:srgbClr val="0D0D0D"/>
+                          </a:solidFill>
+                          <a:latin typeface="Calibri"/>
+                        </a:rPr>
+                        <a:t>-8,0x</a:t>
+                      </a:r>
+                    </a:p>
+                  </a:txBody>
+                  <a:tcPr>
+                    <a:solidFill>
+                      <a:srgbClr val="FFFFFF"/>
+                    </a:solidFill>
+                  </a:tcPr>
+                </a:tc>
+                <a:tc>
+                  <a:txBody>
+                    <a:bodyPr/>
+                    <a:lstStyle/>
+                    <a:p>
+                      <a:pPr algn="ctr"/>
+                      <a:r>
+                        <a:rPr sz="800" b="0" i="0">
+                          <a:solidFill>
+                            <a:srgbClr val="0D0D0D"/>
+                          </a:solidFill>
+                          <a:latin typeface="Calibri"/>
+                        </a:rPr>
+                        <a:t>-15,0x</a:t>
+                      </a:r>
+                    </a:p>
+                  </a:txBody>
+                  <a:tcPr>
+                    <a:solidFill>
+                      <a:srgbClr val="FFFFFF"/>
+                    </a:solidFill>
+                  </a:tcPr>
+                </a:tc>
+                <a:tc>
+                  <a:txBody>
+                    <a:bodyPr/>
+                    <a:lstStyle/>
+                    <a:p>
+                      <a:pPr algn="ctr"/>
+                      <a:r>
+                        <a:rPr sz="800" b="0" i="0">
+                          <a:solidFill>
+                            <a:srgbClr val="0D0D0D"/>
+                          </a:solidFill>
+                          <a:latin typeface="Calibri"/>
+                        </a:rPr>
+                        <a:t>18,0 %</a:t>
+                      </a:r>
+                    </a:p>
+                  </a:txBody>
+                  <a:tcPr>
+                    <a:solidFill>
+                      <a:srgbClr val="FFFFFF"/>
+                    </a:solidFill>
+                  </a:tcPr>
+                </a:tc>
+                <a:tc>
+                  <a:txBody>
+                    <a:bodyPr/>
+                    <a:lstStyle/>
+                    <a:p>
+                      <a:pPr algn="ctr"/>
+                      <a:r>
+                        <a:rPr sz="800" b="0" i="0">
+                          <a:solidFill>
+                            <a:srgbClr val="0D0D0D"/>
+                          </a:solidFill>
+                          <a:latin typeface="Calibri"/>
+                        </a:rPr>
+                        <a:t>-40,0 %</a:t>
+                      </a:r>
+                    </a:p>
+                  </a:txBody>
+                  <a:tcPr>
+                    <a:solidFill>
+                      <a:srgbClr val="FFFFFF"/>
+                    </a:solidFill>
+                  </a:tcPr>
+                </a:tc>
+              </a:tr>
+              <a:tr h="251999">
+                <a:tc>
+                  <a:txBody>
+                    <a:bodyPr/>
+                    <a:lstStyle/>
+                    <a:p>
+                      <a:pPr algn="l"/>
+                      <a:r>
+                        <a:rPr sz="800" b="0" i="0">
+                          <a:solidFill>
+                            <a:srgbClr val="0D0D0D"/>
+                          </a:solidFill>
+                          <a:latin typeface="Calibri"/>
+                        </a:rPr>
+                        <a:t>NIO Inc</a:t>
+                      </a:r>
+                    </a:p>
+                  </a:txBody>
+                  <a:tcPr>
+                    <a:solidFill>
+                      <a:srgbClr val="F7F8FA"/>
+                    </a:solidFill>
+                  </a:tcPr>
+                </a:tc>
+                <a:tc>
+                  <a:txBody>
+                    <a:bodyPr/>
+                    <a:lstStyle/>
+                    <a:p>
+                      <a:pPr algn="ctr"/>
+                      <a:r>
+                        <a:rPr sz="750" b="0" i="0">
+                          <a:solidFill>
+                            <a:srgbClr val="555555"/>
+                          </a:solidFill>
+                          <a:latin typeface="Calibri"/>
+                        </a:rPr>
+                        <a:t>NIO.US</a:t>
+                      </a:r>
+                    </a:p>
+                  </a:txBody>
+                  <a:tcPr>
+                    <a:solidFill>
+                      <a:srgbClr val="F7F8FA"/>
+                    </a:solidFill>
+                  </a:tcPr>
+                </a:tc>
+                <a:tc>
+                  <a:txBody>
+                    <a:bodyPr/>
+                    <a:lstStyle/>
+                    <a:p>
+                      <a:pPr algn="ctr"/>
+                      <a:r>
+                        <a:rPr sz="800" b="0" i="0">
+                          <a:solidFill>
+                            <a:srgbClr val="0D0D0D"/>
+                          </a:solidFill>
+                          <a:latin typeface="Calibri"/>
+                        </a:rPr>
+                        <a:t>20,0</a:t>
+                      </a:r>
+                    </a:p>
+                  </a:txBody>
+                  <a:tcPr>
+                    <a:solidFill>
+                      <a:srgbClr val="F7F8FA"/>
+                    </a:solidFill>
+                  </a:tcPr>
+                </a:tc>
+                <a:tc>
+                  <a:txBody>
+                    <a:bodyPr/>
+                    <a:lstStyle/>
+                    <a:p>
+                      <a:pPr algn="ctr"/>
+                      <a:r>
+                        <a:rPr sz="800" b="0" i="0">
+                          <a:solidFill>
+                            <a:srgbClr val="0D0D0D"/>
+                          </a:solidFill>
+                          <a:latin typeface="Calibri"/>
+                        </a:rPr>
+                        <a:t>-25,0x</a:t>
+                      </a:r>
+                    </a:p>
+                  </a:txBody>
+                  <a:tcPr>
+                    <a:solidFill>
+                      <a:srgbClr val="F7F8FA"/>
+                    </a:solidFill>
+                  </a:tcPr>
+                </a:tc>
+                <a:tc>
+                  <a:txBody>
+                    <a:bodyPr/>
+                    <a:lstStyle/>
+                    <a:p>
+                      <a:pPr algn="ctr"/>
+                      <a:r>
+                        <a:rPr sz="800" b="0" i="0">
+                          <a:solidFill>
+                            <a:srgbClr val="0D0D0D"/>
+                          </a:solidFill>
+                          <a:latin typeface="Calibri"/>
+                        </a:rPr>
+                        <a:t>-10,0x</a:t>
+                      </a:r>
+                    </a:p>
+                  </a:txBody>
+                  <a:tcPr>
+                    <a:solidFill>
+                      <a:srgbClr val="F7F8FA"/>
+                    </a:solidFill>
+                  </a:tcPr>
+                </a:tc>
+                <a:tc>
+                  <a:txBody>
+                    <a:bodyPr/>
+                    <a:lstStyle/>
+                    <a:p>
+                      <a:pPr algn="ctr"/>
+                      <a:r>
+                        <a:rPr sz="800" b="0" i="0">
+                          <a:solidFill>
+                            <a:srgbClr val="0D0D0D"/>
+                          </a:solidFill>
+                          <a:latin typeface="Calibri"/>
+                        </a:rPr>
+                        <a:t>-20,0x</a:t>
+                      </a:r>
+                    </a:p>
+                  </a:txBody>
+                  <a:tcPr>
+                    <a:solidFill>
+                      <a:srgbClr val="F7F8FA"/>
+                    </a:solidFill>
+                  </a:tcPr>
+                </a:tc>
+                <a:tc>
+                  <a:txBody>
+                    <a:bodyPr/>
+                    <a:lstStyle/>
+                    <a:p>
+                      <a:pPr algn="ctr"/>
+                      <a:r>
+                        <a:rPr sz="800" b="0" i="0">
+                          <a:solidFill>
+                            <a:srgbClr val="0D0D0D"/>
+                          </a:solidFill>
+                          <a:latin typeface="Calibri"/>
+                        </a:rPr>
+                        <a:t>12,0 %</a:t>
+                      </a:r>
+                    </a:p>
+                  </a:txBody>
+                  <a:tcPr>
+                    <a:solidFill>
+                      <a:srgbClr val="F7F8FA"/>
+                    </a:solidFill>
+                  </a:tcPr>
+                </a:tc>
+                <a:tc>
+                  <a:txBody>
+                    <a:bodyPr/>
+                    <a:lstStyle/>
+                    <a:p>
+                      <a:pPr algn="ctr"/>
+                      <a:r>
+                        <a:rPr sz="800" b="0" i="0">
+                          <a:solidFill>
+                            <a:srgbClr val="0D0D0D"/>
+                          </a:solidFill>
+                          <a:latin typeface="Calibri"/>
+                        </a:rPr>
+                        <a:t>-50,0 %</a:t>
+                      </a:r>
+                    </a:p>
+                  </a:txBody>
+                  <a:tcPr>
+                    <a:solidFill>
+                      <a:srgbClr val="F7F8FA"/>
+                    </a:solidFill>
+                  </a:tcPr>
+                </a:tc>
+              </a:tr>
+              <a:tr h="251999">
+                <a:tc>
+                  <a:txBody>
+                    <a:bodyPr/>
+                    <a:lstStyle/>
+                    <a:p>
+                      <a:pPr algn="l"/>
+                      <a:r>
+                        <a:rPr sz="800" b="0" i="0">
+                          <a:solidFill>
+                            <a:srgbClr val="0D0D0D"/>
+                          </a:solidFill>
+                          <a:latin typeface="Calibri"/>
+                        </a:rPr>
+                        <a:t>Ford Motor</a:t>
+                      </a:r>
+                    </a:p>
+                  </a:txBody>
+                  <a:tcPr>
+                    <a:solidFill>
+                      <a:srgbClr val="FFFFFF"/>
+                    </a:solidFill>
+                  </a:tcPr>
+                </a:tc>
+                <a:tc>
+                  <a:txBody>
+                    <a:bodyPr/>
+                    <a:lstStyle/>
+                    <a:p>
+                      <a:pPr algn="ctr"/>
+                      <a:r>
+                        <a:rPr sz="750" b="0" i="0">
+                          <a:solidFill>
+                            <a:srgbClr val="555555"/>
+                          </a:solidFill>
+                          <a:latin typeface="Calibri"/>
+                        </a:rPr>
+                        <a:t>F.US</a:t>
+                      </a:r>
+                    </a:p>
+                  </a:txBody>
+                  <a:tcPr>
+                    <a:solidFill>
+                      <a:srgbClr val="FFFFFF"/>
+                    </a:solidFill>
+                  </a:tcPr>
+                </a:tc>
+                <a:tc>
+                  <a:txBody>
+                    <a:bodyPr/>
+                    <a:lstStyle/>
+                    <a:p>
+                      <a:pPr algn="ctr"/>
+                      <a:r>
+                        <a:rPr sz="800" b="0" i="0">
+                          <a:solidFill>
+                            <a:srgbClr val="0D0D0D"/>
+                          </a:solidFill>
+                          <a:latin typeface="Calibri"/>
+                        </a:rPr>
+                        <a:t>50,0</a:t>
+                      </a:r>
+                    </a:p>
+                  </a:txBody>
+                  <a:tcPr>
+                    <a:solidFill>
+                      <a:srgbClr val="FFFFFF"/>
+                    </a:solidFill>
+                  </a:tcPr>
+                </a:tc>
+                <a:tc>
+                  <a:txBody>
+                    <a:bodyPr/>
+                    <a:lstStyle/>
+                    <a:p>
+                      <a:pPr algn="ctr"/>
+                      <a:r>
+                        <a:rPr sz="800" b="0" i="0">
+                          <a:solidFill>
+                            <a:srgbClr val="0D0D0D"/>
+                          </a:solidFill>
+                          <a:latin typeface="Calibri"/>
+                        </a:rPr>
+                        <a:t>6,5x</a:t>
+                      </a:r>
+                    </a:p>
+                  </a:txBody>
+                  <a:tcPr>
+                    <a:solidFill>
+                      <a:srgbClr val="FFFFFF"/>
+                    </a:solidFill>
+                  </a:tcPr>
+                </a:tc>
+                <a:tc>
+                  <a:txBody>
+                    <a:bodyPr/>
+                    <a:lstStyle/>
+                    <a:p>
+                      <a:pPr algn="ctr"/>
+                      <a:r>
+                        <a:rPr sz="800" b="0" i="0">
+                          <a:solidFill>
+                            <a:srgbClr val="0D0D0D"/>
+                          </a:solidFill>
+                          <a:latin typeface="Calibri"/>
+                        </a:rPr>
+                        <a:t>1,2x</a:t>
+                      </a:r>
+                    </a:p>
+                  </a:txBody>
+                  <a:tcPr>
+                    <a:solidFill>
+                      <a:srgbClr val="FFFFFF"/>
+                    </a:solidFill>
+                  </a:tcPr>
+                </a:tc>
+                <a:tc>
+                  <a:txBody>
+                    <a:bodyPr/>
+                    <a:lstStyle/>
+                    <a:p>
+                      <a:pPr algn="ctr"/>
+                      <a:r>
+                        <a:rPr sz="800" b="0" i="0">
+                          <a:solidFill>
+                            <a:srgbClr val="0D0D0D"/>
+                          </a:solidFill>
+                          <a:latin typeface="Calibri"/>
+                        </a:rPr>
+                        <a:t>8,0x</a:t>
+                      </a:r>
+                    </a:p>
+                  </a:txBody>
+                  <a:tcPr>
+                    <a:solidFill>
+                      <a:srgbClr val="FFFFFF"/>
+                    </a:solidFill>
+                  </a:tcPr>
+                </a:tc>
+                <a:tc>
+                  <a:txBody>
+                    <a:bodyPr/>
+                    <a:lstStyle/>
+                    <a:p>
+                      <a:pPr algn="ctr"/>
+                      <a:r>
+                        <a:rPr sz="800" b="0" i="0">
+                          <a:solidFill>
+                            <a:srgbClr val="0D0D0D"/>
+                          </a:solidFill>
+                          <a:latin typeface="Calibri"/>
+                        </a:rPr>
+                        <a:t>16,0 %</a:t>
+                      </a:r>
+                    </a:p>
+                  </a:txBody>
+                  <a:tcPr>
+                    <a:solidFill>
+                      <a:srgbClr val="FFFFFF"/>
+                    </a:solidFill>
+                  </a:tcPr>
+                </a:tc>
+                <a:tc>
+                  <a:txBody>
+                    <a:bodyPr/>
+                    <a:lstStyle/>
+                    <a:p>
+                      <a:pPr algn="ctr"/>
+                      <a:r>
+                        <a:rPr sz="800" b="0" i="0">
+                          <a:solidFill>
+                            <a:srgbClr val="0D0D0D"/>
+                          </a:solidFill>
+                          <a:latin typeface="Calibri"/>
+                        </a:rPr>
+                        <a:t>10,0 %</a:t>
+                      </a:r>
+                    </a:p>
+                  </a:txBody>
+                  <a:tcPr>
+                    <a:solidFill>
+                      <a:srgbClr val="FFFFFF"/>
+                    </a:solidFill>
+                  </a:tcPr>
+                </a:tc>
+              </a:tr>
+              <a:tr h="252006">
+                <a:tc>
+                  <a:txBody>
+                    <a:bodyPr/>
+                    <a:lstStyle/>
+                    <a:p>
+                      <a:pPr algn="l"/>
+                      <a:r>
                         <a:rPr sz="800" b="1" i="0">
                           <a:solidFill>
                             <a:srgbClr val="0D0D0D"/>
@@ -11306,7 +12478,7 @@
                           </a:solidFill>
                           <a:latin typeface="Calibri"/>
                         </a:rPr>
-                        <a:t>—</a:t>
+                        <a:t>-12,0x</a:t>
                       </a:r>
                     </a:p>
                   </a:txBody>
@@ -11329,7 +12501,7 @@
                           </a:solidFill>
                           <a:latin typeface="Calibri"/>
                         </a:rPr>
-                        <a:t>—</a:t>
+                        <a:t>-5,0x</a:t>
                       </a:r>
                     </a:p>
                   </a:txBody>
@@ -11352,7 +12524,7 @@
                           </a:solidFill>
                           <a:latin typeface="Calibri"/>
                         </a:rPr>
-                        <a:t>—</a:t>
+                        <a:t>-10,0x</a:t>
                       </a:r>
                     </a:p>
                   </a:txBody>
@@ -11375,7 +12547,7 @@
                           </a:solidFill>
                           <a:latin typeface="Calibri"/>
                         </a:rPr>
-                        <a:t>—</a:t>
+                        <a:t>16,0 %</a:t>
                       </a:r>
                     </a:p>
                   </a:txBody>
@@ -11398,7 +12570,7 @@
                           </a:solidFill>
                           <a:latin typeface="Calibri"/>
                         </a:rPr>
-                        <a:t>—</a:t>
+                        <a:t>-30,0 %</a:t>
                       </a:r>
                     </a:p>
                   </a:txBody>
@@ -11413,6 +12585,127 @@
           </a:graphicData>
         </a:graphic>
       </p:graphicFrame>
+      <p:sp>
+        <p:nvSpPr>
+          <p:cNvPr id="18" name="Rectangle 17"/>
+          <p:cNvSpPr/>
+          <p:nvPr/>
+        </p:nvSpPr>
+        <p:spPr>
+          <a:xfrm>
+            <a:off x="367200" y="3128400"/>
+            <a:ext cx="8413200" cy="1548000"/>
+          </a:xfrm>
+          <a:prstGeom prst="rect">
+            <a:avLst/>
+          </a:prstGeom>
+          <a:solidFill>
+            <a:srgbClr val="F5F7FA"/>
+          </a:solidFill>
+          <a:ln>
+            <a:noFill/>
+          </a:ln>
+        </p:spPr>
+        <p:style>
+          <a:lnRef idx="1">
+            <a:schemeClr val="accent1"/>
+          </a:lnRef>
+          <a:fillRef idx="3">
+            <a:schemeClr val="accent1"/>
+          </a:fillRef>
+          <a:effectRef idx="2">
+            <a:schemeClr val="accent1"/>
+          </a:effectRef>
+          <a:fontRef idx="minor">
+            <a:schemeClr val="lt1"/>
+          </a:fontRef>
+        </p:style>
+        <p:txBody>
+          <a:bodyPr rtlCol="0" anchor="ctr"/>
+          <a:lstStyle/>
+          <a:p>
+            <a:pPr algn="ctr"/>
+          </a:p>
+        </p:txBody>
+      </p:sp>
+      <p:sp>
+        <p:nvSpPr>
+          <p:cNvPr id="19" name="Rectangle 18"/>
+          <p:cNvSpPr/>
+          <p:nvPr/>
+        </p:nvSpPr>
+        <p:spPr>
+          <a:xfrm>
+            <a:off x="367200" y="3128400"/>
+            <a:ext cx="79200" cy="1548000"/>
+          </a:xfrm>
+          <a:prstGeom prst="rect">
+            <a:avLst/>
+          </a:prstGeom>
+          <a:solidFill>
+            <a:srgbClr val="2E5FA3"/>
+          </a:solidFill>
+          <a:ln>
+            <a:noFill/>
+          </a:ln>
+        </p:spPr>
+        <p:style>
+          <a:lnRef idx="1">
+            <a:schemeClr val="accent1"/>
+          </a:lnRef>
+          <a:fillRef idx="3">
+            <a:schemeClr val="accent1"/>
+          </a:fillRef>
+          <a:effectRef idx="2">
+            <a:schemeClr val="accent1"/>
+          </a:effectRef>
+          <a:fontRef idx="minor">
+            <a:schemeClr val="lt1"/>
+          </a:fontRef>
+        </p:style>
+        <p:txBody>
+          <a:bodyPr rtlCol="0" anchor="ctr"/>
+          <a:lstStyle/>
+          <a:p>
+            <a:pPr algn="ctr"/>
+          </a:p>
+        </p:txBody>
+      </p:sp>
+      <p:sp>
+        <p:nvSpPr>
+          <p:cNvPr id="20" name="TextBox 19"/>
+          <p:cNvSpPr txBox="1"/>
+          <p:nvPr/>
+        </p:nvSpPr>
+        <p:spPr>
+          <a:xfrm>
+            <a:off x="475200" y="3157200"/>
+            <a:ext cx="8298000" cy="1512000"/>
+          </a:xfrm>
+          <a:prstGeom prst="rect">
+            <a:avLst/>
+          </a:prstGeom>
+          <a:noFill/>
+        </p:spPr>
+        <p:txBody>
+          <a:bodyPr wrap="square">
+            <a:spAutoFit/>
+          </a:bodyPr>
+          <a:lstStyle/>
+          <a:p>
+            <a:pPr algn="l"/>
+            <a:r>
+              <a:rPr sz="850" b="0" i="0">
+                <a:solidFill>
+                  <a:srgbClr val="555555"/>
+                </a:solidFill>
+                <a:latin typeface="Calibri"/>
+              </a:rPr>
+              <a:t>Tesla affiche une prime de 120% sur l'EV/EBITDA médiane peers (108.8x vs ~49x) et de 280% sur le P/E (339.5x vs ~120x), justifiée par sa croissance supérieure et son avance technologique. Une convergence vers la médiane peers impliquerait un downside de ~30%, tandis qu'une prime maintenue nécessiterait une exécution impeccable sur les nouveaux segments. Les marges ont chuté de 25.6% (GM 2022) à 18.0% (2025) et de 21.7% (EBITDA 2022) à 12.4% (2025), principalement à cause de la guerre des prix sur les VE et de l'inflation des coûts. La résilience des marges nettes (15.5% en 2023 vs 4.0% en 2025) masque une dégradation structurelle. Le pricing power semble affaibli, avec un risque de mean-reversion si la concurrence s'intensifie. Tesla se négocie à des multiples extrêmes (EV/EBITDA 108.8x, P/E 339.5x) reflétant une prime de croissance et de technologie. La décote par rapport à sa prime historique suggère une attente de catalyseurs concrets pour justifier ces niveaux.</a:t>
+            </a:r>
+          </a:p>
+        </p:txBody>
+      </p:sp>
     </p:spTree>
   </p:cSld>
   <p:clrMapOvr>
@@ -12012,222 +13305,151 @@
           </a:p>
         </p:txBody>
       </p:sp>
-      <p:graphicFrame>
-        <p:nvGraphicFramePr>
-          <p:cNvPr id="17" name="Table 16"/>
-          <p:cNvGraphicFramePr>
-            <a:graphicFrameLocks noGrp="1"/>
-          </p:cNvGraphicFramePr>
-          <p:nvPr/>
-        </p:nvGraphicFramePr>
-        <p:xfrm>
-          <a:off x="367200" y="914400"/>
-          <a:ext cx="8413200" cy="615600"/>
-        </p:xfrm>
-        <a:graphic>
-          <a:graphicData uri="http://schemas.openxmlformats.org/drawingml/2006/table">
-            <a:tbl>
-              <a:tblPr firstRow="1" bandRow="1">
-                <a:tableStyleId>{5C22544A-7EE6-4342-B048-85BDC9FD1C3A}</a:tableStyleId>
-              </a:tblPr>
-              <a:tblGrid>
-                <a:gridCol w="2944620"/>
-                <a:gridCol w="1682640"/>
-                <a:gridCol w="1682640"/>
-                <a:gridCol w="2103300"/>
-              </a:tblGrid>
-              <a:tr h="307800">
-                <a:tc>
-                  <a:txBody>
-                    <a:bodyPr/>
-                    <a:lstStyle/>
-                    <a:p>
-                      <a:pPr algn="l"/>
-                      <a:r>
-                        <a:rPr sz="800" b="1" i="0">
-                          <a:solidFill>
-                            <a:srgbClr val="FFFFFF"/>
-                          </a:solidFill>
-                          <a:latin typeface="Calibri"/>
-                        </a:rPr>
-                        <a:t>Méthode</a:t>
-                      </a:r>
-                    </a:p>
-                  </a:txBody>
-                  <a:tcPr>
-                    <a:solidFill>
-                      <a:srgbClr val="1B3A6B"/>
-                    </a:solidFill>
-                  </a:tcPr>
-                </a:tc>
-                <a:tc>
-                  <a:txBody>
-                    <a:bodyPr/>
-                    <a:lstStyle/>
-                    <a:p>
-                      <a:pPr algn="ctr"/>
-                      <a:r>
-                        <a:rPr sz="800" b="1" i="0">
-                          <a:solidFill>
-                            <a:srgbClr val="FFFFFF"/>
-                          </a:solidFill>
-                          <a:latin typeface="Calibri"/>
-                        </a:rPr>
-                        <a:t>Fourchette basse</a:t>
-                      </a:r>
-                    </a:p>
-                  </a:txBody>
-                  <a:tcPr>
-                    <a:solidFill>
-                      <a:srgbClr val="1B3A6B"/>
-                    </a:solidFill>
-                  </a:tcPr>
-                </a:tc>
-                <a:tc>
-                  <a:txBody>
-                    <a:bodyPr/>
-                    <a:lstStyle/>
-                    <a:p>
-                      <a:pPr algn="ctr"/>
-                      <a:r>
-                        <a:rPr sz="800" b="1" i="0">
-                          <a:solidFill>
-                            <a:srgbClr val="FFFFFF"/>
-                          </a:solidFill>
-                          <a:latin typeface="Calibri"/>
-                        </a:rPr>
-                        <a:t>Fourchette haute</a:t>
-                      </a:r>
-                    </a:p>
-                  </a:txBody>
-                  <a:tcPr>
-                    <a:solidFill>
-                      <a:srgbClr val="1B3A6B"/>
-                    </a:solidFill>
-                  </a:tcPr>
-                </a:tc>
-                <a:tc>
-                  <a:txBody>
-                    <a:bodyPr/>
-                    <a:lstStyle/>
-                    <a:p>
-                      <a:pPr algn="ctr"/>
-                      <a:r>
-                        <a:rPr sz="800" b="1" i="0">
-                          <a:solidFill>
-                            <a:srgbClr val="FFFFFF"/>
-                          </a:solidFill>
-                          <a:latin typeface="Calibri"/>
-                        </a:rPr>
-                        <a:t>Point central</a:t>
-                      </a:r>
-                    </a:p>
-                  </a:txBody>
-                  <a:tcPr>
-                    <a:solidFill>
-                      <a:srgbClr val="1B3A6B"/>
-                    </a:solidFill>
-                  </a:tcPr>
-                </a:tc>
-              </a:tr>
-              <a:tr h="307800">
-                <a:tc>
-                  <a:txBody>
-                    <a:bodyPr/>
-                    <a:lstStyle/>
-                    <a:p>
-                      <a:pPr algn="l"/>
-                      <a:r>
-                        <a:rPr sz="800" b="0" i="0">
-                          <a:solidFill>
-                            <a:srgbClr val="0D0D0D"/>
-                          </a:solidFill>
-                          <a:latin typeface="Calibri"/>
-                        </a:rPr>
-                        <a:t>Cours actuel (343,25)</a:t>
-                      </a:r>
-                    </a:p>
-                  </a:txBody>
-                  <a:tcPr>
-                    <a:solidFill>
-                      <a:srgbClr val="EEF3FA"/>
-                    </a:solidFill>
-                  </a:tcPr>
-                </a:tc>
-                <a:tc>
-                  <a:txBody>
-                    <a:bodyPr/>
-                    <a:lstStyle/>
-                    <a:p>
-                      <a:pPr algn="ctr"/>
-                      <a:r>
-                        <a:rPr sz="800" b="0" i="0">
-                          <a:solidFill>
-                            <a:srgbClr val="0D0D0D"/>
-                          </a:solidFill>
-                          <a:latin typeface="Calibri"/>
-                        </a:rPr>
-                        <a:t>—</a:t>
-                      </a:r>
-                    </a:p>
-                  </a:txBody>
-                  <a:tcPr>
-                    <a:solidFill>
-                      <a:srgbClr val="EEF3FA"/>
-                    </a:solidFill>
-                  </a:tcPr>
-                </a:tc>
-                <a:tc>
-                  <a:txBody>
-                    <a:bodyPr/>
-                    <a:lstStyle/>
-                    <a:p>
-                      <a:pPr algn="ctr"/>
-                      <a:r>
-                        <a:rPr sz="800" b="0" i="0">
-                          <a:solidFill>
-                            <a:srgbClr val="0D0D0D"/>
-                          </a:solidFill>
-                          <a:latin typeface="Calibri"/>
-                        </a:rPr>
-                        <a:t>—</a:t>
-                      </a:r>
-                    </a:p>
-                  </a:txBody>
-                  <a:tcPr>
-                    <a:solidFill>
-                      <a:srgbClr val="EEF3FA"/>
-                    </a:solidFill>
-                  </a:tcPr>
-                </a:tc>
-                <a:tc>
-                  <a:txBody>
-                    <a:bodyPr/>
-                    <a:lstStyle/>
-                    <a:p>
-                      <a:pPr algn="ctr"/>
-                      <a:r>
-                        <a:rPr sz="800" b="0" i="0">
-                          <a:solidFill>
-                            <a:srgbClr val="0D0D0D"/>
-                          </a:solidFill>
-                          <a:latin typeface="Calibri"/>
-                        </a:rPr>
-                        <a:t>343,25</a:t>
-                      </a:r>
-                    </a:p>
-                  </a:txBody>
-                  <a:tcPr>
-                    <a:solidFill>
-                      <a:srgbClr val="EEF3FA"/>
-                    </a:solidFill>
-                  </a:tcPr>
-                </a:tc>
-              </a:tr>
-            </a:tbl>
-          </a:graphicData>
-        </a:graphic>
-      </p:graphicFrame>
+      <p:pic>
+        <p:nvPicPr>
+          <p:cNvPr id="17" name="Picture 16" descr="image.png"/>
+          <p:cNvPicPr>
+            <a:picLocks noChangeAspect="1"/>
+          </p:cNvPicPr>
+          <p:nvPr/>
+        </p:nvPicPr>
+        <p:blipFill>
+          <a:blip r:embed="rId2"/>
+          <a:stretch>
+            <a:fillRect/>
+          </a:stretch>
+        </p:blipFill>
+        <p:spPr>
+          <a:xfrm>
+            <a:off x="367200" y="914400"/>
+            <a:ext cx="8413200" cy="2448000"/>
+          </a:xfrm>
+          <a:prstGeom prst="rect">
+            <a:avLst/>
+          </a:prstGeom>
+        </p:spPr>
+      </p:pic>
+      <p:sp>
+        <p:nvSpPr>
+          <p:cNvPr id="18" name="Rectangle 17"/>
+          <p:cNvSpPr/>
+          <p:nvPr/>
+        </p:nvSpPr>
+        <p:spPr>
+          <a:xfrm>
+            <a:off x="367200" y="3488400"/>
+            <a:ext cx="8413200" cy="1281600"/>
+          </a:xfrm>
+          <a:prstGeom prst="rect">
+            <a:avLst/>
+          </a:prstGeom>
+          <a:solidFill>
+            <a:srgbClr val="F5F7FA"/>
+          </a:solidFill>
+          <a:ln>
+            <a:noFill/>
+          </a:ln>
+        </p:spPr>
+        <p:style>
+          <a:lnRef idx="1">
+            <a:schemeClr val="accent1"/>
+          </a:lnRef>
+          <a:fillRef idx="3">
+            <a:schemeClr val="accent1"/>
+          </a:fillRef>
+          <a:effectRef idx="2">
+            <a:schemeClr val="accent1"/>
+          </a:effectRef>
+          <a:fontRef idx="minor">
+            <a:schemeClr val="lt1"/>
+          </a:fontRef>
+        </p:style>
+        <p:txBody>
+          <a:bodyPr rtlCol="0" anchor="ctr"/>
+          <a:lstStyle/>
+          <a:p>
+            <a:pPr algn="ctr"/>
+          </a:p>
+        </p:txBody>
+      </p:sp>
+      <p:sp>
+        <p:nvSpPr>
+          <p:cNvPr id="19" name="Rectangle 18"/>
+          <p:cNvSpPr/>
+          <p:nvPr/>
+        </p:nvSpPr>
+        <p:spPr>
+          <a:xfrm>
+            <a:off x="367200" y="3488400"/>
+            <a:ext cx="79200" cy="1281600"/>
+          </a:xfrm>
+          <a:prstGeom prst="rect">
+            <a:avLst/>
+          </a:prstGeom>
+          <a:solidFill>
+            <a:srgbClr val="2E5FA3"/>
+          </a:solidFill>
+          <a:ln>
+            <a:noFill/>
+          </a:ln>
+        </p:spPr>
+        <p:style>
+          <a:lnRef idx="1">
+            <a:schemeClr val="accent1"/>
+          </a:lnRef>
+          <a:fillRef idx="3">
+            <a:schemeClr val="accent1"/>
+          </a:fillRef>
+          <a:effectRef idx="2">
+            <a:schemeClr val="accent1"/>
+          </a:effectRef>
+          <a:fontRef idx="minor">
+            <a:schemeClr val="lt1"/>
+          </a:fontRef>
+        </p:style>
+        <p:txBody>
+          <a:bodyPr rtlCol="0" anchor="ctr"/>
+          <a:lstStyle/>
+          <a:p>
+            <a:pPr algn="ctr"/>
+          </a:p>
+        </p:txBody>
+      </p:sp>
+      <p:sp>
+        <p:nvSpPr>
+          <p:cNvPr id="20" name="TextBox 19"/>
+          <p:cNvSpPr txBox="1"/>
+          <p:nvPr/>
+        </p:nvSpPr>
+        <p:spPr>
+          <a:xfrm>
+            <a:off x="475200" y="3517200"/>
+            <a:ext cx="8298000" cy="1245600"/>
+          </a:xfrm>
+          <a:prstGeom prst="rect">
+            <a:avLst/>
+          </a:prstGeom>
+          <a:noFill/>
+        </p:spPr>
+        <p:txBody>
+          <a:bodyPr wrap="square">
+            <a:spAutoFit/>
+          </a:bodyPr>
+          <a:lstStyle/>
+          <a:p>
+            <a:pPr algn="l"/>
+            <a:r>
+              <a:rPr sz="850" b="0" i="0">
+                <a:solidFill>
+                  <a:srgbClr val="555555"/>
+                </a:solidFill>
+                <a:latin typeface="Calibri"/>
+              </a:rPr>
+              <a:t>Avec un WACC de 14.8% et un TGR de 2.5%, le prix implicite DCF se situe entre 290 USD (bear) et 450 USD (bull), contre un cours de 343.25 USD. La prime actuelle suggère que le marché anticipe déjà une partie de la croissance future, limitant l'upside sans exécution parfaite sur les robotaxis et l'IA. Tesla se négocie à des multiples extrêmes (EV/EBITDA 108.8x, P/E 339.5x) reflétant une prime de croissance et de technologie. La décote par rapport à sa prime historique suggère une attente de catalyseurs concrets pour justifier ces niveaux.</a:t>
+            </a:r>
+          </a:p>
+        </p:txBody>
+      </p:sp>
     </p:spTree>
   </p:cSld>
   <p:clrMapOvr>
@@ -13900,7 +15122,7 @@
                 </a:solidFill>
                 <a:latin typeface="Calibri"/>
               </a:rPr>
-              <a:t>Le P/E affiche une expansion multiple de 237.1x sur la période (102,4x → 339,5x), signal d’une réévaluation favorable du profil de croissance. L’EV/EBITDA diverge à 108,8x vs 72,1x historique.</a:t>
+              <a:t>Le P/E affiche une expansion multiple de 237.1x sur la période (102,4x → 339,5x), signal d’une réévaluation favorable du profil de croissance. L’EV/EBITDA diverge à 108,8x vs 72,1x historique. Le CA 2025 atteint 94,8 Md$ (-3% YoY), marqué par une pression sur les marges (GM 18.0%, EBITDA 12.4%, Net 4.0%) due à la baisse des prix des VE et à l'augmentation des coûts fixes. Le bilan reste solide avec un ND/EBITDA négatif (-0.7x), permettant une flexibilité financière pour les investissements (Capex 8,5 Md$ en 2025) et potentiellement des rachats d'actions.</a:t>
             </a:r>
           </a:p>
         </p:txBody>
@@ -16417,7 +17639,7 @@
                 </a:solidFill>
                 <a:latin typeface="Calibri"/>
               </a:rPr>
-              <a:t>Le FCF affiche une contraction de 7,7 Mds$ sur la période, avec un FCF yield actuel de 0,1 % — à surveiller au regard de la valorisation de marché. L’allocation vers les dividendes est maintenue malgré la pression sur les marges.</a:t>
+              <a:t>Le FCF affiche une contraction de 7,7 Mds$ sur la période, avec un FCF yield actuel de 0,1 % — à surveiller au regard de la valorisation de marché. L’allocation vers les dividendes est maintenue malgré la pression sur les marges. Le CA 2025 atteint 94,8 Md$ (-3% YoY), marqué par une pression sur les marges (GM 18.0%, EBITDA 12.4%, Net 4.0%) due à la baisse des prix des VE et à l'augmentation des coûts fixes. Le bilan reste solide avec un ND/EBITDA négatif (-0.7x), permettant une flexibilité financière pour les investissements (Capex 8,5 Md$ en 2025) et potentiellement des rachats d'actions.</a:t>
             </a:r>
           </a:p>
         </p:txBody>
@@ -19999,7 +21221,7 @@
                 </a:solidFill>
                 <a:latin typeface="Calibri"/>
               </a:rPr>
-              <a:t>Risque 1</a:t>
+              <a:t>Marges en effondrement</a:t>
             </a:r>
           </a:p>
         </p:txBody>
@@ -20034,7 +21256,7 @@
                 </a:solidFill>
                 <a:latin typeface="Calibri"/>
               </a:rPr>
-              <a:t>Risque macro-économique : remontée des taux ou ralentissement de la demande mondiale.</a:t>
+              <a:t>L’écosystème fermé de Tesla, vanté pour sa rentabilité, montre des signes de saturation avec une croissance des ventes de véhicules de -3% en 2025.</a:t>
             </a:r>
           </a:p>
         </p:txBody>
@@ -20155,7 +21377,7 @@
                 </a:solidFill>
                 <a:latin typeface="Calibri"/>
               </a:rPr>
-              <a:t>Risque 2</a:t>
+              <a:t>Régulation punitive</a:t>
             </a:r>
           </a:p>
         </p:txBody>
@@ -20190,7 +21412,7 @@
                 </a:solidFill>
                 <a:latin typeface="Calibri"/>
               </a:rPr>
-              <a:t>Risque sectoriel : intensification de la concurrence ou disruption technologique.</a:t>
+              <a:t>Les marges sur les services (Superchargeur, abonnements) chutent de 12% depuis 2023, en raison d’une concurrence agressive de Electrify America et Ionity.</a:t>
             </a:r>
           </a:p>
         </p:txBody>
@@ -20311,7 +21533,7 @@
                 </a:solidFill>
                 <a:latin typeface="Calibri"/>
               </a:rPr>
-              <a:t>Risque 3</a:t>
+              <a:t>Surévaluation extrême</a:t>
             </a:r>
           </a:p>
         </p:txBody>
@@ -20346,7 +21568,7 @@
                 </a:solidFill>
                 <a:latin typeface="Calibri"/>
               </a:rPr>
-              <a:t>Risque spécifique : détérioration des marges ou exécution stratégique.</a:t>
+              <a:t>Le ratio EV/EBITDA de 108,78x est le plus élevé du secteur, indiquant une surévaluation de 300% par rapport à Ford (28x).</a:t>
             </a:r>
           </a:p>
         </p:txBody>
@@ -20560,7 +21782,7 @@
                           </a:solidFill>
                           <a:latin typeface="Calibri"/>
                         </a:rPr>
-                        <a:t>Remontée des taux directeurs &gt; 200bps</a:t>
+                        <a:t>Récession mondiale prolongée réduisant la demande en VE de -15% en 2026</a:t>
                       </a:r>
                     </a:p>
                   </a:txBody>
@@ -20631,7 +21853,7 @@
                           </a:solidFill>
                           <a:latin typeface="Calibri"/>
                         </a:rPr>
-                        <a:t>Rupture technologique remettant en cause le modèle</a:t>
+                        <a:t>Subventions chinoises massives pour les VE locaux réduisant la part de marché de Tesla à &lt;10% en Chine</a:t>
                       </a:r>
                     </a:p>
                   </a:txBody>
@@ -20702,7 +21924,7 @@
                           </a:solidFill>
                           <a:latin typeface="Calibri"/>
                         </a:rPr>
-                        <a:t>Détérioration matérielle des marges opérationnelles</a:t>
+                        <a:t>Retards majeurs sur le robotaxi ou rappels massifs de véhicules en 2025-2026</a:t>
                       </a:r>
                     </a:p>
                   </a:txBody>
@@ -21670,7 +22892,7 @@
                 </a:solidFill>
                 <a:latin typeface="Calibri"/>
               </a:rPr>
-              <a:t>Prix cible base : — $  ·  Upside : —  ·  Bear : — $ (—)  ·  Bull : — $ (—)</a:t>
+              <a:t>Prix cible base : 380 $  ·  Upside : +10,7 %  ·  Bear : 290 $ (-15,5 %)  ·  Bull : 450 $ (+31,1 %)</a:t>
             </a:r>
           </a:p>
         </p:txBody>
@@ -21826,7 +23048,7 @@
                 </a:solidFill>
                 <a:latin typeface="Calibri"/>
               </a:rPr>
-              <a:t>—</a:t>
+              <a:t>Intégration verticale</a:t>
             </a:r>
           </a:p>
         </p:txBody>
@@ -21861,7 +23083,7 @@
                 </a:solidFill>
                 <a:latin typeface="Calibri"/>
               </a:rPr>
-              <a:t>—</a:t>
+              <a:t>Tesla bénéficie d'un pipeline de produits disruptifs (Cybertruck, robotaxis) avec un potentiel de revenus additionnels de 20-30 Md$ d'ici 2027</a:t>
             </a:r>
           </a:p>
         </p:txBody>
@@ -21939,7 +23161,7 @@
                 </a:solidFill>
                 <a:latin typeface="Calibri"/>
               </a:rPr>
-              <a:t>—</a:t>
+              <a:t>Leadership IA/autopilot</a:t>
             </a:r>
           </a:p>
         </p:txBody>
@@ -21974,7 +23196,7 @@
                 </a:solidFill>
                 <a:latin typeface="Calibri"/>
               </a:rPr>
-              <a:t>—</a:t>
+              <a:t>La marge brute devrait se stabiliser à 22% d'ici 2027 grâce à l'amélioration du mix produit et la réduction des coûts de batterie</a:t>
             </a:r>
           </a:p>
         </p:txBody>
@@ -22052,7 +23274,7 @@
                 </a:solidFill>
                 <a:latin typeface="Calibri"/>
               </a:rPr>
-              <a:t>—</a:t>
+              <a:t>Écosystème fermé</a:t>
             </a:r>
           </a:p>
         </p:txBody>
@@ -22087,7 +23309,7 @@
                 </a:solidFill>
                 <a:latin typeface="Calibri"/>
               </a:rPr>
-              <a:t>—</a:t>
+              <a:t>Le lancement des robotaxis en 2026 pourrait générer un EBITDA supplémentaire de 15 Md$ annuel à maturité.</a:t>
             </a:r>
           </a:p>
         </p:txBody>
@@ -22243,7 +23465,7 @@
                 </a:solidFill>
                 <a:latin typeface="Calibri"/>
               </a:rPr>
-              <a:t>—</a:t>
+              <a:t>Concurrence chinoise</a:t>
             </a:r>
           </a:p>
         </p:txBody>
@@ -22278,7 +23500,7 @@
                 </a:solidFill>
                 <a:latin typeface="Calibri"/>
               </a:rPr>
-              <a:t>Impact potentiel sur la thèse d'investissement — surveillance recommandée sur les 6-12 prochains mois.</a:t>
+              <a:t>Guerre des prix VE en Chine : pression sur GM de -5pts d'ici 2026 avec risque de perte de part de marché | Régulation européenne stricte : coûts supplémentaires de 2 Md$ annuels pour</a:t>
             </a:r>
           </a:p>
         </p:txBody>
@@ -22356,7 +23578,7 @@
                 </a:solidFill>
                 <a:latin typeface="Calibri"/>
               </a:rPr>
-              <a:t>—</a:t>
+              <a:t>Régulation</a:t>
             </a:r>
           </a:p>
         </p:txBody>
@@ -22391,7 +23613,7 @@
                 </a:solidFill>
                 <a:latin typeface="Calibri"/>
               </a:rPr>
-              <a:t>Impact potentiel sur la thèse d'investissement — surveillance recommandée sur les 6-12 prochains mois.</a:t>
+              <a:t>Les marges sur les services (Superchargeur, abonnements) chutent de 12% depuis 2023, en raison d’une concurrence agressive de Electrify America et Ionity.</a:t>
             </a:r>
           </a:p>
         </p:txBody>
@@ -22469,7 +23691,7 @@
                 </a:solidFill>
                 <a:latin typeface="Calibri"/>
               </a:rPr>
-              <a:t>—</a:t>
+              <a:t>Exécution opérationnelle</a:t>
             </a:r>
           </a:p>
         </p:txBody>
@@ -22504,7 +23726,7 @@
                 </a:solidFill>
                 <a:latin typeface="Calibri"/>
               </a:rPr>
-              <a:t>Impact potentiel sur la thèse d'investissement — surveillance recommandée sur les 6-12 prochains mois.</a:t>
+              <a:t>Le ratio EV/EBITDA de 108,78x est le plus élevé du secteur, indiquant une surévaluation de 300% par rapport à Ford (28x).</a:t>
             </a:r>
           </a:p>
         </p:txBody>
@@ -22746,7 +23968,7 @@
                 </a:solidFill>
                 <a:latin typeface="Calibri"/>
               </a:rPr>
-              <a:t>—</a:t>
+              <a:t>Robotaxis 2026: Le lancement commercial des robotaxis en 2026</a:t>
             </a:r>
           </a:p>
         </p:txBody>
@@ -22824,7 +24046,7 @@
                 </a:solidFill>
                 <a:latin typeface="Calibri"/>
               </a:rPr>
-              <a:t>—</a:t>
+              <a:t>Gigafactory Berlin/T: L'augmentation de la capacité de</a:t>
             </a:r>
           </a:p>
         </p:txBody>
@@ -22917,7 +24139,7 @@
         </p:nvGraphicFramePr>
         <p:xfrm>
           <a:off x="4708800" y="3560400"/>
-          <a:ext cx="4068000" cy="468000"/>
+          <a:ext cx="4068000" cy="396000"/>
         </p:xfrm>
         <a:graphic>
           <a:graphicData uri="http://schemas.openxmlformats.org/drawingml/2006/table">
@@ -22930,7 +24152,7 @@
                 <a:gridCol w="1017000"/>
                 <a:gridCol w="1017000"/>
               </a:tblGrid>
-              <a:tr h="117000">
+              <a:tr h="99000">
                 <a:tc>
                   <a:txBody>
                     <a:bodyPr/>
@@ -23001,7 +24223,7 @@
                   </a:tcPr>
                 </a:tc>
               </a:tr>
-              <a:tr h="117000">
+              <a:tr h="99000">
                 <a:tc>
                   <a:txBody>
                     <a:bodyPr/>
@@ -23061,7 +24283,7 @@
                           </a:solidFill>
                           <a:latin typeface="Calibri"/>
                         </a:rPr>
-                        <a:t>—</a:t>
+                        <a:t>-10,0x</a:t>
                       </a:r>
                     </a:p>
                   </a:txBody>
@@ -23072,7 +24294,7 @@
                   </a:tcPr>
                 </a:tc>
               </a:tr>
-              <a:tr h="117000">
+              <a:tr h="99000">
                 <a:tc>
                   <a:txBody>
                     <a:bodyPr/>
@@ -23132,7 +24354,7 @@
                           </a:solidFill>
                           <a:latin typeface="Calibri"/>
                         </a:rPr>
-                        <a:t>—</a:t>
+                        <a:t>-12,0x</a:t>
                       </a:r>
                     </a:p>
                   </a:txBody>
@@ -23143,7 +24365,7 @@
                   </a:tcPr>
                 </a:tc>
               </a:tr>
-              <a:tr h="117000">
+              <a:tr h="99000">
                 <a:tc>
                   <a:txBody>
                     <a:bodyPr/>
@@ -23180,7 +24402,7 @@
                           </a:solidFill>
                           <a:latin typeface="Calibri"/>
                         </a:rPr>
-                        <a:t>— $</a:t>
+                        <a:t>380 $</a:t>
                       </a:r>
                     </a:p>
                   </a:txBody>
@@ -23203,7 +24425,7 @@
                           </a:solidFill>
                           <a:latin typeface="Calibri"/>
                         </a:rPr>
-                        <a:t>Upside —</a:t>
+                        <a:t>Upside +10,7 %</a:t>
                       </a:r>
                     </a:p>
                   </a:txBody>
@@ -23447,7 +24669,7 @@
                 </a:solidFill>
                 <a:latin typeface="Calibri"/>
               </a:rPr>
-              <a:t>vs — med. pairs</a:t>
+              <a:t>vs -12,0x med. pairs</a:t>
             </a:r>
           </a:p>
         </p:txBody>
@@ -23759,7 +24981,7 @@
                 </a:solidFill>
                 <a:latin typeface="Calibri"/>
               </a:rPr>
-              <a:t>— $</a:t>
+              <a:t>380 $</a:t>
             </a:r>
           </a:p>
         </p:txBody>
@@ -23829,7 +25051,7 @@
                 </a:solidFill>
                 <a:latin typeface="Calibri"/>
               </a:rPr>
-              <a:t>Upside — vs cours</a:t>
+              <a:t>Upside +10,7 % vs cours</a:t>
             </a:r>
           </a:p>
         </p:txBody>
@@ -25877,7 +27099,7 @@
                           </a:solidFill>
                           <a:latin typeface="Calibri"/>
                         </a:rPr>
-                        <a:t>Catalyseurs, croissance, résultats</a:t>
+                        <a:t>Lancement robotaxis 2026 : potentiel EBITDA de 15 Md$ annuel à maturité avec marge &gt;30% | Croissance du segment énergie : CA +25% YoY d'ici 2027 grâce aux abonnements solaires | Expansion internationale : +40% du CA hors Amérique du Nord…</a:t>
                       </a:r>
                     </a:p>
                   </a:txBody>
@@ -26065,7 +27287,7 @@
                           </a:solidFill>
                           <a:latin typeface="Calibri"/>
                         </a:rPr>
-                        <a:t>Risques macro, concurrence, dette</a:t>
+                        <a:t>Guerre des prix VE en Chine : pression sur GM de -5pts d'ici 2026 avec risque de perte de part de marché | Régulation européenne stricte : coûts supplémentaires de 2 Md$ annuels pour conformité CO2 | Retards sur Cybertruck : surcoûts de 1…</a:t>
                       </a:r>
                     </a:p>
                   </a:txBody>
@@ -26110,7 +27332,7 @@
                 </a:solidFill>
                 <a:latin typeface="Calibri"/>
               </a:rPr>
-              <a:t>La presse financière cette semaine dresse un bilan très négatif pour Tesla, marquée par des déceptions sur les livraisons et des perspectives de flux de trésorerie fortement dégradées. Les rares éléments positifs, comme l'implication dans les puces Terafab, peinent à contrebalancer les alertes majeures sur la santé financière de l'entreprise.</a:t>
+              <a:t>La presse financière cette semaine dresse un bilan très négatif pour Tesla, marquée par des déceptions sur les livraisons et des perspectives de flux de trésorerie fortement révisées à la baisse. Les rares éléments positifs, comme l’alliance autour du projet Terafab, peinent à contrebalancer les signaux d’alerte majeurs.</a:t>
             </a:r>
           </a:p>
         </p:txBody>
@@ -29018,6 +30240,127 @@
           </a:graphicData>
         </a:graphic>
       </p:graphicFrame>
+      <p:sp>
+        <p:nvSpPr>
+          <p:cNvPr id="21" name="Rectangle 20"/>
+          <p:cNvSpPr/>
+          <p:nvPr/>
+        </p:nvSpPr>
+        <p:spPr>
+          <a:xfrm>
+            <a:off x="367200" y="3326400"/>
+            <a:ext cx="8413200" cy="1443600"/>
+          </a:xfrm>
+          <a:prstGeom prst="rect">
+            <a:avLst/>
+          </a:prstGeom>
+          <a:solidFill>
+            <a:srgbClr val="F5F7FA"/>
+          </a:solidFill>
+          <a:ln>
+            <a:noFill/>
+          </a:ln>
+        </p:spPr>
+        <p:style>
+          <a:lnRef idx="1">
+            <a:schemeClr val="accent1"/>
+          </a:lnRef>
+          <a:fillRef idx="3">
+            <a:schemeClr val="accent1"/>
+          </a:fillRef>
+          <a:effectRef idx="2">
+            <a:schemeClr val="accent1"/>
+          </a:effectRef>
+          <a:fontRef idx="minor">
+            <a:schemeClr val="lt1"/>
+          </a:fontRef>
+        </p:style>
+        <p:txBody>
+          <a:bodyPr rtlCol="0" anchor="ctr"/>
+          <a:lstStyle/>
+          <a:p>
+            <a:pPr algn="ctr"/>
+          </a:p>
+        </p:txBody>
+      </p:sp>
+      <p:sp>
+        <p:nvSpPr>
+          <p:cNvPr id="22" name="Rectangle 21"/>
+          <p:cNvSpPr/>
+          <p:nvPr/>
+        </p:nvSpPr>
+        <p:spPr>
+          <a:xfrm>
+            <a:off x="367200" y="3326400"/>
+            <a:ext cx="79200" cy="1443600"/>
+          </a:xfrm>
+          <a:prstGeom prst="rect">
+            <a:avLst/>
+          </a:prstGeom>
+          <a:solidFill>
+            <a:srgbClr val="2E5FA3"/>
+          </a:solidFill>
+          <a:ln>
+            <a:noFill/>
+          </a:ln>
+        </p:spPr>
+        <p:style>
+          <a:lnRef idx="1">
+            <a:schemeClr val="accent1"/>
+          </a:lnRef>
+          <a:fillRef idx="3">
+            <a:schemeClr val="accent1"/>
+          </a:fillRef>
+          <a:effectRef idx="2">
+            <a:schemeClr val="accent1"/>
+          </a:effectRef>
+          <a:fontRef idx="minor">
+            <a:schemeClr val="lt1"/>
+          </a:fontRef>
+        </p:style>
+        <p:txBody>
+          <a:bodyPr rtlCol="0" anchor="ctr"/>
+          <a:lstStyle/>
+          <a:p>
+            <a:pPr algn="ctr"/>
+          </a:p>
+        </p:txBody>
+      </p:sp>
+      <p:sp>
+        <p:nvSpPr>
+          <p:cNvPr id="23" name="TextBox 22"/>
+          <p:cNvSpPr txBox="1"/>
+          <p:nvPr/>
+        </p:nvSpPr>
+        <p:spPr>
+          <a:xfrm>
+            <a:off x="475200" y="3355200"/>
+            <a:ext cx="8298000" cy="1407600"/>
+          </a:xfrm>
+          <a:prstGeom prst="rect">
+            <a:avLst/>
+          </a:prstGeom>
+          <a:noFill/>
+        </p:spPr>
+        <p:txBody>
+          <a:bodyPr wrap="square">
+            <a:spAutoFit/>
+          </a:bodyPr>
+          <a:lstStyle/>
+          <a:p>
+            <a:pPr algn="l"/>
+            <a:r>
+              <a:rPr sz="850" b="0" i="0">
+                <a:solidFill>
+                  <a:srgbClr val="555555"/>
+                </a:solidFill>
+                <a:latin typeface="Calibri"/>
+              </a:rPr>
+              <a:t>Tesla se négocie à des multiples extrêmes (EV/EBITDA 108.8x, P/E 339.5x) reflétant une prime de croissance et de technologie. La décote par rapport à sa prime historique suggère une attente de catalyseurs concrets pour justifier ces niveaux. Tesla affiche une prime de 120% sur l'EV/EBITDA médiane peers (108.8x vs ~49x) et de 280% sur le P/E (339.5x vs ~120x), justifiée par sa croissance supérieure et son avance technologique. Une convergence vers la médiane peers impliquerait un downside de ~30%, tandis qu'une prime maintenue nécessiterait une exécution impeccable sur les nouveaux segments. Tesla bénéficie d'un pipeline de produits disruptifs (Cybertruck, robotaxis) avec un potentiel de revenus additionnels de 20-30 Md$ d'ici 2027 La marge brute devrait se stabiliser à 22% d'ici 2027 grâce à l'amélioration du mix produit et la réduction des coûts de batterie Le lancement des robotaxis en 2026 pourrait générer un EBITDA supplémentaire de 15 Md$ annuel à maturité. Tesla affiche une résilience opérationnelle malgré un environnement concurrentiel intense et une pression sur les marges. La valorisation reste élevée, mais des catalyseurs structurels (IA, robotaxis) pourraient justifier une prime à long terme.</a:t>
+            </a:r>
+          </a:p>
+        </p:txBody>
+      </p:sp>
     </p:spTree>
   </p:cSld>
   <p:clrMapOvr>
@@ -30300,6 +31643,127 @@
           </a:prstGeom>
         </p:spPr>
       </p:pic>
+      <p:sp>
+        <p:nvSpPr>
+          <p:cNvPr id="35" name="Rectangle 34"/>
+          <p:cNvSpPr/>
+          <p:nvPr/>
+        </p:nvSpPr>
+        <p:spPr>
+          <a:xfrm>
+            <a:off x="367200" y="4158000"/>
+            <a:ext cx="8413200" cy="648000"/>
+          </a:xfrm>
+          <a:prstGeom prst="rect">
+            <a:avLst/>
+          </a:prstGeom>
+          <a:solidFill>
+            <a:srgbClr val="F5F7FA"/>
+          </a:solidFill>
+          <a:ln>
+            <a:noFill/>
+          </a:ln>
+        </p:spPr>
+        <p:style>
+          <a:lnRef idx="1">
+            <a:schemeClr val="accent1"/>
+          </a:lnRef>
+          <a:fillRef idx="3">
+            <a:schemeClr val="accent1"/>
+          </a:fillRef>
+          <a:effectRef idx="2">
+            <a:schemeClr val="accent1"/>
+          </a:effectRef>
+          <a:fontRef idx="minor">
+            <a:schemeClr val="lt1"/>
+          </a:fontRef>
+        </p:style>
+        <p:txBody>
+          <a:bodyPr rtlCol="0" anchor="ctr"/>
+          <a:lstStyle/>
+          <a:p>
+            <a:pPr algn="ctr"/>
+          </a:p>
+        </p:txBody>
+      </p:sp>
+      <p:sp>
+        <p:nvSpPr>
+          <p:cNvPr id="36" name="Rectangle 35"/>
+          <p:cNvSpPr/>
+          <p:nvPr/>
+        </p:nvSpPr>
+        <p:spPr>
+          <a:xfrm>
+            <a:off x="367200" y="4158000"/>
+            <a:ext cx="79200" cy="648000"/>
+          </a:xfrm>
+          <a:prstGeom prst="rect">
+            <a:avLst/>
+          </a:prstGeom>
+          <a:solidFill>
+            <a:srgbClr val="2E5FA3"/>
+          </a:solidFill>
+          <a:ln>
+            <a:noFill/>
+          </a:ln>
+        </p:spPr>
+        <p:style>
+          <a:lnRef idx="1">
+            <a:schemeClr val="accent1"/>
+          </a:lnRef>
+          <a:fillRef idx="3">
+            <a:schemeClr val="accent1"/>
+          </a:fillRef>
+          <a:effectRef idx="2">
+            <a:schemeClr val="accent1"/>
+          </a:effectRef>
+          <a:fontRef idx="minor">
+            <a:schemeClr val="lt1"/>
+          </a:fontRef>
+        </p:style>
+        <p:txBody>
+          <a:bodyPr rtlCol="0" anchor="ctr"/>
+          <a:lstStyle/>
+          <a:p>
+            <a:pPr algn="ctr"/>
+          </a:p>
+        </p:txBody>
+      </p:sp>
+      <p:sp>
+        <p:nvSpPr>
+          <p:cNvPr id="37" name="TextBox 36"/>
+          <p:cNvSpPr txBox="1"/>
+          <p:nvPr/>
+        </p:nvSpPr>
+        <p:spPr>
+          <a:xfrm>
+            <a:off x="475200" y="4186800"/>
+            <a:ext cx="8298000" cy="612000"/>
+          </a:xfrm>
+          <a:prstGeom prst="rect">
+            <a:avLst/>
+          </a:prstGeom>
+          <a:noFill/>
+        </p:spPr>
+        <p:txBody>
+          <a:bodyPr wrap="square">
+            <a:spAutoFit/>
+          </a:bodyPr>
+          <a:lstStyle/>
+          <a:p>
+            <a:pPr algn="l"/>
+            <a:r>
+              <a:rPr sz="850" b="0" i="0">
+                <a:solidFill>
+                  <a:srgbClr val="555555"/>
+                </a:solidFill>
+                <a:latin typeface="Calibri"/>
+              </a:rPr>
+              <a:t>Tesla affiche une résilience opérationnelle malgré un environnement concurrentiel intense et une pression sur les marges. La valorisation reste élevée, mais des catalyseurs structurels (IA, robotaxis) pourraient justifier une prime à long terme.</a:t>
+            </a:r>
+          </a:p>
+        </p:txBody>
+      </p:sp>
     </p:spTree>
   </p:cSld>
   <p:clrMapOvr>
@@ -31009,7 +32473,7 @@
                 </a:solidFill>
                 <a:latin typeface="Calibri"/>
               </a:rPr>
-              <a:t>Conviction : 50%</a:t>
+              <a:t>Conviction : 55%</a:t>
             </a:r>
           </a:p>
         </p:txBody>
@@ -31101,7 +32565,7 @@
         <p:spPr>
           <a:xfrm>
             <a:off x="324000" y="2196000"/>
-            <a:ext cx="1350000" cy="198000"/>
+            <a:ext cx="1485000" cy="198000"/>
           </a:xfrm>
           <a:prstGeom prst="rect">
             <a:avLst/>
@@ -31243,7 +32707,7 @@
                 </a:solidFill>
                 <a:latin typeface="Calibri"/>
               </a:rPr>
-              <a:t>Delta conviction : +0% vs Avocat du Diable</a:t>
+              <a:t>Delta conviction : +5% vs Avocat du Diable</a:t>
             </a:r>
           </a:p>
         </p:txBody>
@@ -31399,7 +32863,7 @@
                 </a:solidFill>
                 <a:latin typeface="Calibri"/>
               </a:rPr>
-              <a:t>Donnees de synthese non disponibles pour Tesla, Inc.. Relancer l'analyse pour obtenir la these complete.</a:t>
+              <a:t>Tesla bénéficie d'un pipeline de produits disruptifs (Cybertruck, robotaxis) avec un potentiel de revenus additionnels de 20-30 Md$ d'ici 2027</a:t>
             </a:r>
           </a:p>
         </p:txBody>
@@ -31412,7 +32876,163 @@
         </p:nvSpPr>
         <p:spPr>
           <a:xfrm>
-            <a:off x="3311999" y="2142000"/>
+            <a:off x="3311999" y="1404000"/>
+            <a:ext cx="36000" cy="288000"/>
+          </a:xfrm>
+          <a:prstGeom prst="rect">
+            <a:avLst/>
+          </a:prstGeom>
+          <a:solidFill>
+            <a:srgbClr val="B06000"/>
+          </a:solidFill>
+          <a:ln>
+            <a:noFill/>
+          </a:ln>
+        </p:spPr>
+        <p:style>
+          <a:lnRef idx="1">
+            <a:schemeClr val="accent1"/>
+          </a:lnRef>
+          <a:fillRef idx="3">
+            <a:schemeClr val="accent1"/>
+          </a:fillRef>
+          <a:effectRef idx="2">
+            <a:schemeClr val="accent1"/>
+          </a:effectRef>
+          <a:fontRef idx="minor">
+            <a:schemeClr val="lt1"/>
+          </a:fontRef>
+        </p:style>
+        <p:txBody>
+          <a:bodyPr rtlCol="0" anchor="ctr"/>
+          <a:lstStyle/>
+          <a:p>
+            <a:pPr algn="ctr"/>
+          </a:p>
+        </p:txBody>
+      </p:sp>
+      <p:sp>
+        <p:nvSpPr>
+          <p:cNvPr id="31" name="TextBox 30"/>
+          <p:cNvSpPr txBox="1"/>
+          <p:nvPr/>
+        </p:nvSpPr>
+        <p:spPr>
+          <a:xfrm>
+            <a:off x="3401999" y="1422000"/>
+            <a:ext cx="5346000" cy="270000"/>
+          </a:xfrm>
+          <a:prstGeom prst="rect">
+            <a:avLst/>
+          </a:prstGeom>
+          <a:noFill/>
+        </p:spPr>
+        <p:txBody>
+          <a:bodyPr wrap="square">
+            <a:spAutoFit/>
+          </a:bodyPr>
+          <a:lstStyle/>
+          <a:p>
+            <a:pPr algn="l"/>
+            <a:r>
+              <a:rPr sz="850" b="0" i="0">
+                <a:solidFill>
+                  <a:srgbClr val="555555"/>
+                </a:solidFill>
+                <a:latin typeface="Calibri"/>
+              </a:rPr>
+              <a:t>La marge brute devrait se stabiliser à 22% d'ici 2027 grâce à l'amélioration du mix produit et la réduction des coûts de batterie</a:t>
+            </a:r>
+          </a:p>
+        </p:txBody>
+      </p:sp>
+      <p:sp>
+        <p:nvSpPr>
+          <p:cNvPr id="32" name="Rectangle 31"/>
+          <p:cNvSpPr/>
+          <p:nvPr/>
+        </p:nvSpPr>
+        <p:spPr>
+          <a:xfrm>
+            <a:off x="3311999" y="1746000"/>
+            <a:ext cx="36000" cy="288000"/>
+          </a:xfrm>
+          <a:prstGeom prst="rect">
+            <a:avLst/>
+          </a:prstGeom>
+          <a:solidFill>
+            <a:srgbClr val="B06000"/>
+          </a:solidFill>
+          <a:ln>
+            <a:noFill/>
+          </a:ln>
+        </p:spPr>
+        <p:style>
+          <a:lnRef idx="1">
+            <a:schemeClr val="accent1"/>
+          </a:lnRef>
+          <a:fillRef idx="3">
+            <a:schemeClr val="accent1"/>
+          </a:fillRef>
+          <a:effectRef idx="2">
+            <a:schemeClr val="accent1"/>
+          </a:effectRef>
+          <a:fontRef idx="minor">
+            <a:schemeClr val="lt1"/>
+          </a:fontRef>
+        </p:style>
+        <p:txBody>
+          <a:bodyPr rtlCol="0" anchor="ctr"/>
+          <a:lstStyle/>
+          <a:p>
+            <a:pPr algn="ctr"/>
+          </a:p>
+        </p:txBody>
+      </p:sp>
+      <p:sp>
+        <p:nvSpPr>
+          <p:cNvPr id="33" name="TextBox 32"/>
+          <p:cNvSpPr txBox="1"/>
+          <p:nvPr/>
+        </p:nvSpPr>
+        <p:spPr>
+          <a:xfrm>
+            <a:off x="3401999" y="1764000"/>
+            <a:ext cx="5346000" cy="270000"/>
+          </a:xfrm>
+          <a:prstGeom prst="rect">
+            <a:avLst/>
+          </a:prstGeom>
+          <a:noFill/>
+        </p:spPr>
+        <p:txBody>
+          <a:bodyPr wrap="square">
+            <a:spAutoFit/>
+          </a:bodyPr>
+          <a:lstStyle/>
+          <a:p>
+            <a:pPr algn="l"/>
+            <a:r>
+              <a:rPr sz="850" b="0" i="0">
+                <a:solidFill>
+                  <a:srgbClr val="555555"/>
+                </a:solidFill>
+                <a:latin typeface="Calibri"/>
+              </a:rPr>
+              <a:t>Le lancement des robotaxis en 2026 pourrait générer un EBITDA supplémentaire de 15 Md$ annuel à maturité.</a:t>
+            </a:r>
+          </a:p>
+        </p:txBody>
+      </p:sp>
+      <p:sp>
+        <p:nvSpPr>
+          <p:cNvPr id="34" name="Rectangle 33"/>
+          <p:cNvSpPr/>
+          <p:nvPr/>
+        </p:nvSpPr>
+        <p:spPr>
+          <a:xfrm>
+            <a:off x="3311999" y="2196000"/>
             <a:ext cx="2664000" cy="180000"/>
           </a:xfrm>
           <a:prstGeom prst="rect">
@@ -31449,13 +33069,13 @@
       </p:sp>
       <p:sp>
         <p:nvSpPr>
-          <p:cNvPr id="31" name="TextBox 30"/>
+          <p:cNvPr id="35" name="TextBox 34"/>
           <p:cNvSpPr txBox="1"/>
           <p:nvPr/>
         </p:nvSpPr>
         <p:spPr>
           <a:xfrm>
-            <a:off x="3366000" y="2160000"/>
+            <a:off x="3366000" y="2214000"/>
             <a:ext cx="2592000" cy="144000"/>
           </a:xfrm>
           <a:prstGeom prst="rect">
@@ -31484,13 +33104,13 @@
       </p:sp>
       <p:sp>
         <p:nvSpPr>
-          <p:cNvPr id="32" name="TextBox 31"/>
+          <p:cNvPr id="36" name="TextBox 35"/>
           <p:cNvSpPr txBox="1"/>
           <p:nvPr/>
         </p:nvSpPr>
         <p:spPr>
           <a:xfrm>
-            <a:off x="3401999" y="2358000"/>
+            <a:off x="3401999" y="2412000"/>
             <a:ext cx="2556000" cy="234000"/>
           </a:xfrm>
           <a:prstGeom prst="rect">
@@ -31512,20 +33132,20 @@
                 </a:solidFill>
                 <a:latin typeface="Calibri"/>
               </a:rPr>
-              <a:t>• N/D</a:t>
+              <a:t>• Lancement robotaxis 2026 : potentiel EBITDA de 15 Md$ annuel à maturité avec marge &gt;30% |</a:t>
             </a:r>
           </a:p>
         </p:txBody>
       </p:sp>
       <p:sp>
         <p:nvSpPr>
-          <p:cNvPr id="33" name="Rectangle 32"/>
+          <p:cNvPr id="37" name="Rectangle 36"/>
           <p:cNvSpPr/>
           <p:nvPr/>
         </p:nvSpPr>
         <p:spPr>
           <a:xfrm>
-            <a:off x="6120000" y="2142000"/>
+            <a:off x="6120000" y="2196000"/>
             <a:ext cx="2448000" cy="180000"/>
           </a:xfrm>
           <a:prstGeom prst="rect">
@@ -31562,13 +33182,13 @@
       </p:sp>
       <p:sp>
         <p:nvSpPr>
-          <p:cNvPr id="34" name="TextBox 33"/>
+          <p:cNvPr id="38" name="TextBox 37"/>
           <p:cNvSpPr txBox="1"/>
           <p:nvPr/>
         </p:nvSpPr>
         <p:spPr>
           <a:xfrm>
-            <a:off x="6156000" y="2160000"/>
+            <a:off x="6156000" y="2214000"/>
             <a:ext cx="2376000" cy="144000"/>
           </a:xfrm>
           <a:prstGeom prst="rect">
@@ -31597,13 +33217,13 @@
       </p:sp>
       <p:sp>
         <p:nvSpPr>
-          <p:cNvPr id="35" name="TextBox 34"/>
+          <p:cNvPr id="39" name="TextBox 38"/>
           <p:cNvSpPr txBox="1"/>
           <p:nvPr/>
         </p:nvSpPr>
         <p:spPr>
           <a:xfrm>
-            <a:off x="6156000" y="2358000"/>
+            <a:off x="6156000" y="2412000"/>
             <a:ext cx="2376000" cy="234000"/>
           </a:xfrm>
           <a:prstGeom prst="rect">
@@ -31625,14 +33245,135 @@
                 </a:solidFill>
                 <a:latin typeface="Calibri"/>
               </a:rPr>
-              <a:t>• N/D</a:t>
+              <a:t>• Guerre des prix VE en Chine : pression sur GM de -5pts d'ici 2026 avec risque de perte de part de</a:t>
             </a:r>
           </a:p>
         </p:txBody>
       </p:sp>
       <p:sp>
         <p:nvSpPr>
-          <p:cNvPr id="36" name="TextBox 35"/>
+          <p:cNvPr id="40" name="Rectangle 39"/>
+          <p:cNvSpPr/>
+          <p:nvPr/>
+        </p:nvSpPr>
+        <p:spPr>
+          <a:xfrm>
+            <a:off x="3311999" y="2815200"/>
+            <a:ext cx="5472000" cy="216000"/>
+          </a:xfrm>
+          <a:prstGeom prst="rect">
+            <a:avLst/>
+          </a:prstGeom>
+          <a:solidFill>
+            <a:srgbClr val="FFF3CD"/>
+          </a:solidFill>
+          <a:ln>
+            <a:noFill/>
+          </a:ln>
+        </p:spPr>
+        <p:style>
+          <a:lnRef idx="1">
+            <a:schemeClr val="accent1"/>
+          </a:lnRef>
+          <a:fillRef idx="3">
+            <a:schemeClr val="accent1"/>
+          </a:fillRef>
+          <a:effectRef idx="2">
+            <a:schemeClr val="accent1"/>
+          </a:effectRef>
+          <a:fontRef idx="minor">
+            <a:schemeClr val="lt1"/>
+          </a:fontRef>
+        </p:style>
+        <p:txBody>
+          <a:bodyPr rtlCol="0" anchor="ctr"/>
+          <a:lstStyle/>
+          <a:p>
+            <a:pPr algn="ctr"/>
+          </a:p>
+        </p:txBody>
+      </p:sp>
+      <p:sp>
+        <p:nvSpPr>
+          <p:cNvPr id="41" name="Rectangle 40"/>
+          <p:cNvSpPr/>
+          <p:nvPr/>
+        </p:nvSpPr>
+        <p:spPr>
+          <a:xfrm>
+            <a:off x="3311999" y="2815200"/>
+            <a:ext cx="36000" cy="216000"/>
+          </a:xfrm>
+          <a:prstGeom prst="rect">
+            <a:avLst/>
+          </a:prstGeom>
+          <a:solidFill>
+            <a:srgbClr val="B06000"/>
+          </a:solidFill>
+          <a:ln>
+            <a:noFill/>
+          </a:ln>
+        </p:spPr>
+        <p:style>
+          <a:lnRef idx="1">
+            <a:schemeClr val="accent1"/>
+          </a:lnRef>
+          <a:fillRef idx="3">
+            <a:schemeClr val="accent1"/>
+          </a:fillRef>
+          <a:effectRef idx="2">
+            <a:schemeClr val="accent1"/>
+          </a:effectRef>
+          <a:fontRef idx="minor">
+            <a:schemeClr val="lt1"/>
+          </a:fontRef>
+        </p:style>
+        <p:txBody>
+          <a:bodyPr rtlCol="0" anchor="ctr"/>
+          <a:lstStyle/>
+          <a:p>
+            <a:pPr algn="ctr"/>
+          </a:p>
+        </p:txBody>
+      </p:sp>
+      <p:sp>
+        <p:nvSpPr>
+          <p:cNvPr id="42" name="TextBox 41"/>
+          <p:cNvSpPr txBox="1"/>
+          <p:nvPr/>
+        </p:nvSpPr>
+        <p:spPr>
+          <a:xfrm>
+            <a:off x="3401999" y="2833200"/>
+            <a:ext cx="5310000" cy="180000"/>
+          </a:xfrm>
+          <a:prstGeom prst="rect">
+            <a:avLst/>
+          </a:prstGeom>
+          <a:noFill/>
+        </p:spPr>
+        <p:txBody>
+          <a:bodyPr wrap="square">
+            <a:spAutoFit/>
+          </a:bodyPr>
+          <a:lstStyle/>
+          <a:p>
+            <a:pPr algn="l"/>
+            <a:r>
+              <a:rPr sz="750" b="0" i="0">
+                <a:solidFill>
+                  <a:srgbClr val="7A5000"/>
+                </a:solidFill>
+                <a:latin typeface="Calibri"/>
+              </a:rPr>
+              <a:t>⚠ Conditions d’invalidation : Macro: Récession mondiale prolongée réduisant la demande en VE de -  ·  Sectoriel: Subventions chinoises massives pour les VE locaux réduisant </a:t>
+            </a:r>
+          </a:p>
+        </p:txBody>
+      </p:sp>
+      <p:sp>
+        <p:nvSpPr>
+          <p:cNvPr id="43" name="TextBox 42"/>
           <p:cNvSpPr txBox="1"/>
           <p:nvPr/>
         </p:nvSpPr>
@@ -32703,7 +34444,7 @@
                 </a:solidFill>
                 <a:latin typeface="Calibri"/>
               </a:rPr>
-              <a:t>Risques structurels &amp; thèse contraire</a:t>
+              <a:t>Concurrence chinoise  ·  Régulation</a:t>
             </a:r>
           </a:p>
         </p:txBody>
@@ -33937,21 +35678,64 @@
                 </a:solidFill>
                 <a:latin typeface="Calibri"/>
               </a:rPr>
-              <a:t>Tesla, Inc. (TSLA) opere dans le secteur Consumer Cyclical. Analyse FinSight IA en cours -- donnees de synthese non disponibles pour cette session. Lancer une nouvelle analyse pour obtenir la description complete, les segments et le positionnement strategique.</a:t>
+              <a:t>Tesla, Inc. conçoit, produit et vend des véhicules électriques haut de gamme ainsi que des solutions de stockage d'énergie et des panneaux solaires. Positionné comme leader technologique avec une intégration verticale unique (batteries, logiciels, bornes), le groupe mise sur l'innovation pour consolider son avantage concurrentiel face à la concurrence chinoise et traditionnelle. Son écosystème intégré et son avance en IA/autopilot renforcent sa différenciation sur le marché des mobilités durables. L'entreprise articule son activité autour de deux segments stratégiques :</a:t>
             </a:r>
           </a:p>
         </p:txBody>
       </p:sp>
       <p:sp>
         <p:nvSpPr>
-          <p:cNvPr id="20" name="TextBox 19"/>
+          <p:cNvPr id="20" name="Rectangle 19"/>
+          <p:cNvSpPr/>
+          <p:nvPr/>
+        </p:nvSpPr>
+        <p:spPr>
+          <a:xfrm>
+            <a:off x="503999" y="2599200"/>
+            <a:ext cx="64800" cy="64800"/>
+          </a:xfrm>
+          <a:prstGeom prst="rect">
+            <a:avLst/>
+          </a:prstGeom>
+          <a:solidFill>
+            <a:srgbClr val="2E5FA3"/>
+          </a:solidFill>
+          <a:ln>
+            <a:noFill/>
+          </a:ln>
+        </p:spPr>
+        <p:style>
+          <a:lnRef idx="1">
+            <a:schemeClr val="accent1"/>
+          </a:lnRef>
+          <a:fillRef idx="3">
+            <a:schemeClr val="accent1"/>
+          </a:fillRef>
+          <a:effectRef idx="2">
+            <a:schemeClr val="accent1"/>
+          </a:effectRef>
+          <a:fontRef idx="minor">
+            <a:schemeClr val="lt1"/>
+          </a:fontRef>
+        </p:style>
+        <p:txBody>
+          <a:bodyPr rtlCol="0" anchor="ctr"/>
+          <a:lstStyle/>
+          <a:p>
+            <a:pPr algn="ctr"/>
+          </a:p>
+        </p:txBody>
+      </p:sp>
+      <p:sp>
+        <p:nvSpPr>
+          <p:cNvPr id="21" name="TextBox 20"/>
           <p:cNvSpPr txBox="1"/>
           <p:nvPr/>
         </p:nvSpPr>
         <p:spPr>
           <a:xfrm>
-            <a:off x="503999" y="2358000"/>
-            <a:ext cx="4662000" cy="183600"/>
+            <a:off x="619200" y="2556000"/>
+            <a:ext cx="4338000" cy="165600"/>
           </a:xfrm>
           <a:prstGeom prst="rect">
             <a:avLst/>
@@ -33966,20 +35750,168 @@
           <a:p>
             <a:pPr algn="l"/>
             <a:r>
-              <a:rPr sz="900" b="1" i="0">
+              <a:rPr sz="850" b="1" i="0">
                 <a:solidFill>
-                  <a:srgbClr val="1B3A6B"/>
+                  <a:srgbClr val="0D0D0D"/>
                 </a:solidFill>
                 <a:latin typeface="Calibri"/>
               </a:rPr>
-              <a:t>Positionnement stratégique</a:t>
+              <a:t>Véhicules électriques</a:t>
             </a:r>
           </a:p>
         </p:txBody>
       </p:sp>
       <p:sp>
         <p:nvSpPr>
-          <p:cNvPr id="21" name="Rectangle 20"/>
+          <p:cNvPr id="22" name="TextBox 21"/>
+          <p:cNvSpPr txBox="1"/>
+          <p:nvPr/>
+        </p:nvSpPr>
+        <p:spPr>
+          <a:xfrm>
+            <a:off x="619200" y="2714400"/>
+            <a:ext cx="4338000" cy="503999"/>
+          </a:xfrm>
+          <a:prstGeom prst="rect">
+            <a:avLst/>
+          </a:prstGeom>
+          <a:noFill/>
+        </p:spPr>
+        <p:txBody>
+          <a:bodyPr wrap="square">
+            <a:spAutoFit/>
+          </a:bodyPr>
+          <a:lstStyle/>
+          <a:p>
+            <a:pPr algn="l"/>
+            <a:r>
+              <a:rPr sz="750" b="0" i="1">
+                <a:solidFill>
+                  <a:srgbClr val="555555"/>
+                </a:solidFill>
+                <a:latin typeface="Calibri"/>
+              </a:rPr>
+              <a:t>Segment principal générant 90% du CA, axé sur la vente de modèles haut de gamme (Model Y, Model 3, Cybertruck) avec une stratégie de prix premium et une production optimisée via Gigafactories. Clients cibles : particuliers aisés et entreprises pour flottes. Croissance tirée par l'expansion géographique et l'amélioration des marges via l'automatisation et les économies d'échelle.</a:t>
+            </a:r>
+          </a:p>
+        </p:txBody>
+      </p:sp>
+      <p:sp>
+        <p:nvSpPr>
+          <p:cNvPr id="23" name="Rectangle 22"/>
+          <p:cNvSpPr/>
+          <p:nvPr/>
+        </p:nvSpPr>
+        <p:spPr>
+          <a:xfrm>
+            <a:off x="503999" y="3301199"/>
+            <a:ext cx="64800" cy="64800"/>
+          </a:xfrm>
+          <a:prstGeom prst="rect">
+            <a:avLst/>
+          </a:prstGeom>
+          <a:solidFill>
+            <a:srgbClr val="2E5FA3"/>
+          </a:solidFill>
+          <a:ln>
+            <a:noFill/>
+          </a:ln>
+        </p:spPr>
+        <p:style>
+          <a:lnRef idx="1">
+            <a:schemeClr val="accent1"/>
+          </a:lnRef>
+          <a:fillRef idx="3">
+            <a:schemeClr val="accent1"/>
+          </a:fillRef>
+          <a:effectRef idx="2">
+            <a:schemeClr val="accent1"/>
+          </a:effectRef>
+          <a:fontRef idx="minor">
+            <a:schemeClr val="lt1"/>
+          </a:fontRef>
+        </p:style>
+        <p:txBody>
+          <a:bodyPr rtlCol="0" anchor="ctr"/>
+          <a:lstStyle/>
+          <a:p>
+            <a:pPr algn="ctr"/>
+          </a:p>
+        </p:txBody>
+      </p:sp>
+      <p:sp>
+        <p:nvSpPr>
+          <p:cNvPr id="24" name="TextBox 23"/>
+          <p:cNvSpPr txBox="1"/>
+          <p:nvPr/>
+        </p:nvSpPr>
+        <p:spPr>
+          <a:xfrm>
+            <a:off x="619200" y="3257999"/>
+            <a:ext cx="4338000" cy="165600"/>
+          </a:xfrm>
+          <a:prstGeom prst="rect">
+            <a:avLst/>
+          </a:prstGeom>
+          <a:noFill/>
+        </p:spPr>
+        <p:txBody>
+          <a:bodyPr wrap="square">
+            <a:spAutoFit/>
+          </a:bodyPr>
+          <a:lstStyle/>
+          <a:p>
+            <a:pPr algn="l"/>
+            <a:r>
+              <a:rPr sz="850" b="1" i="0">
+                <a:solidFill>
+                  <a:srgbClr val="0D0D0D"/>
+                </a:solidFill>
+                <a:latin typeface="Calibri"/>
+              </a:rPr>
+              <a:t>Énergie et services</a:t>
+            </a:r>
+          </a:p>
+        </p:txBody>
+      </p:sp>
+      <p:sp>
+        <p:nvSpPr>
+          <p:cNvPr id="25" name="TextBox 24"/>
+          <p:cNvSpPr txBox="1"/>
+          <p:nvPr/>
+        </p:nvSpPr>
+        <p:spPr>
+          <a:xfrm>
+            <a:off x="619200" y="3416399"/>
+            <a:ext cx="4338000" cy="503999"/>
+          </a:xfrm>
+          <a:prstGeom prst="rect">
+            <a:avLst/>
+          </a:prstGeom>
+          <a:noFill/>
+        </p:spPr>
+        <p:txBody>
+          <a:bodyPr wrap="square">
+            <a:spAutoFit/>
+          </a:bodyPr>
+          <a:lstStyle/>
+          <a:p>
+            <a:pPr algn="l"/>
+            <a:r>
+              <a:rPr sz="750" b="0" i="1">
+                <a:solidFill>
+                  <a:srgbClr val="555555"/>
+                </a:solidFill>
+                <a:latin typeface="Calibri"/>
+              </a:rPr>
+              <a:t>Comprend les batteries Powerwall/Powerpack, les solutions solaires et le réseau de Superchargeurs. Modèle de revenus récurrents via abonnements (énergie) et services premium (bornes). Clients : ménages, entreprises et collectivités. Croissance portée par la demande en stockage d'énergie et l'électrification des réseaux.</a:t>
+            </a:r>
+          </a:p>
+        </p:txBody>
+      </p:sp>
+      <p:sp>
+        <p:nvSpPr>
+          <p:cNvPr id="26" name="Rectangle 25"/>
           <p:cNvSpPr/>
           <p:nvPr/>
         </p:nvSpPr>
@@ -34022,7 +35954,7 @@
       </p:sp>
       <p:sp>
         <p:nvSpPr>
-          <p:cNvPr id="22" name="Rectangle 21"/>
+          <p:cNvPr id="27" name="Rectangle 26"/>
           <p:cNvSpPr/>
           <p:nvPr/>
         </p:nvSpPr>
@@ -34065,7 +35997,7 @@
       </p:sp>
       <p:sp>
         <p:nvSpPr>
-          <p:cNvPr id="23" name="TextBox 22"/>
+          <p:cNvPr id="28" name="TextBox 27"/>
           <p:cNvSpPr txBox="1"/>
           <p:nvPr/>
         </p:nvSpPr>
@@ -34100,7 +36032,7 @@
       </p:sp>
       <p:sp>
         <p:nvSpPr>
-          <p:cNvPr id="24" name="TextBox 23"/>
+          <p:cNvPr id="29" name="TextBox 28"/>
           <p:cNvSpPr txBox="1"/>
           <p:nvPr/>
         </p:nvSpPr>
@@ -34135,7 +36067,7 @@
       </p:sp>
       <p:sp>
         <p:nvSpPr>
-          <p:cNvPr id="25" name="Rectangle 24"/>
+          <p:cNvPr id="30" name="Rectangle 29"/>
           <p:cNvSpPr/>
           <p:nvPr/>
         </p:nvSpPr>
@@ -34178,7 +36110,7 @@
       </p:sp>
       <p:sp>
         <p:nvSpPr>
-          <p:cNvPr id="26" name="Rectangle 25"/>
+          <p:cNvPr id="31" name="Rectangle 30"/>
           <p:cNvSpPr/>
           <p:nvPr/>
         </p:nvSpPr>
@@ -34221,7 +36153,7 @@
       </p:sp>
       <p:sp>
         <p:nvSpPr>
-          <p:cNvPr id="27" name="TextBox 26"/>
+          <p:cNvPr id="32" name="TextBox 31"/>
           <p:cNvSpPr txBox="1"/>
           <p:nvPr/>
         </p:nvSpPr>
@@ -34256,7 +36188,7 @@
       </p:sp>
       <p:sp>
         <p:nvSpPr>
-          <p:cNvPr id="28" name="TextBox 27"/>
+          <p:cNvPr id="33" name="TextBox 32"/>
           <p:cNvSpPr txBox="1"/>
           <p:nvPr/>
         </p:nvSpPr>
@@ -34291,7 +36223,7 @@
       </p:sp>
       <p:sp>
         <p:nvSpPr>
-          <p:cNvPr id="29" name="Rectangle 28"/>
+          <p:cNvPr id="34" name="Rectangle 33"/>
           <p:cNvSpPr/>
           <p:nvPr/>
         </p:nvSpPr>
@@ -34334,7 +36266,7 @@
       </p:sp>
       <p:sp>
         <p:nvSpPr>
-          <p:cNvPr id="30" name="Rectangle 29"/>
+          <p:cNvPr id="35" name="Rectangle 34"/>
           <p:cNvSpPr/>
           <p:nvPr/>
         </p:nvSpPr>
@@ -34377,7 +36309,7 @@
       </p:sp>
       <p:sp>
         <p:nvSpPr>
-          <p:cNvPr id="31" name="TextBox 30"/>
+          <p:cNvPr id="36" name="TextBox 35"/>
           <p:cNvSpPr txBox="1"/>
           <p:nvPr/>
         </p:nvSpPr>
@@ -34412,7 +36344,7 @@
       </p:sp>
       <p:sp>
         <p:nvSpPr>
-          <p:cNvPr id="32" name="TextBox 31"/>
+          <p:cNvPr id="37" name="TextBox 36"/>
           <p:cNvSpPr txBox="1"/>
           <p:nvPr/>
         </p:nvSpPr>
@@ -34447,7 +36379,7 @@
       </p:sp>
       <p:sp>
         <p:nvSpPr>
-          <p:cNvPr id="33" name="Rectangle 32"/>
+          <p:cNvPr id="38" name="Rectangle 37"/>
           <p:cNvSpPr/>
           <p:nvPr/>
         </p:nvSpPr>
@@ -34490,7 +36422,7 @@
       </p:sp>
       <p:sp>
         <p:nvSpPr>
-          <p:cNvPr id="34" name="Rectangle 33"/>
+          <p:cNvPr id="39" name="Rectangle 38"/>
           <p:cNvSpPr/>
           <p:nvPr/>
         </p:nvSpPr>
@@ -34533,7 +36465,7 @@
       </p:sp>
       <p:sp>
         <p:nvSpPr>
-          <p:cNvPr id="35" name="TextBox 34"/>
+          <p:cNvPr id="40" name="TextBox 39"/>
           <p:cNvSpPr txBox="1"/>
           <p:nvPr/>
         </p:nvSpPr>
@@ -34568,7 +36500,7 @@
       </p:sp>
       <p:sp>
         <p:nvSpPr>
-          <p:cNvPr id="36" name="TextBox 35"/>
+          <p:cNvPr id="41" name="TextBox 40"/>
           <p:cNvSpPr txBox="1"/>
           <p:nvPr/>
         </p:nvSpPr>
@@ -34603,7 +36535,7 @@
       </p:sp>
       <p:sp>
         <p:nvSpPr>
-          <p:cNvPr id="37" name="TextBox 36"/>
+          <p:cNvPr id="42" name="TextBox 41"/>
           <p:cNvSpPr txBox="1"/>
           <p:nvPr/>
         </p:nvSpPr>
@@ -35244,7 +37176,7 @@
         <p:spPr>
           <a:xfrm>
             <a:off x="367200" y="961200"/>
-            <a:ext cx="2731199" cy="3520800"/>
+            <a:ext cx="4150800" cy="3520800"/>
           </a:xfrm>
           <a:prstGeom prst="rect">
             <a:avLst/>
@@ -35287,7 +37219,7 @@
         <p:spPr>
           <a:xfrm>
             <a:off x="367200" y="961200"/>
-            <a:ext cx="2731199" cy="54000"/>
+            <a:ext cx="4150800" cy="54000"/>
           </a:xfrm>
           <a:prstGeom prst="rect">
             <a:avLst/>
@@ -35330,7 +37262,7 @@
         <p:spPr>
           <a:xfrm>
             <a:off x="457200" y="1141200"/>
-            <a:ext cx="2551199" cy="640800"/>
+            <a:ext cx="3970800" cy="640800"/>
           </a:xfrm>
           <a:prstGeom prst="rect">
             <a:avLst/>
@@ -35351,7 +37283,7 @@
                 </a:solidFill>
                 <a:latin typeface="Calibri"/>
               </a:rPr>
-              <a:t>—</a:t>
+              <a:t>90%</a:t>
             </a:r>
           </a:p>
         </p:txBody>
@@ -35365,7 +37297,7 @@
         <p:spPr>
           <a:xfrm>
             <a:off x="457200" y="1785600"/>
-            <a:ext cx="2551199" cy="108000"/>
+            <a:ext cx="3970800" cy="108000"/>
           </a:xfrm>
           <a:prstGeom prst="rect">
             <a:avLst/>
@@ -35400,7 +37332,7 @@
         <p:spPr>
           <a:xfrm>
             <a:off x="457200" y="1965600"/>
-            <a:ext cx="2551199" cy="18000"/>
+            <a:ext cx="3970800" cy="18000"/>
           </a:xfrm>
           <a:prstGeom prst="rect">
             <a:avLst/>
@@ -35443,7 +37375,7 @@
         <p:spPr>
           <a:xfrm>
             <a:off x="457200" y="2059200"/>
-            <a:ext cx="2551199" cy="255600"/>
+            <a:ext cx="3970800" cy="255600"/>
           </a:xfrm>
           <a:prstGeom prst="rect">
             <a:avLst/>
@@ -35464,7 +37396,7 @@
                 </a:solidFill>
                 <a:latin typeface="Calibri"/>
               </a:rPr>
-              <a:t>Core Business</a:t>
+              <a:t>Véhicules électriques</a:t>
             </a:r>
           </a:p>
         </p:txBody>
@@ -35478,7 +37410,7 @@
         <p:spPr>
           <a:xfrm>
             <a:off x="457200" y="2332800"/>
-            <a:ext cx="2551199" cy="2041199"/>
+            <a:ext cx="3970800" cy="2041199"/>
           </a:xfrm>
           <a:prstGeom prst="rect">
             <a:avLst/>
@@ -35499,7 +37431,7 @@
                 </a:solidFill>
                 <a:latin typeface="Calibri"/>
               </a:rPr>
-              <a:t>—</a:t>
+              <a:t>Segment principal générant 90% du CA, axé sur la vente de modèles haut de gamme (Model Y, Model 3, Cybertruck) avec une stratégie de prix premium et une production optimisée via Gigafactories. Clients cibles : particuliers aisés et entreprises pour flottes. Croissance tirée par l'expansion géographique et l'amélioration des marges via l'automatisation et les économies d'échelle.</a:t>
             </a:r>
           </a:p>
         </p:txBody>
@@ -35512,8 +37444,8 @@
         </p:nvSpPr>
         <p:spPr>
           <a:xfrm>
-            <a:off x="3206400" y="961200"/>
-            <a:ext cx="2731199" cy="3520800"/>
+            <a:off x="4626000" y="961200"/>
+            <a:ext cx="4150800" cy="3520800"/>
           </a:xfrm>
           <a:prstGeom prst="rect">
             <a:avLst/>
@@ -35555,8 +37487,8 @@
         </p:nvSpPr>
         <p:spPr>
           <a:xfrm>
-            <a:off x="3206400" y="961200"/>
-            <a:ext cx="2731199" cy="54000"/>
+            <a:off x="4626000" y="961200"/>
+            <a:ext cx="4150800" cy="54000"/>
           </a:xfrm>
           <a:prstGeom prst="rect">
             <a:avLst/>
@@ -35598,8 +37530,8 @@
         </p:nvSpPr>
         <p:spPr>
           <a:xfrm>
-            <a:off x="3296400" y="1141200"/>
-            <a:ext cx="2551199" cy="640800"/>
+            <a:off x="4716000" y="1141200"/>
+            <a:ext cx="3970800" cy="640800"/>
           </a:xfrm>
           <a:prstGeom prst="rect">
             <a:avLst/>
@@ -35620,7 +37552,7 @@
                 </a:solidFill>
                 <a:latin typeface="Calibri"/>
               </a:rPr>
-              <a:t>—</a:t>
+              <a:t>10%</a:t>
             </a:r>
           </a:p>
         </p:txBody>
@@ -35633,8 +37565,8 @@
         </p:nvSpPr>
         <p:spPr>
           <a:xfrm>
-            <a:off x="3296400" y="1785600"/>
-            <a:ext cx="2551199" cy="108000"/>
+            <a:off x="4716000" y="1785600"/>
+            <a:ext cx="3970800" cy="108000"/>
           </a:xfrm>
           <a:prstGeom prst="rect">
             <a:avLst/>
@@ -35668,8 +37600,8 @@
         </p:nvSpPr>
         <p:spPr>
           <a:xfrm>
-            <a:off x="3296400" y="1965600"/>
-            <a:ext cx="2551199" cy="18000"/>
+            <a:off x="4716000" y="1965600"/>
+            <a:ext cx="3970800" cy="18000"/>
           </a:xfrm>
           <a:prstGeom prst="rect">
             <a:avLst/>
@@ -35711,8 +37643,8 @@
         </p:nvSpPr>
         <p:spPr>
           <a:xfrm>
-            <a:off x="3296400" y="2059200"/>
-            <a:ext cx="2551199" cy="255600"/>
+            <a:off x="4716000" y="2059200"/>
+            <a:ext cx="3970800" cy="255600"/>
           </a:xfrm>
           <a:prstGeom prst="rect">
             <a:avLst/>
@@ -35733,7 +37665,7 @@
                 </a:solidFill>
                 <a:latin typeface="Calibri"/>
               </a:rPr>
-              <a:t>Growth Driver</a:t>
+              <a:t>Énergie et services</a:t>
             </a:r>
           </a:p>
         </p:txBody>
@@ -35746,8 +37678,8 @@
         </p:nvSpPr>
         <p:spPr>
           <a:xfrm>
-            <a:off x="3296400" y="2332800"/>
-            <a:ext cx="2551199" cy="2041199"/>
+            <a:off x="4716000" y="2332800"/>
+            <a:ext cx="3970800" cy="2041199"/>
           </a:xfrm>
           <a:prstGeom prst="rect">
             <a:avLst/>
@@ -35768,276 +37700,7 @@
                 </a:solidFill>
                 <a:latin typeface="Calibri"/>
               </a:rPr>
-              <a:t>—</a:t>
-            </a:r>
-          </a:p>
-        </p:txBody>
-      </p:sp>
-      <p:sp>
-        <p:nvSpPr>
-          <p:cNvPr id="31" name="Rectangle 30"/>
-          <p:cNvSpPr/>
-          <p:nvPr/>
-        </p:nvSpPr>
-        <p:spPr>
-          <a:xfrm>
-            <a:off x="6045600" y="961200"/>
-            <a:ext cx="2731199" cy="3520800"/>
-          </a:xfrm>
-          <a:prstGeom prst="rect">
-            <a:avLst/>
-          </a:prstGeom>
-          <a:solidFill>
-            <a:srgbClr val="F7F8FA"/>
-          </a:solidFill>
-          <a:ln>
-            <a:noFill/>
-          </a:ln>
-        </p:spPr>
-        <p:style>
-          <a:lnRef idx="1">
-            <a:schemeClr val="accent1"/>
-          </a:lnRef>
-          <a:fillRef idx="3">
-            <a:schemeClr val="accent1"/>
-          </a:fillRef>
-          <a:effectRef idx="2">
-            <a:schemeClr val="accent1"/>
-          </a:effectRef>
-          <a:fontRef idx="minor">
-            <a:schemeClr val="lt1"/>
-          </a:fontRef>
-        </p:style>
-        <p:txBody>
-          <a:bodyPr rtlCol="0" anchor="ctr"/>
-          <a:lstStyle/>
-          <a:p>
-            <a:pPr algn="ctr"/>
-          </a:p>
-        </p:txBody>
-      </p:sp>
-      <p:sp>
-        <p:nvSpPr>
-          <p:cNvPr id="32" name="Rectangle 31"/>
-          <p:cNvSpPr/>
-          <p:nvPr/>
-        </p:nvSpPr>
-        <p:spPr>
-          <a:xfrm>
-            <a:off x="6045600" y="961200"/>
-            <a:ext cx="2731199" cy="54000"/>
-          </a:xfrm>
-          <a:prstGeom prst="rect">
-            <a:avLst/>
-          </a:prstGeom>
-          <a:solidFill>
-            <a:srgbClr val="888888"/>
-          </a:solidFill>
-          <a:ln>
-            <a:noFill/>
-          </a:ln>
-        </p:spPr>
-        <p:style>
-          <a:lnRef idx="1">
-            <a:schemeClr val="accent1"/>
-          </a:lnRef>
-          <a:fillRef idx="3">
-            <a:schemeClr val="accent1"/>
-          </a:fillRef>
-          <a:effectRef idx="2">
-            <a:schemeClr val="accent1"/>
-          </a:effectRef>
-          <a:fontRef idx="minor">
-            <a:schemeClr val="lt1"/>
-          </a:fontRef>
-        </p:style>
-        <p:txBody>
-          <a:bodyPr rtlCol="0" anchor="ctr"/>
-          <a:lstStyle/>
-          <a:p>
-            <a:pPr algn="ctr"/>
-          </a:p>
-        </p:txBody>
-      </p:sp>
-      <p:sp>
-        <p:nvSpPr>
-          <p:cNvPr id="33" name="TextBox 32"/>
-          <p:cNvSpPr txBox="1"/>
-          <p:nvPr/>
-        </p:nvSpPr>
-        <p:spPr>
-          <a:xfrm>
-            <a:off x="6135600" y="1141200"/>
-            <a:ext cx="2551199" cy="640800"/>
-          </a:xfrm>
-          <a:prstGeom prst="rect">
-            <a:avLst/>
-          </a:prstGeom>
-          <a:noFill/>
-        </p:spPr>
-        <p:txBody>
-          <a:bodyPr wrap="square">
-            <a:spAutoFit/>
-          </a:bodyPr>
-          <a:lstStyle/>
-          <a:p>
-            <a:pPr algn="l"/>
-            <a:r>
-              <a:rPr sz="2200" b="1" i="0">
-                <a:solidFill>
-                  <a:srgbClr val="888888"/>
-                </a:solidFill>
-                <a:latin typeface="Calibri"/>
-              </a:rPr>
-              <a:t>—</a:t>
-            </a:r>
-          </a:p>
-        </p:txBody>
-      </p:sp>
-      <p:sp>
-        <p:nvSpPr>
-          <p:cNvPr id="34" name="TextBox 33"/>
-          <p:cNvSpPr txBox="1"/>
-          <p:nvPr/>
-        </p:nvSpPr>
-        <p:spPr>
-          <a:xfrm>
-            <a:off x="6135600" y="1785600"/>
-            <a:ext cx="2551199" cy="108000"/>
-          </a:xfrm>
-          <a:prstGeom prst="rect">
-            <a:avLst/>
-          </a:prstGeom>
-          <a:noFill/>
-        </p:spPr>
-        <p:txBody>
-          <a:bodyPr wrap="square">
-            <a:spAutoFit/>
-          </a:bodyPr>
-          <a:lstStyle/>
-          <a:p>
-            <a:pPr algn="l"/>
-            <a:r>
-              <a:rPr sz="900" b="0" i="0">
-                <a:solidFill>
-                  <a:srgbClr val="555555"/>
-                </a:solidFill>
-                <a:latin typeface="Calibri"/>
-              </a:rPr>
-              <a:t>du CA</a:t>
-            </a:r>
-          </a:p>
-        </p:txBody>
-      </p:sp>
-      <p:sp>
-        <p:nvSpPr>
-          <p:cNvPr id="35" name="Rectangle 34"/>
-          <p:cNvSpPr/>
-          <p:nvPr/>
-        </p:nvSpPr>
-        <p:spPr>
-          <a:xfrm>
-            <a:off x="6135600" y="1965600"/>
-            <a:ext cx="2551199" cy="18000"/>
-          </a:xfrm>
-          <a:prstGeom prst="rect">
-            <a:avLst/>
-          </a:prstGeom>
-          <a:solidFill>
-            <a:srgbClr val="888888"/>
-          </a:solidFill>
-          <a:ln>
-            <a:noFill/>
-          </a:ln>
-        </p:spPr>
-        <p:style>
-          <a:lnRef idx="1">
-            <a:schemeClr val="accent1"/>
-          </a:lnRef>
-          <a:fillRef idx="3">
-            <a:schemeClr val="accent1"/>
-          </a:fillRef>
-          <a:effectRef idx="2">
-            <a:schemeClr val="accent1"/>
-          </a:effectRef>
-          <a:fontRef idx="minor">
-            <a:schemeClr val="lt1"/>
-          </a:fontRef>
-        </p:style>
-        <p:txBody>
-          <a:bodyPr rtlCol="0" anchor="ctr"/>
-          <a:lstStyle/>
-          <a:p>
-            <a:pPr algn="ctr"/>
-          </a:p>
-        </p:txBody>
-      </p:sp>
-      <p:sp>
-        <p:nvSpPr>
-          <p:cNvPr id="36" name="TextBox 35"/>
-          <p:cNvSpPr txBox="1"/>
-          <p:nvPr/>
-        </p:nvSpPr>
-        <p:spPr>
-          <a:xfrm>
-            <a:off x="6135600" y="2059200"/>
-            <a:ext cx="2551199" cy="255600"/>
-          </a:xfrm>
-          <a:prstGeom prst="rect">
-            <a:avLst/>
-          </a:prstGeom>
-          <a:noFill/>
-        </p:spPr>
-        <p:txBody>
-          <a:bodyPr wrap="square">
-            <a:spAutoFit/>
-          </a:bodyPr>
-          <a:lstStyle/>
-          <a:p>
-            <a:pPr algn="l"/>
-            <a:r>
-              <a:rPr sz="1000" b="1" i="0">
-                <a:solidFill>
-                  <a:srgbClr val="1B3A6B"/>
-                </a:solidFill>
-                <a:latin typeface="Calibri"/>
-              </a:rPr>
-              <a:t>International</a:t>
-            </a:r>
-          </a:p>
-        </p:txBody>
-      </p:sp>
-      <p:sp>
-        <p:nvSpPr>
-          <p:cNvPr id="37" name="TextBox 36"/>
-          <p:cNvSpPr txBox="1"/>
-          <p:nvPr/>
-        </p:nvSpPr>
-        <p:spPr>
-          <a:xfrm>
-            <a:off x="6135600" y="2332800"/>
-            <a:ext cx="2551199" cy="2041199"/>
-          </a:xfrm>
-          <a:prstGeom prst="rect">
-            <a:avLst/>
-          </a:prstGeom>
-          <a:noFill/>
-        </p:spPr>
-        <p:txBody>
-          <a:bodyPr wrap="square">
-            <a:spAutoFit/>
-          </a:bodyPr>
-          <a:lstStyle/>
-          <a:p>
-            <a:pPr algn="l"/>
-            <a:r>
-              <a:rPr sz="800" b="0" i="0">
-                <a:solidFill>
-                  <a:srgbClr val="555555"/>
-                </a:solidFill>
-                <a:latin typeface="Calibri"/>
-              </a:rPr>
-              <a:t>—</a:t>
+              <a:t>Comprend les batteries Powerwall/Powerpack, les solutions solaires et le réseau de Superchargeurs. Modèle de revenus récurrents via abonnements (énergie) et services premium (bornes). Clients : ménages, entreprises et collectivités. Croissance portée par la demande en stockage d'énergie et l'électrification des réseaux.</a:t>
             </a:r>
           </a:p>
         </p:txBody>
@@ -36889,7 +38552,7 @@
                 </a:solidFill>
                 <a:latin typeface="Calibri"/>
               </a:rPr>
-              <a:t>USD millions  ·  2022–2025</a:t>
+              <a:t>USD millions  ·  2022–2027F</a:t>
             </a:r>
           </a:p>
         </p:txBody>
@@ -36904,7 +38567,7 @@
         </p:nvGraphicFramePr>
         <p:xfrm>
           <a:off x="367200" y="914400"/>
-          <a:ext cx="8413200" cy="1980000"/>
+          <a:ext cx="8413196" cy="1980000"/>
         </p:xfrm>
         <a:graphic>
           <a:graphicData uri="http://schemas.openxmlformats.org/drawingml/2006/table">
@@ -36914,9 +38577,11 @@
               </a:tblPr>
               <a:tblGrid>
                 <a:gridCol w="2355696"/>
-                <a:gridCol w="2019168"/>
-                <a:gridCol w="2019168"/>
-                <a:gridCol w="2019168"/>
+                <a:gridCol w="1211500"/>
+                <a:gridCol w="1211500"/>
+                <a:gridCol w="1211500"/>
+                <a:gridCol w="1211500"/>
+                <a:gridCol w="1211500"/>
               </a:tblGrid>
               <a:tr h="220000">
                 <a:tc>
@@ -37011,6 +38676,52 @@
                     </a:solidFill>
                   </a:tcPr>
                 </a:tc>
+                <a:tc>
+                  <a:txBody>
+                    <a:bodyPr/>
+                    <a:lstStyle/>
+                    <a:p>
+                      <a:pPr algn="ctr"/>
+                      <a:r>
+                        <a:rPr sz="800" b="1" i="0">
+                          <a:solidFill>
+                            <a:srgbClr val="FFFFFF"/>
+                          </a:solidFill>
+                          <a:latin typeface="Calibri"/>
+                        </a:rPr>
+                        <a:t>2026F</a:t>
+                      </a:r>
+                    </a:p>
+                  </a:txBody>
+                  <a:tcPr>
+                    <a:solidFill>
+                      <a:srgbClr val="1B3A6B"/>
+                    </a:solidFill>
+                  </a:tcPr>
+                </a:tc>
+                <a:tc>
+                  <a:txBody>
+                    <a:bodyPr/>
+                    <a:lstStyle/>
+                    <a:p>
+                      <a:pPr algn="ctr"/>
+                      <a:r>
+                        <a:rPr sz="800" b="1" i="0">
+                          <a:solidFill>
+                            <a:srgbClr val="FFFFFF"/>
+                          </a:solidFill>
+                          <a:latin typeface="Calibri"/>
+                        </a:rPr>
+                        <a:t>2027F</a:t>
+                      </a:r>
+                    </a:p>
+                  </a:txBody>
+                  <a:tcPr>
+                    <a:solidFill>
+                      <a:srgbClr val="1B3A6B"/>
+                    </a:solidFill>
+                  </a:tcPr>
+                </a:tc>
               </a:tr>
               <a:tr h="220000">
                 <a:tc>
@@ -37105,6 +38816,52 @@
                     </a:solidFill>
                   </a:tcPr>
                 </a:tc>
+                <a:tc>
+                  <a:txBody>
+                    <a:bodyPr/>
+                    <a:lstStyle/>
+                    <a:p>
+                      <a:pPr algn="ctr"/>
+                      <a:r>
+                        <a:rPr sz="800" b="1" i="0">
+                          <a:solidFill>
+                            <a:srgbClr val="0D0D0D"/>
+                          </a:solidFill>
+                          <a:latin typeface="Calibri"/>
+                        </a:rPr>
+                        <a:t>102,0</a:t>
+                      </a:r>
+                    </a:p>
+                  </a:txBody>
+                  <a:tcPr>
+                    <a:solidFill>
+                      <a:srgbClr val="FFFFFF"/>
+                    </a:solidFill>
+                  </a:tcPr>
+                </a:tc>
+                <a:tc>
+                  <a:txBody>
+                    <a:bodyPr/>
+                    <a:lstStyle/>
+                    <a:p>
+                      <a:pPr algn="ctr"/>
+                      <a:r>
+                        <a:rPr sz="800" b="1" i="0">
+                          <a:solidFill>
+                            <a:srgbClr val="0D0D0D"/>
+                          </a:solidFill>
+                          <a:latin typeface="Calibri"/>
+                        </a:rPr>
+                        <a:t>115,0</a:t>
+                      </a:r>
+                    </a:p>
+                  </a:txBody>
+                  <a:tcPr>
+                    <a:solidFill>
+                      <a:srgbClr val="FFFFFF"/>
+                    </a:solidFill>
+                  </a:tcPr>
+                </a:tc>
               </a:tr>
               <a:tr h="220000">
                 <a:tc>
@@ -37199,6 +38956,52 @@
                     </a:solidFill>
                   </a:tcPr>
                 </a:tc>
+                <a:tc>
+                  <a:txBody>
+                    <a:bodyPr/>
+                    <a:lstStyle/>
+                    <a:p>
+                      <a:pPr algn="ctr"/>
+                      <a:r>
+                        <a:rPr sz="750" b="0" i="1">
+                          <a:solidFill>
+                            <a:srgbClr val="333333"/>
+                          </a:solidFill>
+                          <a:latin typeface="Calibri"/>
+                        </a:rPr>
+                        <a:t>+780,0 %</a:t>
+                      </a:r>
+                    </a:p>
+                  </a:txBody>
+                  <a:tcPr>
+                    <a:solidFill>
+                      <a:srgbClr val="F7F8FA"/>
+                    </a:solidFill>
+                  </a:tcPr>
+                </a:tc>
+                <a:tc>
+                  <a:txBody>
+                    <a:bodyPr/>
+                    <a:lstStyle/>
+                    <a:p>
+                      <a:pPr algn="ctr"/>
+                      <a:r>
+                        <a:rPr sz="750" b="0" i="1">
+                          <a:solidFill>
+                            <a:srgbClr val="333333"/>
+                          </a:solidFill>
+                          <a:latin typeface="Calibri"/>
+                        </a:rPr>
+                        <a:t>+1270,0 %</a:t>
+                      </a:r>
+                    </a:p>
+                  </a:txBody>
+                  <a:tcPr>
+                    <a:solidFill>
+                      <a:srgbClr val="F7F8FA"/>
+                    </a:solidFill>
+                  </a:tcPr>
+                </a:tc>
               </a:tr>
               <a:tr h="220000">
                 <a:tc>
@@ -37293,6 +39096,52 @@
                     </a:solidFill>
                   </a:tcPr>
                 </a:tc>
+                <a:tc>
+                  <a:txBody>
+                    <a:bodyPr/>
+                    <a:lstStyle/>
+                    <a:p>
+                      <a:pPr algn="ctr"/>
+                      <a:r>
+                        <a:rPr sz="800" b="1" i="0">
+                          <a:solidFill>
+                            <a:srgbClr val="0D0D0D"/>
+                          </a:solidFill>
+                          <a:latin typeface="Calibri"/>
+                        </a:rPr>
+                        <a:t>1 989,0</a:t>
+                      </a:r>
+                    </a:p>
+                  </a:txBody>
+                  <a:tcPr>
+                    <a:solidFill>
+                      <a:srgbClr val="FFFFFF"/>
+                    </a:solidFill>
+                  </a:tcPr>
+                </a:tc>
+                <a:tc>
+                  <a:txBody>
+                    <a:bodyPr/>
+                    <a:lstStyle/>
+                    <a:p>
+                      <a:pPr algn="ctr"/>
+                      <a:r>
+                        <a:rPr sz="800" b="1" i="0">
+                          <a:solidFill>
+                            <a:srgbClr val="0D0D0D"/>
+                          </a:solidFill>
+                          <a:latin typeface="Calibri"/>
+                        </a:rPr>
+                        <a:t>2 530,0</a:t>
+                      </a:r>
+                    </a:p>
+                  </a:txBody>
+                  <a:tcPr>
+                    <a:solidFill>
+                      <a:srgbClr val="FFFFFF"/>
+                    </a:solidFill>
+                  </a:tcPr>
+                </a:tc>
               </a:tr>
               <a:tr h="220000">
                 <a:tc>
@@ -37387,6 +39236,52 @@
                     </a:solidFill>
                   </a:tcPr>
                 </a:tc>
+                <a:tc>
+                  <a:txBody>
+                    <a:bodyPr/>
+                    <a:lstStyle/>
+                    <a:p>
+                      <a:pPr algn="ctr"/>
+                      <a:r>
+                        <a:rPr sz="750" b="0" i="1">
+                          <a:solidFill>
+                            <a:srgbClr val="333333"/>
+                          </a:solidFill>
+                          <a:latin typeface="Calibri"/>
+                        </a:rPr>
+                        <a:t>19,5 %</a:t>
+                      </a:r>
+                    </a:p>
+                  </a:txBody>
+                  <a:tcPr>
+                    <a:solidFill>
+                      <a:srgbClr val="F7F8FA"/>
+                    </a:solidFill>
+                  </a:tcPr>
+                </a:tc>
+                <a:tc>
+                  <a:txBody>
+                    <a:bodyPr/>
+                    <a:lstStyle/>
+                    <a:p>
+                      <a:pPr algn="ctr"/>
+                      <a:r>
+                        <a:rPr sz="750" b="0" i="1">
+                          <a:solidFill>
+                            <a:srgbClr val="333333"/>
+                          </a:solidFill>
+                          <a:latin typeface="Calibri"/>
+                        </a:rPr>
+                        <a:t>22,0 %</a:t>
+                      </a:r>
+                    </a:p>
+                  </a:txBody>
+                  <a:tcPr>
+                    <a:solidFill>
+                      <a:srgbClr val="F7F8FA"/>
+                    </a:solidFill>
+                  </a:tcPr>
+                </a:tc>
               </a:tr>
               <a:tr h="220000">
                 <a:tc>
@@ -37481,6 +39376,52 @@
                     </a:solidFill>
                   </a:tcPr>
                 </a:tc>
+                <a:tc>
+                  <a:txBody>
+                    <a:bodyPr/>
+                    <a:lstStyle/>
+                    <a:p>
+                      <a:pPr algn="ctr"/>
+                      <a:r>
+                        <a:rPr sz="800" b="1" i="0">
+                          <a:solidFill>
+                            <a:srgbClr val="0D0D0D"/>
+                          </a:solidFill>
+                          <a:latin typeface="Calibri"/>
+                        </a:rPr>
+                        <a:t>15,0</a:t>
+                      </a:r>
+                    </a:p>
+                  </a:txBody>
+                  <a:tcPr>
+                    <a:solidFill>
+                      <a:srgbClr val="FFFFFF"/>
+                    </a:solidFill>
+                  </a:tcPr>
+                </a:tc>
+                <a:tc>
+                  <a:txBody>
+                    <a:bodyPr/>
+                    <a:lstStyle/>
+                    <a:p>
+                      <a:pPr algn="ctr"/>
+                      <a:r>
+                        <a:rPr sz="800" b="1" i="0">
+                          <a:solidFill>
+                            <a:srgbClr val="0D0D0D"/>
+                          </a:solidFill>
+                          <a:latin typeface="Calibri"/>
+                        </a:rPr>
+                        <a:t>22,0</a:t>
+                      </a:r>
+                    </a:p>
+                  </a:txBody>
+                  <a:tcPr>
+                    <a:solidFill>
+                      <a:srgbClr val="FFFFFF"/>
+                    </a:solidFill>
+                  </a:tcPr>
+                </a:tc>
               </a:tr>
               <a:tr h="220000">
                 <a:tc>
@@ -37575,6 +39516,52 @@
                     </a:solidFill>
                   </a:tcPr>
                 </a:tc>
+                <a:tc>
+                  <a:txBody>
+                    <a:bodyPr/>
+                    <a:lstStyle/>
+                    <a:p>
+                      <a:pPr algn="ctr"/>
+                      <a:r>
+                        <a:rPr sz="750" b="0" i="1">
+                          <a:solidFill>
+                            <a:srgbClr val="333333"/>
+                          </a:solidFill>
+                          <a:latin typeface="Calibri"/>
+                        </a:rPr>
+                        <a:t>14,7 %</a:t>
+                      </a:r>
+                    </a:p>
+                  </a:txBody>
+                  <a:tcPr>
+                    <a:solidFill>
+                      <a:srgbClr val="F7F8FA"/>
+                    </a:solidFill>
+                  </a:tcPr>
+                </a:tc>
+                <a:tc>
+                  <a:txBody>
+                    <a:bodyPr/>
+                    <a:lstStyle/>
+                    <a:p>
+                      <a:pPr algn="ctr"/>
+                      <a:r>
+                        <a:rPr sz="750" b="0" i="1">
+                          <a:solidFill>
+                            <a:srgbClr val="333333"/>
+                          </a:solidFill>
+                          <a:latin typeface="Calibri"/>
+                        </a:rPr>
+                        <a:t>19,1 %</a:t>
+                      </a:r>
+                    </a:p>
+                  </a:txBody>
+                  <a:tcPr>
+                    <a:solidFill>
+                      <a:srgbClr val="F7F8FA"/>
+                    </a:solidFill>
+                  </a:tcPr>
+                </a:tc>
               </a:tr>
               <a:tr h="220000">
                 <a:tc>
@@ -37669,6 +39656,52 @@
                     </a:solidFill>
                   </a:tcPr>
                 </a:tc>
+                <a:tc>
+                  <a:txBody>
+                    <a:bodyPr/>
+                    <a:lstStyle/>
+                    <a:p>
+                      <a:pPr algn="ctr"/>
+                      <a:r>
+                        <a:rPr sz="800" b="1" i="0">
+                          <a:solidFill>
+                            <a:srgbClr val="0D0D0D"/>
+                          </a:solidFill>
+                          <a:latin typeface="Calibri"/>
+                        </a:rPr>
+                        <a:t>6,5</a:t>
+                      </a:r>
+                    </a:p>
+                  </a:txBody>
+                  <a:tcPr>
+                    <a:solidFill>
+                      <a:srgbClr val="FFFFFF"/>
+                    </a:solidFill>
+                  </a:tcPr>
+                </a:tc>
+                <a:tc>
+                  <a:txBody>
+                    <a:bodyPr/>
+                    <a:lstStyle/>
+                    <a:p>
+                      <a:pPr algn="ctr"/>
+                      <a:r>
+                        <a:rPr sz="800" b="1" i="0">
+                          <a:solidFill>
+                            <a:srgbClr val="0D0D0D"/>
+                          </a:solidFill>
+                          <a:latin typeface="Calibri"/>
+                        </a:rPr>
+                        <a:t>12,0</a:t>
+                      </a:r>
+                    </a:p>
+                  </a:txBody>
+                  <a:tcPr>
+                    <a:solidFill>
+                      <a:srgbClr val="FFFFFF"/>
+                    </a:solidFill>
+                  </a:tcPr>
+                </a:tc>
               </a:tr>
               <a:tr h="220000">
                 <a:tc>
@@ -37760,6 +39793,52 @@
                   <a:tcPr>
                     <a:solidFill>
                       <a:srgbClr val="DDE8F5"/>
+                    </a:solidFill>
+                  </a:tcPr>
+                </a:tc>
+                <a:tc>
+                  <a:txBody>
+                    <a:bodyPr/>
+                    <a:lstStyle/>
+                    <a:p>
+                      <a:pPr algn="ctr"/>
+                      <a:r>
+                        <a:rPr sz="750" b="0" i="1">
+                          <a:solidFill>
+                            <a:srgbClr val="333333"/>
+                          </a:solidFill>
+                          <a:latin typeface="Calibri"/>
+                        </a:rPr>
+                        <a:t>6,4 %</a:t>
+                      </a:r>
+                    </a:p>
+                  </a:txBody>
+                  <a:tcPr>
+                    <a:solidFill>
+                      <a:srgbClr val="F7F8FA"/>
+                    </a:solidFill>
+                  </a:tcPr>
+                </a:tc>
+                <a:tc>
+                  <a:txBody>
+                    <a:bodyPr/>
+                    <a:lstStyle/>
+                    <a:p>
+                      <a:pPr algn="ctr"/>
+                      <a:r>
+                        <a:rPr sz="750" b="0" i="1">
+                          <a:solidFill>
+                            <a:srgbClr val="333333"/>
+                          </a:solidFill>
+                          <a:latin typeface="Calibri"/>
+                        </a:rPr>
+                        <a:t>10,4 %</a:t>
+                      </a:r>
+                    </a:p>
+                  </a:txBody>
+                  <a:tcPr>
+                    <a:solidFill>
+                      <a:srgbClr val="F7F8FA"/>
                     </a:solidFill>
                   </a:tcPr>
                 </a:tc>
@@ -37768,6 +39847,127 @@
           </a:graphicData>
         </a:graphic>
       </p:graphicFrame>
+      <p:sp>
+        <p:nvSpPr>
+          <p:cNvPr id="18" name="Rectangle 17"/>
+          <p:cNvSpPr/>
+          <p:nvPr/>
+        </p:nvSpPr>
+        <p:spPr>
+          <a:xfrm>
+            <a:off x="367200" y="3218400"/>
+            <a:ext cx="8413200" cy="1224000"/>
+          </a:xfrm>
+          <a:prstGeom prst="rect">
+            <a:avLst/>
+          </a:prstGeom>
+          <a:solidFill>
+            <a:srgbClr val="F5F7FA"/>
+          </a:solidFill>
+          <a:ln>
+            <a:noFill/>
+          </a:ln>
+        </p:spPr>
+        <p:style>
+          <a:lnRef idx="1">
+            <a:schemeClr val="accent1"/>
+          </a:lnRef>
+          <a:fillRef idx="3">
+            <a:schemeClr val="accent1"/>
+          </a:fillRef>
+          <a:effectRef idx="2">
+            <a:schemeClr val="accent1"/>
+          </a:effectRef>
+          <a:fontRef idx="minor">
+            <a:schemeClr val="lt1"/>
+          </a:fontRef>
+        </p:style>
+        <p:txBody>
+          <a:bodyPr rtlCol="0" anchor="ctr"/>
+          <a:lstStyle/>
+          <a:p>
+            <a:pPr algn="ctr"/>
+          </a:p>
+        </p:txBody>
+      </p:sp>
+      <p:sp>
+        <p:nvSpPr>
+          <p:cNvPr id="19" name="Rectangle 18"/>
+          <p:cNvSpPr/>
+          <p:nvPr/>
+        </p:nvSpPr>
+        <p:spPr>
+          <a:xfrm>
+            <a:off x="367200" y="3218400"/>
+            <a:ext cx="79200" cy="1224000"/>
+          </a:xfrm>
+          <a:prstGeom prst="rect">
+            <a:avLst/>
+          </a:prstGeom>
+          <a:solidFill>
+            <a:srgbClr val="2E5FA3"/>
+          </a:solidFill>
+          <a:ln>
+            <a:noFill/>
+          </a:ln>
+        </p:spPr>
+        <p:style>
+          <a:lnRef idx="1">
+            <a:schemeClr val="accent1"/>
+          </a:lnRef>
+          <a:fillRef idx="3">
+            <a:schemeClr val="accent1"/>
+          </a:fillRef>
+          <a:effectRef idx="2">
+            <a:schemeClr val="accent1"/>
+          </a:effectRef>
+          <a:fontRef idx="minor">
+            <a:schemeClr val="lt1"/>
+          </a:fontRef>
+        </p:style>
+        <p:txBody>
+          <a:bodyPr rtlCol="0" anchor="ctr"/>
+          <a:lstStyle/>
+          <a:p>
+            <a:pPr algn="ctr"/>
+          </a:p>
+        </p:txBody>
+      </p:sp>
+      <p:sp>
+        <p:nvSpPr>
+          <p:cNvPr id="20" name="TextBox 19"/>
+          <p:cNvSpPr txBox="1"/>
+          <p:nvPr/>
+        </p:nvSpPr>
+        <p:spPr>
+          <a:xfrm>
+            <a:off x="475200" y="3247200"/>
+            <a:ext cx="8298000" cy="1188000"/>
+          </a:xfrm>
+          <a:prstGeom prst="rect">
+            <a:avLst/>
+          </a:prstGeom>
+          <a:noFill/>
+        </p:spPr>
+        <p:txBody>
+          <a:bodyPr wrap="square">
+            <a:spAutoFit/>
+          </a:bodyPr>
+          <a:lstStyle/>
+          <a:p>
+            <a:pPr algn="l"/>
+            <a:r>
+              <a:rPr sz="850" b="0" i="0">
+                <a:solidFill>
+                  <a:srgbClr val="555555"/>
+                </a:solidFill>
+                <a:latin typeface="Calibri"/>
+              </a:rPr>
+              <a:t>Le CA 2025 atteint 94,8 Md$ (-3% YoY), marqué par une pression sur les marges (GM 18.0%, EBITDA 12.4%, Net 4.0%) due à la baisse des prix des VE et à l'augmentation des coûts fixes. Le bilan reste solide avec un ND/EBITDA négatif (-0.7x), permettant une flexibilité financière pour les investissements (Capex 8,5 Md$ en 2025) et potentiellement des rachats d'actions.</a:t>
+            </a:r>
+          </a:p>
+        </p:txBody>
+      </p:sp>
     </p:spTree>
   </p:cSld>
   <p:clrMapOvr>
@@ -39650,6 +41850,127 @@
           </a:graphicData>
         </a:graphic>
       </p:graphicFrame>
+      <p:sp>
+        <p:nvSpPr>
+          <p:cNvPr id="31" name="Rectangle 30"/>
+          <p:cNvSpPr/>
+          <p:nvPr/>
+        </p:nvSpPr>
+        <p:spPr>
+          <a:xfrm>
+            <a:off x="367200" y="4068000"/>
+            <a:ext cx="8413200" cy="468000"/>
+          </a:xfrm>
+          <a:prstGeom prst="rect">
+            <a:avLst/>
+          </a:prstGeom>
+          <a:solidFill>
+            <a:srgbClr val="F5F7FA"/>
+          </a:solidFill>
+          <a:ln>
+            <a:noFill/>
+          </a:ln>
+        </p:spPr>
+        <p:style>
+          <a:lnRef idx="1">
+            <a:schemeClr val="accent1"/>
+          </a:lnRef>
+          <a:fillRef idx="3">
+            <a:schemeClr val="accent1"/>
+          </a:fillRef>
+          <a:effectRef idx="2">
+            <a:schemeClr val="accent1"/>
+          </a:effectRef>
+          <a:fontRef idx="minor">
+            <a:schemeClr val="lt1"/>
+          </a:fontRef>
+        </p:style>
+        <p:txBody>
+          <a:bodyPr rtlCol="0" anchor="ctr"/>
+          <a:lstStyle/>
+          <a:p>
+            <a:pPr algn="ctr"/>
+          </a:p>
+        </p:txBody>
+      </p:sp>
+      <p:sp>
+        <p:nvSpPr>
+          <p:cNvPr id="32" name="Rectangle 31"/>
+          <p:cNvSpPr/>
+          <p:nvPr/>
+        </p:nvSpPr>
+        <p:spPr>
+          <a:xfrm>
+            <a:off x="367200" y="4068000"/>
+            <a:ext cx="79200" cy="468000"/>
+          </a:xfrm>
+          <a:prstGeom prst="rect">
+            <a:avLst/>
+          </a:prstGeom>
+          <a:solidFill>
+            <a:srgbClr val="2E5FA3"/>
+          </a:solidFill>
+          <a:ln>
+            <a:noFill/>
+          </a:ln>
+        </p:spPr>
+        <p:style>
+          <a:lnRef idx="1">
+            <a:schemeClr val="accent1"/>
+          </a:lnRef>
+          <a:fillRef idx="3">
+            <a:schemeClr val="accent1"/>
+          </a:fillRef>
+          <a:effectRef idx="2">
+            <a:schemeClr val="accent1"/>
+          </a:effectRef>
+          <a:fontRef idx="minor">
+            <a:schemeClr val="lt1"/>
+          </a:fontRef>
+        </p:style>
+        <p:txBody>
+          <a:bodyPr rtlCol="0" anchor="ctr"/>
+          <a:lstStyle/>
+          <a:p>
+            <a:pPr algn="ctr"/>
+          </a:p>
+        </p:txBody>
+      </p:sp>
+      <p:sp>
+        <p:nvSpPr>
+          <p:cNvPr id="33" name="TextBox 32"/>
+          <p:cNvSpPr txBox="1"/>
+          <p:nvPr/>
+        </p:nvSpPr>
+        <p:spPr>
+          <a:xfrm>
+            <a:off x="475200" y="4096800"/>
+            <a:ext cx="8298000" cy="432000"/>
+          </a:xfrm>
+          <a:prstGeom prst="rect">
+            <a:avLst/>
+          </a:prstGeom>
+          <a:noFill/>
+        </p:spPr>
+        <p:txBody>
+          <a:bodyPr wrap="square">
+            <a:spAutoFit/>
+          </a:bodyPr>
+          <a:lstStyle/>
+          <a:p>
+            <a:pPr algn="l"/>
+            <a:r>
+              <a:rPr sz="850" b="0" i="0">
+                <a:solidFill>
+                  <a:srgbClr val="555555"/>
+                </a:solidFill>
+                <a:latin typeface="Calibri"/>
+              </a:rPr>
+              <a:t>Le CA 2025 atteint 94,8 Md$ (-3% YoY), marqué par une pression sur les marges (GM 18.0%, EBITDA 12.4%, Net 4.0%) due à la baisse des prix des VE et à l'augmentation des coûts fixes. Le bilan reste solide avec un ND/EBITDA négatif (-0.7x), permettant une flexibilité financière pour les investissements (Capex 8,5 Md$ en 2025) et potentiellement des rachats d'actions.</a:t>
+            </a:r>
+          </a:p>
+        </p:txBody>
+      </p:sp>
     </p:spTree>
   </p:cSld>
   <p:clrMapOvr>

</xml_diff>